<commit_message>
fix(mail): send a public reply's files to the customer as attachments
The reply mail carried only the text. Its images and documents are now
attached (read inside the workspace, since media disks are rooted per
tenant), up to MAIL_ATTACHMENTS_MAX_BYTES in total (default 7 MiB,
under the 10 MB limit of SES and Brevo); files that do not fit or are
gone are named in the mail, which is always sent.
</commit_message>
<xml_diff>
--- a/college/report/Project-III-Presentation-Smart-Helpdesk.pptx
+++ b/college/report/Project-III-Presentation-Smart-Helpdesk.pptx
@@ -2636,7 +2636,7 @@
                 <a:ea typeface="Georgia" pitchFamily="34" charset="-122"/>
                 <a:cs typeface="Georgia" pitchFamily="34" charset="-120"/>
               </a:rPr>
-              <a:t>Priority Scoring and Agent Assignment</a:t>
+              <a:t>Algorithms (1/2)</a:t>
             </a:r>
             <a:endParaRPr lang="en-US" sz="2800" dirty="0"/>
           </a:p>
@@ -2801,1126 +2801,9 @@
                 <a:ea typeface="Georgia" pitchFamily="34" charset="-122"/>
                 <a:cs typeface="Georgia" pitchFamily="34" charset="-120"/>
               </a:rPr>
-              <a:t>Weighted priority score</a:t>
+              <a:t>Priority scoring</a:t>
             </a:r>
             <a:endParaRPr lang="en-US" sz="1800" dirty="0"/>
-          </a:p>
-        </p:txBody>
-      </p:sp>
-      <p:graphicFrame>
-        <p:nvGraphicFramePr>
-          <p:cNvPr id="11" name="Table 0"/>
-          <p:cNvGraphicFramePr>
-            <a:graphicFrameLocks noGrp="1"/>
-          </p:cNvGraphicFramePr>
-          <p:nvPr>
-            <p:extLst>
-              <p:ext uri="{D42A27DB-BD31-4B8C-83A1-F6EECF244321}">
-                <p14:modId xmlns:p14="http://schemas.microsoft.com/office/powerpoint/2010/main" val="1579011935"/>
-              </p:ext>
-            </p:extLst>
-          </p:nvPr>
-        </p:nvGraphicFramePr>
-        <p:xfrm>
-          <a:off x="548640" y="1783080"/>
-          <a:ext cx="5394960" cy="914400"/>
-        </p:xfrm>
-        <a:graphic>
-          <a:graphicData uri="http://schemas.openxmlformats.org/drawingml/2006/table">
-            <a:tbl>
-              <a:tblPr/>
-              <a:tblGrid>
-                <a:gridCol w="1463040"/>
-                <a:gridCol w="3108960"/>
-                <a:gridCol w="822960"/>
-              </a:tblGrid>
-              <a:tr h="329184">
-                <a:tc>
-                  <a:txBody>
-                    <a:bodyPr/>
-                    <a:lstStyle/>
-                    <a:p>
-                      <a:pPr indent="0" marL="0">
-                        <a:buNone/>
-                      </a:pPr>
-                      <a:r>
-                        <a:rPr lang="en-US" sz="1250" b="1" dirty="0">
-                          <a:solidFill>
-                            <a:srgbClr val="FFFFFF"/>
-                          </a:solidFill>
-                          <a:latin typeface="Calibri" pitchFamily="34" charset="0"/>
-                          <a:ea typeface="Calibri" pitchFamily="34" charset="-122"/>
-                          <a:cs typeface="Calibri" pitchFamily="34" charset="-120"/>
-                        </a:rPr>
-                        <a:t>Input</a:t>
-                      </a:r>
-                      <a:endParaRPr lang="en-US" sz="1250" dirty="0">
-                        <a:latin typeface="Calibri" charset="0"/>
-                        <a:ea typeface="Calibri" charset="0"/>
-                        <a:cs typeface="Calibri" charset="0"/>
-                      </a:endParaRPr>
-                    </a:p>
-                  </a:txBody>
-                  <a:tcPr marL="76200" marR="76200" marT="25400" marB="25400" anchor="ctr">
-                    <a:lnL w="9525" cap="flat" cmpd="sng" algn="ctr">
-                      <a:solidFill>
-                        <a:srgbClr val="D5DAE1"/>
-                      </a:solidFill>
-                      <a:prstDash val="solid"/>
-                      <a:round/>
-                      <a:headEnd type="none" w="med" len="med"/>
-                      <a:tailEnd type="none" w="med" len="med"/>
-                    </a:lnL>
-                    <a:lnR w="9525" cap="flat" cmpd="sng" algn="ctr">
-                      <a:solidFill>
-                        <a:srgbClr val="D5DAE1"/>
-                      </a:solidFill>
-                      <a:prstDash val="solid"/>
-                      <a:round/>
-                      <a:headEnd type="none" w="med" len="med"/>
-                      <a:tailEnd type="none" w="med" len="med"/>
-                    </a:lnR>
-                    <a:lnT w="9525" cap="flat" cmpd="sng" algn="ctr">
-                      <a:solidFill>
-                        <a:srgbClr val="D5DAE1"/>
-                      </a:solidFill>
-                      <a:prstDash val="solid"/>
-                      <a:round/>
-                      <a:headEnd type="none" w="med" len="med"/>
-                      <a:tailEnd type="none" w="med" len="med"/>
-                    </a:lnT>
-                    <a:lnB w="9525" cap="flat" cmpd="sng" algn="ctr">
-                      <a:solidFill>
-                        <a:srgbClr val="D5DAE1"/>
-                      </a:solidFill>
-                      <a:prstDash val="solid"/>
-                      <a:round/>
-                      <a:headEnd type="none" w="med" len="med"/>
-                      <a:tailEnd type="none" w="med" len="med"/>
-                    </a:lnB>
-                    <a:solidFill>
-                      <a:srgbClr val="14213D"/>
-                    </a:solidFill>
-                  </a:tcPr>
-                </a:tc>
-                <a:tc>
-                  <a:txBody>
-                    <a:bodyPr/>
-                    <a:lstStyle/>
-                    <a:p>
-                      <a:pPr indent="0" marL="0">
-                        <a:buNone/>
-                      </a:pPr>
-                      <a:r>
-                        <a:rPr lang="en-US" sz="1250" b="1" dirty="0">
-                          <a:solidFill>
-                            <a:srgbClr val="FFFFFF"/>
-                          </a:solidFill>
-                          <a:latin typeface="Calibri" pitchFamily="34" charset="0"/>
-                          <a:ea typeface="Calibri" pitchFamily="34" charset="-122"/>
-                          <a:cs typeface="Calibri" pitchFamily="34" charset="-120"/>
-                        </a:rPr>
-                        <a:t>Scaled to 0–1</a:t>
-                      </a:r>
-                      <a:endParaRPr lang="en-US" sz="1250" dirty="0">
-                        <a:latin typeface="Calibri" charset="0"/>
-                        <a:ea typeface="Calibri" charset="0"/>
-                        <a:cs typeface="Calibri" charset="0"/>
-                      </a:endParaRPr>
-                    </a:p>
-                  </a:txBody>
-                  <a:tcPr marL="76200" marR="76200" marT="25400" marB="25400" anchor="ctr">
-                    <a:lnL w="9525" cap="flat" cmpd="sng" algn="ctr">
-                      <a:solidFill>
-                        <a:srgbClr val="D5DAE1"/>
-                      </a:solidFill>
-                      <a:prstDash val="solid"/>
-                      <a:round/>
-                      <a:headEnd type="none" w="med" len="med"/>
-                      <a:tailEnd type="none" w="med" len="med"/>
-                    </a:lnL>
-                    <a:lnR w="9525" cap="flat" cmpd="sng" algn="ctr">
-                      <a:solidFill>
-                        <a:srgbClr val="D5DAE1"/>
-                      </a:solidFill>
-                      <a:prstDash val="solid"/>
-                      <a:round/>
-                      <a:headEnd type="none" w="med" len="med"/>
-                      <a:tailEnd type="none" w="med" len="med"/>
-                    </a:lnR>
-                    <a:lnT w="9525" cap="flat" cmpd="sng" algn="ctr">
-                      <a:solidFill>
-                        <a:srgbClr val="D5DAE1"/>
-                      </a:solidFill>
-                      <a:prstDash val="solid"/>
-                      <a:round/>
-                      <a:headEnd type="none" w="med" len="med"/>
-                      <a:tailEnd type="none" w="med" len="med"/>
-                    </a:lnT>
-                    <a:lnB w="9525" cap="flat" cmpd="sng" algn="ctr">
-                      <a:solidFill>
-                        <a:srgbClr val="D5DAE1"/>
-                      </a:solidFill>
-                      <a:prstDash val="solid"/>
-                      <a:round/>
-                      <a:headEnd type="none" w="med" len="med"/>
-                      <a:tailEnd type="none" w="med" len="med"/>
-                    </a:lnB>
-                    <a:solidFill>
-                      <a:srgbClr val="14213D"/>
-                    </a:solidFill>
-                  </a:tcPr>
-                </a:tc>
-                <a:tc>
-                  <a:txBody>
-                    <a:bodyPr/>
-                    <a:lstStyle/>
-                    <a:p>
-                      <a:pPr indent="0" marL="0">
-                        <a:buNone/>
-                      </a:pPr>
-                      <a:r>
-                        <a:rPr lang="en-US" sz="1250" b="1" dirty="0">
-                          <a:solidFill>
-                            <a:srgbClr val="FFFFFF"/>
-                          </a:solidFill>
-                          <a:latin typeface="Calibri" pitchFamily="34" charset="0"/>
-                          <a:ea typeface="Calibri" pitchFamily="34" charset="-122"/>
-                          <a:cs typeface="Calibri" pitchFamily="34" charset="-120"/>
-                        </a:rPr>
-                        <a:t>Weight</a:t>
-                      </a:r>
-                      <a:endParaRPr lang="en-US" sz="1250" dirty="0">
-                        <a:latin typeface="Calibri" charset="0"/>
-                        <a:ea typeface="Calibri" charset="0"/>
-                        <a:cs typeface="Calibri" charset="0"/>
-                      </a:endParaRPr>
-                    </a:p>
-                  </a:txBody>
-                  <a:tcPr marL="76200" marR="76200" marT="25400" marB="25400" anchor="ctr">
-                    <a:lnL w="9525" cap="flat" cmpd="sng" algn="ctr">
-                      <a:solidFill>
-                        <a:srgbClr val="D5DAE1"/>
-                      </a:solidFill>
-                      <a:prstDash val="solid"/>
-                      <a:round/>
-                      <a:headEnd type="none" w="med" len="med"/>
-                      <a:tailEnd type="none" w="med" len="med"/>
-                    </a:lnL>
-                    <a:lnR w="9525" cap="flat" cmpd="sng" algn="ctr">
-                      <a:solidFill>
-                        <a:srgbClr val="D5DAE1"/>
-                      </a:solidFill>
-                      <a:prstDash val="solid"/>
-                      <a:round/>
-                      <a:headEnd type="none" w="med" len="med"/>
-                      <a:tailEnd type="none" w="med" len="med"/>
-                    </a:lnR>
-                    <a:lnT w="9525" cap="flat" cmpd="sng" algn="ctr">
-                      <a:solidFill>
-                        <a:srgbClr val="D5DAE1"/>
-                      </a:solidFill>
-                      <a:prstDash val="solid"/>
-                      <a:round/>
-                      <a:headEnd type="none" w="med" len="med"/>
-                      <a:tailEnd type="none" w="med" len="med"/>
-                    </a:lnT>
-                    <a:lnB w="9525" cap="flat" cmpd="sng" algn="ctr">
-                      <a:solidFill>
-                        <a:srgbClr val="D5DAE1"/>
-                      </a:solidFill>
-                      <a:prstDash val="solid"/>
-                      <a:round/>
-                      <a:headEnd type="none" w="med" len="med"/>
-                      <a:tailEnd type="none" w="med" len="med"/>
-                    </a:lnB>
-                    <a:solidFill>
-                      <a:srgbClr val="14213D"/>
-                    </a:solidFill>
-                  </a:tcPr>
-                </a:tc>
-              </a:tr>
-              <a:tr h="329184">
-                <a:tc>
-                  <a:txBody>
-                    <a:bodyPr/>
-                    <a:lstStyle/>
-                    <a:p>
-                      <a:pPr indent="0" marL="0">
-                        <a:buNone/>
-                      </a:pPr>
-                      <a:r>
-                        <a:rPr lang="en-US" sz="1250" dirty="0">
-                          <a:solidFill>
-                            <a:srgbClr val="26303F"/>
-                          </a:solidFill>
-                          <a:latin typeface="Calibri" pitchFamily="34" charset="0"/>
-                          <a:ea typeface="Calibri" pitchFamily="34" charset="-122"/>
-                          <a:cs typeface="Calibri" pitchFamily="34" charset="-120"/>
-                        </a:rPr>
-                        <a:t>Impact (1–4)</a:t>
-                      </a:r>
-                      <a:endParaRPr lang="en-US" sz="1250" dirty="0">
-                        <a:latin typeface="Calibri" charset="0"/>
-                        <a:ea typeface="Calibri" charset="0"/>
-                        <a:cs typeface="Calibri" charset="0"/>
-                      </a:endParaRPr>
-                    </a:p>
-                  </a:txBody>
-                  <a:tcPr marL="76200" marR="76200" marT="25400" marB="25400" anchor="ctr">
-                    <a:lnL w="9525" cap="flat" cmpd="sng" algn="ctr">
-                      <a:solidFill>
-                        <a:srgbClr val="D5DAE1"/>
-                      </a:solidFill>
-                      <a:prstDash val="solid"/>
-                      <a:round/>
-                      <a:headEnd type="none" w="med" len="med"/>
-                      <a:tailEnd type="none" w="med" len="med"/>
-                    </a:lnL>
-                    <a:lnR w="9525" cap="flat" cmpd="sng" algn="ctr">
-                      <a:solidFill>
-                        <a:srgbClr val="D5DAE1"/>
-                      </a:solidFill>
-                      <a:prstDash val="solid"/>
-                      <a:round/>
-                      <a:headEnd type="none" w="med" len="med"/>
-                      <a:tailEnd type="none" w="med" len="med"/>
-                    </a:lnR>
-                    <a:lnT w="9525" cap="flat" cmpd="sng" algn="ctr">
-                      <a:solidFill>
-                        <a:srgbClr val="D5DAE1"/>
-                      </a:solidFill>
-                      <a:prstDash val="solid"/>
-                      <a:round/>
-                      <a:headEnd type="none" w="med" len="med"/>
-                      <a:tailEnd type="none" w="med" len="med"/>
-                    </a:lnT>
-                    <a:lnB w="9525" cap="flat" cmpd="sng" algn="ctr">
-                      <a:solidFill>
-                        <a:srgbClr val="D5DAE1"/>
-                      </a:solidFill>
-                      <a:prstDash val="solid"/>
-                      <a:round/>
-                      <a:headEnd type="none" w="med" len="med"/>
-                      <a:tailEnd type="none" w="med" len="med"/>
-                    </a:lnB>
-                    <a:solidFill>
-                      <a:srgbClr val="FFFFFF"/>
-                    </a:solidFill>
-                  </a:tcPr>
-                </a:tc>
-                <a:tc>
-                  <a:txBody>
-                    <a:bodyPr/>
-                    <a:lstStyle/>
-                    <a:p>
-                      <a:pPr indent="0" marL="0">
-                        <a:buNone/>
-                      </a:pPr>
-                      <a:r>
-                        <a:rPr lang="en-US" sz="1250" dirty="0">
-                          <a:solidFill>
-                            <a:srgbClr val="26303F"/>
-                          </a:solidFill>
-                          <a:latin typeface="Calibri" pitchFamily="34" charset="0"/>
-                          <a:ea typeface="Calibri" pitchFamily="34" charset="-122"/>
-                          <a:cs typeface="Calibri" pitchFamily="34" charset="-120"/>
-                        </a:rPr>
-                        <a:t>(impact − 1) ÷ 3</a:t>
-                      </a:r>
-                      <a:endParaRPr lang="en-US" sz="1250" dirty="0">
-                        <a:latin typeface="Calibri" charset="0"/>
-                        <a:ea typeface="Calibri" charset="0"/>
-                        <a:cs typeface="Calibri" charset="0"/>
-                      </a:endParaRPr>
-                    </a:p>
-                  </a:txBody>
-                  <a:tcPr marL="76200" marR="76200" marT="25400" marB="25400" anchor="ctr">
-                    <a:lnL w="9525" cap="flat" cmpd="sng" algn="ctr">
-                      <a:solidFill>
-                        <a:srgbClr val="D5DAE1"/>
-                      </a:solidFill>
-                      <a:prstDash val="solid"/>
-                      <a:round/>
-                      <a:headEnd type="none" w="med" len="med"/>
-                      <a:tailEnd type="none" w="med" len="med"/>
-                    </a:lnL>
-                    <a:lnR w="9525" cap="flat" cmpd="sng" algn="ctr">
-                      <a:solidFill>
-                        <a:srgbClr val="D5DAE1"/>
-                      </a:solidFill>
-                      <a:prstDash val="solid"/>
-                      <a:round/>
-                      <a:headEnd type="none" w="med" len="med"/>
-                      <a:tailEnd type="none" w="med" len="med"/>
-                    </a:lnR>
-                    <a:lnT w="9525" cap="flat" cmpd="sng" algn="ctr">
-                      <a:solidFill>
-                        <a:srgbClr val="D5DAE1"/>
-                      </a:solidFill>
-                      <a:prstDash val="solid"/>
-                      <a:round/>
-                      <a:headEnd type="none" w="med" len="med"/>
-                      <a:tailEnd type="none" w="med" len="med"/>
-                    </a:lnT>
-                    <a:lnB w="9525" cap="flat" cmpd="sng" algn="ctr">
-                      <a:solidFill>
-                        <a:srgbClr val="D5DAE1"/>
-                      </a:solidFill>
-                      <a:prstDash val="solid"/>
-                      <a:round/>
-                      <a:headEnd type="none" w="med" len="med"/>
-                      <a:tailEnd type="none" w="med" len="med"/>
-                    </a:lnB>
-                    <a:solidFill>
-                      <a:srgbClr val="FFFFFF"/>
-                    </a:solidFill>
-                  </a:tcPr>
-                </a:tc>
-                <a:tc>
-                  <a:txBody>
-                    <a:bodyPr/>
-                    <a:lstStyle/>
-                    <a:p>
-                      <a:pPr indent="0" marL="0">
-                        <a:buNone/>
-                      </a:pPr>
-                      <a:r>
-                        <a:rPr lang="en-US" sz="1250" dirty="0">
-                          <a:solidFill>
-                            <a:srgbClr val="26303F"/>
-                          </a:solidFill>
-                          <a:latin typeface="Calibri" pitchFamily="34" charset="0"/>
-                          <a:ea typeface="Calibri" pitchFamily="34" charset="-122"/>
-                          <a:cs typeface="Calibri" pitchFamily="34" charset="-120"/>
-                        </a:rPr>
-                        <a:t>0.40</a:t>
-                      </a:r>
-                      <a:endParaRPr lang="en-US" sz="1250" dirty="0">
-                        <a:latin typeface="Calibri" charset="0"/>
-                        <a:ea typeface="Calibri" charset="0"/>
-                        <a:cs typeface="Calibri" charset="0"/>
-                      </a:endParaRPr>
-                    </a:p>
-                  </a:txBody>
-                  <a:tcPr marL="76200" marR="76200" marT="25400" marB="25400" anchor="ctr">
-                    <a:lnL w="9525" cap="flat" cmpd="sng" algn="ctr">
-                      <a:solidFill>
-                        <a:srgbClr val="D5DAE1"/>
-                      </a:solidFill>
-                      <a:prstDash val="solid"/>
-                      <a:round/>
-                      <a:headEnd type="none" w="med" len="med"/>
-                      <a:tailEnd type="none" w="med" len="med"/>
-                    </a:lnL>
-                    <a:lnR w="9525" cap="flat" cmpd="sng" algn="ctr">
-                      <a:solidFill>
-                        <a:srgbClr val="D5DAE1"/>
-                      </a:solidFill>
-                      <a:prstDash val="solid"/>
-                      <a:round/>
-                      <a:headEnd type="none" w="med" len="med"/>
-                      <a:tailEnd type="none" w="med" len="med"/>
-                    </a:lnR>
-                    <a:lnT w="9525" cap="flat" cmpd="sng" algn="ctr">
-                      <a:solidFill>
-                        <a:srgbClr val="D5DAE1"/>
-                      </a:solidFill>
-                      <a:prstDash val="solid"/>
-                      <a:round/>
-                      <a:headEnd type="none" w="med" len="med"/>
-                      <a:tailEnd type="none" w="med" len="med"/>
-                    </a:lnT>
-                    <a:lnB w="9525" cap="flat" cmpd="sng" algn="ctr">
-                      <a:solidFill>
-                        <a:srgbClr val="D5DAE1"/>
-                      </a:solidFill>
-                      <a:prstDash val="solid"/>
-                      <a:round/>
-                      <a:headEnd type="none" w="med" len="med"/>
-                      <a:tailEnd type="none" w="med" len="med"/>
-                    </a:lnB>
-                    <a:solidFill>
-                      <a:srgbClr val="FFFFFF"/>
-                    </a:solidFill>
-                  </a:tcPr>
-                </a:tc>
-              </a:tr>
-              <a:tr h="329184">
-                <a:tc>
-                  <a:txBody>
-                    <a:bodyPr/>
-                    <a:lstStyle/>
-                    <a:p>
-                      <a:pPr indent="0" marL="0">
-                        <a:buNone/>
-                      </a:pPr>
-                      <a:r>
-                        <a:rPr lang="en-US" sz="1250" dirty="0">
-                          <a:solidFill>
-                            <a:srgbClr val="26303F"/>
-                          </a:solidFill>
-                          <a:latin typeface="Calibri" pitchFamily="34" charset="0"/>
-                          <a:ea typeface="Calibri" pitchFamily="34" charset="-122"/>
-                          <a:cs typeface="Calibri" pitchFamily="34" charset="-120"/>
-                        </a:rPr>
-                        <a:t>Urgency (1–4)</a:t>
-                      </a:r>
-                      <a:endParaRPr lang="en-US" sz="1250" dirty="0">
-                        <a:latin typeface="Calibri" charset="0"/>
-                        <a:ea typeface="Calibri" charset="0"/>
-                        <a:cs typeface="Calibri" charset="0"/>
-                      </a:endParaRPr>
-                    </a:p>
-                  </a:txBody>
-                  <a:tcPr marL="76200" marR="76200" marT="25400" marB="25400" anchor="ctr">
-                    <a:lnL w="9525" cap="flat" cmpd="sng" algn="ctr">
-                      <a:solidFill>
-                        <a:srgbClr val="D5DAE1"/>
-                      </a:solidFill>
-                      <a:prstDash val="solid"/>
-                      <a:round/>
-                      <a:headEnd type="none" w="med" len="med"/>
-                      <a:tailEnd type="none" w="med" len="med"/>
-                    </a:lnL>
-                    <a:lnR w="9525" cap="flat" cmpd="sng" algn="ctr">
-                      <a:solidFill>
-                        <a:srgbClr val="D5DAE1"/>
-                      </a:solidFill>
-                      <a:prstDash val="solid"/>
-                      <a:round/>
-                      <a:headEnd type="none" w="med" len="med"/>
-                      <a:tailEnd type="none" w="med" len="med"/>
-                    </a:lnR>
-                    <a:lnT w="9525" cap="flat" cmpd="sng" algn="ctr">
-                      <a:solidFill>
-                        <a:srgbClr val="D5DAE1"/>
-                      </a:solidFill>
-                      <a:prstDash val="solid"/>
-                      <a:round/>
-                      <a:headEnd type="none" w="med" len="med"/>
-                      <a:tailEnd type="none" w="med" len="med"/>
-                    </a:lnT>
-                    <a:lnB w="9525" cap="flat" cmpd="sng" algn="ctr">
-                      <a:solidFill>
-                        <a:srgbClr val="D5DAE1"/>
-                      </a:solidFill>
-                      <a:prstDash val="solid"/>
-                      <a:round/>
-                      <a:headEnd type="none" w="med" len="med"/>
-                      <a:tailEnd type="none" w="med" len="med"/>
-                    </a:lnB>
-                    <a:solidFill>
-                      <a:srgbClr val="F7F8FA"/>
-                    </a:solidFill>
-                  </a:tcPr>
-                </a:tc>
-                <a:tc>
-                  <a:txBody>
-                    <a:bodyPr/>
-                    <a:lstStyle/>
-                    <a:p>
-                      <a:pPr indent="0" marL="0">
-                        <a:buNone/>
-                      </a:pPr>
-                      <a:r>
-                        <a:rPr lang="en-US" sz="1250" dirty="0">
-                          <a:solidFill>
-                            <a:srgbClr val="26303F"/>
-                          </a:solidFill>
-                          <a:latin typeface="Calibri" pitchFamily="34" charset="0"/>
-                          <a:ea typeface="Calibri" pitchFamily="34" charset="-122"/>
-                          <a:cs typeface="Calibri" pitchFamily="34" charset="-120"/>
-                        </a:rPr>
-                        <a:t>(urgency − 1) ÷ 3</a:t>
-                      </a:r>
-                      <a:endParaRPr lang="en-US" sz="1250" dirty="0">
-                        <a:latin typeface="Calibri" charset="0"/>
-                        <a:ea typeface="Calibri" charset="0"/>
-                        <a:cs typeface="Calibri" charset="0"/>
-                      </a:endParaRPr>
-                    </a:p>
-                  </a:txBody>
-                  <a:tcPr marL="76200" marR="76200" marT="25400" marB="25400" anchor="ctr">
-                    <a:lnL w="9525" cap="flat" cmpd="sng" algn="ctr">
-                      <a:solidFill>
-                        <a:srgbClr val="D5DAE1"/>
-                      </a:solidFill>
-                      <a:prstDash val="solid"/>
-                      <a:round/>
-                      <a:headEnd type="none" w="med" len="med"/>
-                      <a:tailEnd type="none" w="med" len="med"/>
-                    </a:lnL>
-                    <a:lnR w="9525" cap="flat" cmpd="sng" algn="ctr">
-                      <a:solidFill>
-                        <a:srgbClr val="D5DAE1"/>
-                      </a:solidFill>
-                      <a:prstDash val="solid"/>
-                      <a:round/>
-                      <a:headEnd type="none" w="med" len="med"/>
-                      <a:tailEnd type="none" w="med" len="med"/>
-                    </a:lnR>
-                    <a:lnT w="9525" cap="flat" cmpd="sng" algn="ctr">
-                      <a:solidFill>
-                        <a:srgbClr val="D5DAE1"/>
-                      </a:solidFill>
-                      <a:prstDash val="solid"/>
-                      <a:round/>
-                      <a:headEnd type="none" w="med" len="med"/>
-                      <a:tailEnd type="none" w="med" len="med"/>
-                    </a:lnT>
-                    <a:lnB w="9525" cap="flat" cmpd="sng" algn="ctr">
-                      <a:solidFill>
-                        <a:srgbClr val="D5DAE1"/>
-                      </a:solidFill>
-                      <a:prstDash val="solid"/>
-                      <a:round/>
-                      <a:headEnd type="none" w="med" len="med"/>
-                      <a:tailEnd type="none" w="med" len="med"/>
-                    </a:lnB>
-                    <a:solidFill>
-                      <a:srgbClr val="F7F8FA"/>
-                    </a:solidFill>
-                  </a:tcPr>
-                </a:tc>
-                <a:tc>
-                  <a:txBody>
-                    <a:bodyPr/>
-                    <a:lstStyle/>
-                    <a:p>
-                      <a:pPr indent="0" marL="0">
-                        <a:buNone/>
-                      </a:pPr>
-                      <a:r>
-                        <a:rPr lang="en-US" sz="1250" dirty="0">
-                          <a:solidFill>
-                            <a:srgbClr val="26303F"/>
-                          </a:solidFill>
-                          <a:latin typeface="Calibri" pitchFamily="34" charset="0"/>
-                          <a:ea typeface="Calibri" pitchFamily="34" charset="-122"/>
-                          <a:cs typeface="Calibri" pitchFamily="34" charset="-120"/>
-                        </a:rPr>
-                        <a:t>0.35</a:t>
-                      </a:r>
-                      <a:endParaRPr lang="en-US" sz="1250" dirty="0">
-                        <a:latin typeface="Calibri" charset="0"/>
-                        <a:ea typeface="Calibri" charset="0"/>
-                        <a:cs typeface="Calibri" charset="0"/>
-                      </a:endParaRPr>
-                    </a:p>
-                  </a:txBody>
-                  <a:tcPr marL="76200" marR="76200" marT="25400" marB="25400" anchor="ctr">
-                    <a:lnL w="9525" cap="flat" cmpd="sng" algn="ctr">
-                      <a:solidFill>
-                        <a:srgbClr val="D5DAE1"/>
-                      </a:solidFill>
-                      <a:prstDash val="solid"/>
-                      <a:round/>
-                      <a:headEnd type="none" w="med" len="med"/>
-                      <a:tailEnd type="none" w="med" len="med"/>
-                    </a:lnL>
-                    <a:lnR w="9525" cap="flat" cmpd="sng" algn="ctr">
-                      <a:solidFill>
-                        <a:srgbClr val="D5DAE1"/>
-                      </a:solidFill>
-                      <a:prstDash val="solid"/>
-                      <a:round/>
-                      <a:headEnd type="none" w="med" len="med"/>
-                      <a:tailEnd type="none" w="med" len="med"/>
-                    </a:lnR>
-                    <a:lnT w="9525" cap="flat" cmpd="sng" algn="ctr">
-                      <a:solidFill>
-                        <a:srgbClr val="D5DAE1"/>
-                      </a:solidFill>
-                      <a:prstDash val="solid"/>
-                      <a:round/>
-                      <a:headEnd type="none" w="med" len="med"/>
-                      <a:tailEnd type="none" w="med" len="med"/>
-                    </a:lnT>
-                    <a:lnB w="9525" cap="flat" cmpd="sng" algn="ctr">
-                      <a:solidFill>
-                        <a:srgbClr val="D5DAE1"/>
-                      </a:solidFill>
-                      <a:prstDash val="solid"/>
-                      <a:round/>
-                      <a:headEnd type="none" w="med" len="med"/>
-                      <a:tailEnd type="none" w="med" len="med"/>
-                    </a:lnB>
-                    <a:solidFill>
-                      <a:srgbClr val="F7F8FA"/>
-                    </a:solidFill>
-                  </a:tcPr>
-                </a:tc>
-              </a:tr>
-              <a:tr h="329184">
-                <a:tc>
-                  <a:txBody>
-                    <a:bodyPr/>
-                    <a:lstStyle/>
-                    <a:p>
-                      <a:pPr indent="0" marL="0">
-                        <a:buNone/>
-                      </a:pPr>
-                      <a:r>
-                        <a:rPr lang="en-US" sz="1250" dirty="0">
-                          <a:solidFill>
-                            <a:srgbClr val="26303F"/>
-                          </a:solidFill>
-                          <a:latin typeface="Calibri" pitchFamily="34" charset="0"/>
-                          <a:ea typeface="Calibri" pitchFamily="34" charset="-122"/>
-                          <a:cs typeface="Calibri" pitchFamily="34" charset="-120"/>
-                        </a:rPr>
-                        <a:t>Customer tier</a:t>
-                      </a:r>
-                      <a:endParaRPr lang="en-US" sz="1250" dirty="0">
-                        <a:latin typeface="Calibri" charset="0"/>
-                        <a:ea typeface="Calibri" charset="0"/>
-                        <a:cs typeface="Calibri" charset="0"/>
-                      </a:endParaRPr>
-                    </a:p>
-                  </a:txBody>
-                  <a:tcPr marL="76200" marR="76200" marT="25400" marB="25400" anchor="ctr">
-                    <a:lnL w="9525" cap="flat" cmpd="sng" algn="ctr">
-                      <a:solidFill>
-                        <a:srgbClr val="D5DAE1"/>
-                      </a:solidFill>
-                      <a:prstDash val="solid"/>
-                      <a:round/>
-                      <a:headEnd type="none" w="med" len="med"/>
-                      <a:tailEnd type="none" w="med" len="med"/>
-                    </a:lnL>
-                    <a:lnR w="9525" cap="flat" cmpd="sng" algn="ctr">
-                      <a:solidFill>
-                        <a:srgbClr val="D5DAE1"/>
-                      </a:solidFill>
-                      <a:prstDash val="solid"/>
-                      <a:round/>
-                      <a:headEnd type="none" w="med" len="med"/>
-                      <a:tailEnd type="none" w="med" len="med"/>
-                    </a:lnR>
-                    <a:lnT w="9525" cap="flat" cmpd="sng" algn="ctr">
-                      <a:solidFill>
-                        <a:srgbClr val="D5DAE1"/>
-                      </a:solidFill>
-                      <a:prstDash val="solid"/>
-                      <a:round/>
-                      <a:headEnd type="none" w="med" len="med"/>
-                      <a:tailEnd type="none" w="med" len="med"/>
-                    </a:lnT>
-                    <a:lnB w="9525" cap="flat" cmpd="sng" algn="ctr">
-                      <a:solidFill>
-                        <a:srgbClr val="D5DAE1"/>
-                      </a:solidFill>
-                      <a:prstDash val="solid"/>
-                      <a:round/>
-                      <a:headEnd type="none" w="med" len="med"/>
-                      <a:tailEnd type="none" w="med" len="med"/>
-                    </a:lnB>
-                    <a:solidFill>
-                      <a:srgbClr val="FFFFFF"/>
-                    </a:solidFill>
-                  </a:tcPr>
-                </a:tc>
-                <a:tc>
-                  <a:txBody>
-                    <a:bodyPr/>
-                    <a:lstStyle/>
-                    <a:p>
-                      <a:pPr indent="0" marL="0">
-                        <a:buNone/>
-                      </a:pPr>
-                      <a:r>
-                        <a:rPr lang="en-US" sz="1250" dirty="0">
-                          <a:solidFill>
-                            <a:srgbClr val="26303F"/>
-                          </a:solidFill>
-                          <a:latin typeface="Calibri" pitchFamily="34" charset="0"/>
-                          <a:ea typeface="Calibri" pitchFamily="34" charset="-122"/>
-                          <a:cs typeface="Calibri" pitchFamily="34" charset="-120"/>
-                        </a:rPr>
-                        <a:t>standard 0, premium 0.5, enterprise 1</a:t>
-                      </a:r>
-                      <a:endParaRPr lang="en-US" sz="1250" dirty="0">
-                        <a:latin typeface="Calibri" charset="0"/>
-                        <a:ea typeface="Calibri" charset="0"/>
-                        <a:cs typeface="Calibri" charset="0"/>
-                      </a:endParaRPr>
-                    </a:p>
-                  </a:txBody>
-                  <a:tcPr marL="76200" marR="76200" marT="25400" marB="25400" anchor="ctr">
-                    <a:lnL w="9525" cap="flat" cmpd="sng" algn="ctr">
-                      <a:solidFill>
-                        <a:srgbClr val="D5DAE1"/>
-                      </a:solidFill>
-                      <a:prstDash val="solid"/>
-                      <a:round/>
-                      <a:headEnd type="none" w="med" len="med"/>
-                      <a:tailEnd type="none" w="med" len="med"/>
-                    </a:lnL>
-                    <a:lnR w="9525" cap="flat" cmpd="sng" algn="ctr">
-                      <a:solidFill>
-                        <a:srgbClr val="D5DAE1"/>
-                      </a:solidFill>
-                      <a:prstDash val="solid"/>
-                      <a:round/>
-                      <a:headEnd type="none" w="med" len="med"/>
-                      <a:tailEnd type="none" w="med" len="med"/>
-                    </a:lnR>
-                    <a:lnT w="9525" cap="flat" cmpd="sng" algn="ctr">
-                      <a:solidFill>
-                        <a:srgbClr val="D5DAE1"/>
-                      </a:solidFill>
-                      <a:prstDash val="solid"/>
-                      <a:round/>
-                      <a:headEnd type="none" w="med" len="med"/>
-                      <a:tailEnd type="none" w="med" len="med"/>
-                    </a:lnT>
-                    <a:lnB w="9525" cap="flat" cmpd="sng" algn="ctr">
-                      <a:solidFill>
-                        <a:srgbClr val="D5DAE1"/>
-                      </a:solidFill>
-                      <a:prstDash val="solid"/>
-                      <a:round/>
-                      <a:headEnd type="none" w="med" len="med"/>
-                      <a:tailEnd type="none" w="med" len="med"/>
-                    </a:lnB>
-                    <a:solidFill>
-                      <a:srgbClr val="FFFFFF"/>
-                    </a:solidFill>
-                  </a:tcPr>
-                </a:tc>
-                <a:tc>
-                  <a:txBody>
-                    <a:bodyPr/>
-                    <a:lstStyle/>
-                    <a:p>
-                      <a:pPr indent="0" marL="0">
-                        <a:buNone/>
-                      </a:pPr>
-                      <a:r>
-                        <a:rPr lang="en-US" sz="1250" dirty="0">
-                          <a:solidFill>
-                            <a:srgbClr val="26303F"/>
-                          </a:solidFill>
-                          <a:latin typeface="Calibri" pitchFamily="34" charset="0"/>
-                          <a:ea typeface="Calibri" pitchFamily="34" charset="-122"/>
-                          <a:cs typeface="Calibri" pitchFamily="34" charset="-120"/>
-                        </a:rPr>
-                        <a:t>0.15</a:t>
-                      </a:r>
-                      <a:endParaRPr lang="en-US" sz="1250" dirty="0">
-                        <a:latin typeface="Calibri" charset="0"/>
-                        <a:ea typeface="Calibri" charset="0"/>
-                        <a:cs typeface="Calibri" charset="0"/>
-                      </a:endParaRPr>
-                    </a:p>
-                  </a:txBody>
-                  <a:tcPr marL="76200" marR="76200" marT="25400" marB="25400" anchor="ctr">
-                    <a:lnL w="9525" cap="flat" cmpd="sng" algn="ctr">
-                      <a:solidFill>
-                        <a:srgbClr val="D5DAE1"/>
-                      </a:solidFill>
-                      <a:prstDash val="solid"/>
-                      <a:round/>
-                      <a:headEnd type="none" w="med" len="med"/>
-                      <a:tailEnd type="none" w="med" len="med"/>
-                    </a:lnL>
-                    <a:lnR w="9525" cap="flat" cmpd="sng" algn="ctr">
-                      <a:solidFill>
-                        <a:srgbClr val="D5DAE1"/>
-                      </a:solidFill>
-                      <a:prstDash val="solid"/>
-                      <a:round/>
-                      <a:headEnd type="none" w="med" len="med"/>
-                      <a:tailEnd type="none" w="med" len="med"/>
-                    </a:lnR>
-                    <a:lnT w="9525" cap="flat" cmpd="sng" algn="ctr">
-                      <a:solidFill>
-                        <a:srgbClr val="D5DAE1"/>
-                      </a:solidFill>
-                      <a:prstDash val="solid"/>
-                      <a:round/>
-                      <a:headEnd type="none" w="med" len="med"/>
-                      <a:tailEnd type="none" w="med" len="med"/>
-                    </a:lnT>
-                    <a:lnB w="9525" cap="flat" cmpd="sng" algn="ctr">
-                      <a:solidFill>
-                        <a:srgbClr val="D5DAE1"/>
-                      </a:solidFill>
-                      <a:prstDash val="solid"/>
-                      <a:round/>
-                      <a:headEnd type="none" w="med" len="med"/>
-                      <a:tailEnd type="none" w="med" len="med"/>
-                    </a:lnB>
-                    <a:solidFill>
-                      <a:srgbClr val="FFFFFF"/>
-                    </a:solidFill>
-                  </a:tcPr>
-                </a:tc>
-              </a:tr>
-              <a:tr h="329184">
-                <a:tc>
-                  <a:txBody>
-                    <a:bodyPr/>
-                    <a:lstStyle/>
-                    <a:p>
-                      <a:pPr indent="0" marL="0">
-                        <a:buNone/>
-                      </a:pPr>
-                      <a:r>
-                        <a:rPr lang="en-US" sz="1250" dirty="0">
-                          <a:solidFill>
-                            <a:srgbClr val="26303F"/>
-                          </a:solidFill>
-                          <a:latin typeface="Calibri" pitchFamily="34" charset="0"/>
-                          <a:ea typeface="Calibri" pitchFamily="34" charset="-122"/>
-                          <a:cs typeface="Calibri" pitchFamily="34" charset="-120"/>
-                        </a:rPr>
-                        <a:t>Waiting time</a:t>
-                      </a:r>
-                      <a:endParaRPr lang="en-US" sz="1250" dirty="0">
-                        <a:latin typeface="Calibri" charset="0"/>
-                        <a:ea typeface="Calibri" charset="0"/>
-                        <a:cs typeface="Calibri" charset="0"/>
-                      </a:endParaRPr>
-                    </a:p>
-                  </a:txBody>
-                  <a:tcPr marL="76200" marR="76200" marT="25400" marB="25400" anchor="ctr">
-                    <a:lnL w="9525" cap="flat" cmpd="sng" algn="ctr">
-                      <a:solidFill>
-                        <a:srgbClr val="D5DAE1"/>
-                      </a:solidFill>
-                      <a:prstDash val="solid"/>
-                      <a:round/>
-                      <a:headEnd type="none" w="med" len="med"/>
-                      <a:tailEnd type="none" w="med" len="med"/>
-                    </a:lnL>
-                    <a:lnR w="9525" cap="flat" cmpd="sng" algn="ctr">
-                      <a:solidFill>
-                        <a:srgbClr val="D5DAE1"/>
-                      </a:solidFill>
-                      <a:prstDash val="solid"/>
-                      <a:round/>
-                      <a:headEnd type="none" w="med" len="med"/>
-                      <a:tailEnd type="none" w="med" len="med"/>
-                    </a:lnR>
-                    <a:lnT w="9525" cap="flat" cmpd="sng" algn="ctr">
-                      <a:solidFill>
-                        <a:srgbClr val="D5DAE1"/>
-                      </a:solidFill>
-                      <a:prstDash val="solid"/>
-                      <a:round/>
-                      <a:headEnd type="none" w="med" len="med"/>
-                      <a:tailEnd type="none" w="med" len="med"/>
-                    </a:lnT>
-                    <a:lnB w="9525" cap="flat" cmpd="sng" algn="ctr">
-                      <a:solidFill>
-                        <a:srgbClr val="D5DAE1"/>
-                      </a:solidFill>
-                      <a:prstDash val="solid"/>
-                      <a:round/>
-                      <a:headEnd type="none" w="med" len="med"/>
-                      <a:tailEnd type="none" w="med" len="med"/>
-                    </a:lnB>
-                    <a:solidFill>
-                      <a:srgbClr val="F7F8FA"/>
-                    </a:solidFill>
-                  </a:tcPr>
-                </a:tc>
-                <a:tc>
-                  <a:txBody>
-                    <a:bodyPr/>
-                    <a:lstStyle/>
-                    <a:p>
-                      <a:pPr indent="0" marL="0">
-                        <a:buNone/>
-                      </a:pPr>
-                      <a:r>
-                        <a:rPr lang="en-US" sz="1250" dirty="0">
-                          <a:solidFill>
-                            <a:srgbClr val="26303F"/>
-                          </a:solidFill>
-                          <a:latin typeface="Calibri" pitchFamily="34" charset="0"/>
-                          <a:ea typeface="Calibri" pitchFamily="34" charset="-122"/>
-                          <a:cs typeface="Calibri" pitchFamily="34" charset="-120"/>
-                        </a:rPr>
-                        <a:t>min(1, hours ÷ 72)</a:t>
-                      </a:r>
-                      <a:endParaRPr lang="en-US" sz="1250" dirty="0">
-                        <a:latin typeface="Calibri" charset="0"/>
-                        <a:ea typeface="Calibri" charset="0"/>
-                        <a:cs typeface="Calibri" charset="0"/>
-                      </a:endParaRPr>
-                    </a:p>
-                  </a:txBody>
-                  <a:tcPr marL="76200" marR="76200" marT="25400" marB="25400" anchor="ctr">
-                    <a:lnL w="9525" cap="flat" cmpd="sng" algn="ctr">
-                      <a:solidFill>
-                        <a:srgbClr val="D5DAE1"/>
-                      </a:solidFill>
-                      <a:prstDash val="solid"/>
-                      <a:round/>
-                      <a:headEnd type="none" w="med" len="med"/>
-                      <a:tailEnd type="none" w="med" len="med"/>
-                    </a:lnL>
-                    <a:lnR w="9525" cap="flat" cmpd="sng" algn="ctr">
-                      <a:solidFill>
-                        <a:srgbClr val="D5DAE1"/>
-                      </a:solidFill>
-                      <a:prstDash val="solid"/>
-                      <a:round/>
-                      <a:headEnd type="none" w="med" len="med"/>
-                      <a:tailEnd type="none" w="med" len="med"/>
-                    </a:lnR>
-                    <a:lnT w="9525" cap="flat" cmpd="sng" algn="ctr">
-                      <a:solidFill>
-                        <a:srgbClr val="D5DAE1"/>
-                      </a:solidFill>
-                      <a:prstDash val="solid"/>
-                      <a:round/>
-                      <a:headEnd type="none" w="med" len="med"/>
-                      <a:tailEnd type="none" w="med" len="med"/>
-                    </a:lnT>
-                    <a:lnB w="9525" cap="flat" cmpd="sng" algn="ctr">
-                      <a:solidFill>
-                        <a:srgbClr val="D5DAE1"/>
-                      </a:solidFill>
-                      <a:prstDash val="solid"/>
-                      <a:round/>
-                      <a:headEnd type="none" w="med" len="med"/>
-                      <a:tailEnd type="none" w="med" len="med"/>
-                    </a:lnB>
-                    <a:solidFill>
-                      <a:srgbClr val="F7F8FA"/>
-                    </a:solidFill>
-                  </a:tcPr>
-                </a:tc>
-                <a:tc>
-                  <a:txBody>
-                    <a:bodyPr/>
-                    <a:lstStyle/>
-                    <a:p>
-                      <a:pPr indent="0" marL="0">
-                        <a:buNone/>
-                      </a:pPr>
-                      <a:r>
-                        <a:rPr lang="en-US" sz="1250" dirty="0">
-                          <a:solidFill>
-                            <a:srgbClr val="26303F"/>
-                          </a:solidFill>
-                          <a:latin typeface="Calibri" pitchFamily="34" charset="0"/>
-                          <a:ea typeface="Calibri" pitchFamily="34" charset="-122"/>
-                          <a:cs typeface="Calibri" pitchFamily="34" charset="-120"/>
-                        </a:rPr>
-                        <a:t>0.10</a:t>
-                      </a:r>
-                      <a:endParaRPr lang="en-US" sz="1250" dirty="0">
-                        <a:latin typeface="Calibri" charset="0"/>
-                        <a:ea typeface="Calibri" charset="0"/>
-                        <a:cs typeface="Calibri" charset="0"/>
-                      </a:endParaRPr>
-                    </a:p>
-                  </a:txBody>
-                  <a:tcPr marL="76200" marR="76200" marT="25400" marB="25400" anchor="ctr">
-                    <a:lnL w="9525" cap="flat" cmpd="sng" algn="ctr">
-                      <a:solidFill>
-                        <a:srgbClr val="D5DAE1"/>
-                      </a:solidFill>
-                      <a:prstDash val="solid"/>
-                      <a:round/>
-                      <a:headEnd type="none" w="med" len="med"/>
-                      <a:tailEnd type="none" w="med" len="med"/>
-                    </a:lnL>
-                    <a:lnR w="9525" cap="flat" cmpd="sng" algn="ctr">
-                      <a:solidFill>
-                        <a:srgbClr val="D5DAE1"/>
-                      </a:solidFill>
-                      <a:prstDash val="solid"/>
-                      <a:round/>
-                      <a:headEnd type="none" w="med" len="med"/>
-                      <a:tailEnd type="none" w="med" len="med"/>
-                    </a:lnR>
-                    <a:lnT w="9525" cap="flat" cmpd="sng" algn="ctr">
-                      <a:solidFill>
-                        <a:srgbClr val="D5DAE1"/>
-                      </a:solidFill>
-                      <a:prstDash val="solid"/>
-                      <a:round/>
-                      <a:headEnd type="none" w="med" len="med"/>
-                      <a:tailEnd type="none" w="med" len="med"/>
-                    </a:lnT>
-                    <a:lnB w="9525" cap="flat" cmpd="sng" algn="ctr">
-                      <a:solidFill>
-                        <a:srgbClr val="D5DAE1"/>
-                      </a:solidFill>
-                      <a:prstDash val="solid"/>
-                      <a:round/>
-                      <a:headEnd type="none" w="med" len="med"/>
-                      <a:tailEnd type="none" w="med" len="med"/>
-                    </a:lnB>
-                    <a:solidFill>
-                      <a:srgbClr val="F7F8FA"/>
-                    </a:solidFill>
-                  </a:tcPr>
-                </a:tc>
-              </a:tr>
-            </a:tbl>
-          </a:graphicData>
-        </a:graphic>
-      </p:graphicFrame>
-      <p:sp>
-        <p:nvSpPr>
-          <p:cNvPr id="10" name="Text 6"/>
-          <p:cNvSpPr/>
-          <p:nvPr/>
-        </p:nvSpPr>
-        <p:spPr>
-          <a:xfrm>
-            <a:off x="548640" y="3566160"/>
-            <a:ext cx="5394960" cy="731520"/>
-          </a:xfrm>
-          <a:prstGeom prst="rect">
-            <a:avLst/>
-          </a:prstGeom>
-          <a:noFill/>
-          <a:ln/>
-        </p:spPr>
-        <p:txBody>
-          <a:bodyPr wrap="square" lIns="0" tIns="0" rIns="0" bIns="0" rtlCol="0" anchor="ctr"/>
-          <a:lstStyle/>
-          <a:p>
-            <a:pPr indent="0" marL="0">
-              <a:buNone/>
-            </a:pPr>
-            <a:r>
-              <a:rPr lang="en-US" sz="1600" dirty="0">
-                <a:solidFill>
-                  <a:srgbClr val="14213D"/>
-                </a:solidFill>
-                <a:latin typeface="Georgia" pitchFamily="34" charset="0"/>
-                <a:ea typeface="Georgia" pitchFamily="34" charset="-122"/>
-                <a:cs typeface="Georgia" pitchFamily="34" charset="-120"/>
-              </a:rPr>
-              <a:t>score = 100 × Σ (weight × scaled value)</a:t>
-            </a:r>
-            <a:endParaRPr lang="en-US" sz="1600" dirty="0"/>
-          </a:p>
-          <a:p>
-            <a:pPr indent="0" marL="0">
-              <a:buNone/>
-            </a:pPr>
-            <a:r>
-              <a:rPr lang="en-US" sz="1350" dirty="0">
-                <a:solidFill>
-                  <a:srgbClr val="26303F"/>
-                </a:solidFill>
-                <a:latin typeface="Calibri" pitchFamily="34" charset="0"/>
-                <a:ea typeface="Calibri" pitchFamily="34" charset="-122"/>
-                <a:cs typeface="Calibri" pitchFamily="34" charset="-120"/>
-              </a:rPr>
-              <a:t>P1 from 75, P2 from 50, P3 from 25, otherwise P4</a:t>
-            </a:r>
-            <a:endParaRPr lang="en-US" sz="1600" dirty="0"/>
           </a:p>
         </p:txBody>
       </p:sp>
@@ -3932,8 +2815,8 @@
         </p:nvSpPr>
         <p:spPr>
           <a:xfrm>
-            <a:off x="548640" y="4434840"/>
-            <a:ext cx="5394960" cy="1737360"/>
+            <a:off x="548640" y="4206240"/>
+            <a:ext cx="5394960" cy="1965960"/>
           </a:xfrm>
           <a:prstGeom prst="rect">
             <a:avLst/>
@@ -3957,8 +2840,8 @@
         </p:nvSpPr>
         <p:spPr>
           <a:xfrm>
-            <a:off x="731520" y="4544568"/>
-            <a:ext cx="5029200" cy="1517904"/>
+            <a:off x="731520" y="4316000"/>
+            <a:ext cx="5029200" cy="1746000"/>
           </a:xfrm>
           <a:prstGeom prst="rect">
             <a:avLst/>
@@ -3997,7 +2880,7 @@
               <a:buNone/>
             </a:pPr>
             <a:r>
-              <a:rPr lang="en-US" sz="1350" dirty="0">
+              <a:rPr lang="en-US" sz="1600" dirty="0">
                 <a:solidFill>
                   <a:srgbClr val="26303F"/>
                 </a:solidFill>
@@ -4005,7 +2888,7 @@
                 <a:ea typeface="Calibri" pitchFamily="34" charset="-122"/>
                 <a:cs typeface="Calibri" pitchFamily="34" charset="-120"/>
               </a:rPr>
-              <a:t>Impact 2, urgency 3 and a premium customer give 13.3 + 23.3 + 7.5 + 3.3 = 47.5 (P3) after one day.</a:t>
+              <a:t>Impact 2, urgency 3, premium customer: 47.5 (P3) after one day.</a:t>
             </a:r>
             <a:endParaRPr lang="en-US" sz="1350" dirty="0"/>
           </a:p>
@@ -4017,7 +2900,7 @@
               <a:buNone/>
             </a:pPr>
             <a:r>
-              <a:rPr lang="en-US" sz="1350" dirty="0">
+              <a:rPr lang="en-US" sz="1600" dirty="0">
                 <a:solidFill>
                   <a:srgbClr val="26303F"/>
                 </a:solidFill>
@@ -4025,7 +2908,7 @@
                 <a:ea typeface="Calibri" pitchFamily="34" charset="-122"/>
                 <a:cs typeface="Calibri" pitchFamily="34" charset="-120"/>
               </a:rPr>
-              <a:t>After three days the same ticket scores 54.2 and rises to P2. A manager can always set the priority by hand.</a:t>
+              <a:t>After three days it scores 54.2 and rises to P2.</a:t>
             </a:r>
             <a:endParaRPr lang="en-US" sz="1350" dirty="0"/>
           </a:p>
@@ -4087,7 +2970,7 @@
                 <a:ea typeface="Georgia" pitchFamily="34" charset="-122"/>
                 <a:cs typeface="Georgia" pitchFamily="34" charset="-120"/>
               </a:rPr>
-              <a:t>Least-loaded eligible agent</a:t>
+              <a:t>Agent assignment</a:t>
             </a:r>
             <a:endParaRPr lang="en-US" sz="1800" dirty="0"/>
           </a:p>
@@ -4119,13 +3002,13 @@
                 <a:spcPct val="105000"/>
               </a:lnSpc>
               <a:spcAft>
-                <a:spcPts val="700"/>
+                <a:spcPts val="1400"/>
               </a:spcAft>
               <a:buSzPct val="100000"/>
               <a:buChar char="•"/>
             </a:pPr>
             <a:r>
-              <a:rPr lang="en-US" sz="1400" dirty="0">
+              <a:rPr lang="en-US" sz="1800" dirty="0">
                 <a:solidFill>
                   <a:srgbClr val="26303F"/>
                 </a:solidFill>
@@ -4133,7 +3016,7 @@
                 <a:ea typeface="Calibri" pitchFamily="34" charset="-122"/>
                 <a:cs typeface="Calibri" pitchFamily="34" charset="-120"/>
               </a:rPr>
-              <a:t>An agent is eligible when available, on shift, holding every skill the category needs, in the ticket's team and below capacity.</a:t>
+              <a:t>Eligible: available, on shift, has the needed skills, in the team, below capacity.</a:t>
             </a:r>
             <a:endParaRPr lang="en-US" sz="1400" dirty="0"/>
           </a:p>
@@ -4143,13 +3026,13 @@
                 <a:spcPct val="105000"/>
               </a:lnSpc>
               <a:spcAft>
-                <a:spcPts val="700"/>
+                <a:spcPts val="1400"/>
               </a:spcAft>
               <a:buSzPct val="100000"/>
               <a:buChar char="•"/>
             </a:pPr>
             <a:r>
-              <a:rPr lang="en-US" sz="1400" dirty="0">
+              <a:rPr lang="en-US" sz="1800" dirty="0">
                 <a:solidFill>
                   <a:srgbClr val="26303F"/>
                 </a:solidFill>
@@ -4157,7 +3040,7 @@
                 <a:ea typeface="Calibri" pitchFamily="34" charset="-122"/>
                 <a:cs typeface="Calibri" pitchFamily="34" charset="-120"/>
               </a:rPr>
-              <a:t>Eligible agents are ordered by open tickets per unit of capacity; a tie goes to the one assigned least recently.</a:t>
+              <a:t>Lowest load wins (open tickets ÷ capacity); a tie goes to the least recently assigned.</a:t>
             </a:r>
             <a:endParaRPr lang="en-US" sz="1400" dirty="0"/>
           </a:p>
@@ -4167,13 +3050,13 @@
                 <a:spcPct val="105000"/>
               </a:lnSpc>
               <a:spcAft>
-                <a:spcPts val="700"/>
+                <a:spcPts val="1400"/>
               </a:spcAft>
               <a:buSzPct val="100000"/>
               <a:buChar char="•"/>
             </a:pPr>
             <a:r>
-              <a:rPr lang="en-US" sz="1400" dirty="0">
+              <a:rPr lang="en-US" sz="1800" dirty="0">
                 <a:solidFill>
                   <a:srgbClr val="26303F"/>
                 </a:solidFill>
@@ -4181,23 +3064,45 @@
                 <a:ea typeface="Calibri" pitchFamily="34" charset="-122"/>
                 <a:cs typeface="Calibri" pitchFamily="34" charset="-120"/>
               </a:rPr>
-              <a:t>Agents left out are listed with the rule they failed. If nobody is eligible, managers are notified.</a:t>
+              <a:t>Agents left out are shown with the rule they failed.</a:t>
             </a:r>
             <a:endParaRPr lang="en-US" sz="1400" dirty="0"/>
           </a:p>
+        </p:txBody>
+      </p:sp>
+      <p:sp>
+        <p:nvSpPr>
+          <p:cNvPr id="1000" name="Text 14"/>
+          <p:cNvSpPr/>
+          <p:nvPr/>
+        </p:nvSpPr>
+        <p:spPr>
+          <a:xfrm>
+            <a:off x="548640" y="1783080"/>
+            <a:ext cx="5394960" cy="2560320"/>
+          </a:xfrm>
+          <a:prstGeom prst="rect">
+            <a:avLst/>
+          </a:prstGeom>
+          <a:noFill/>
+          <a:ln/>
+        </p:spPr>
+        <p:txBody>
+          <a:bodyPr wrap="square" lIns="25400" tIns="25400" rIns="25400" bIns="25400" rtlCol="0" anchor="t"/>
+          <a:lstStyle/>
           <a:p>
             <a:pPr marL="190500" indent="-190500">
               <a:lnSpc>
                 <a:spcPct val="105000"/>
               </a:lnSpc>
               <a:spcAft>
-                <a:spcPts val="700"/>
+                <a:spcPts val="1400"/>
               </a:spcAft>
               <a:buSzPct val="100000"/>
               <a:buChar char="•"/>
             </a:pPr>
             <a:r>
-              <a:rPr lang="en-US" sz="1400" dirty="0">
+              <a:rPr lang="en-US" sz="1800" dirty="0">
                 <a:solidFill>
                   <a:srgbClr val="26303F"/>
                 </a:solidFill>
@@ -4205,7 +3110,55 @@
                 <a:ea typeface="Calibri" pitchFamily="34" charset="-122"/>
                 <a:cs typeface="Calibri" pitchFamily="34" charset="-120"/>
               </a:rPr>
-              <a:t>Cost: O(A log A) for A agents.</a:t>
+              <a:t>Weighted sum of impact, urgency, customer tier and waiting time, each scaled to 0–1.</a:t>
+            </a:r>
+            <a:endParaRPr lang="en-US" sz="1400" dirty="0"/>
+          </a:p>
+          <a:p>
+            <a:pPr marL="190500" indent="-190500">
+              <a:lnSpc>
+                <a:spcPct val="105000"/>
+              </a:lnSpc>
+              <a:spcAft>
+                <a:spcPts val="1400"/>
+              </a:spcAft>
+              <a:buSzPct val="100000"/>
+              <a:buChar char="•"/>
+            </a:pPr>
+            <a:r>
+              <a:rPr lang="en-US" sz="1800" dirty="0">
+                <a:solidFill>
+                  <a:srgbClr val="26303F"/>
+                </a:solidFill>
+                <a:latin typeface="Calibri" pitchFamily="34" charset="0"/>
+                <a:ea typeface="Calibri" pitchFamily="34" charset="-122"/>
+                <a:cs typeface="Calibri" pitchFamily="34" charset="-120"/>
+              </a:rPr>
+              <a:t>score = 100 × Σ (weight × value), weights 0.40, 0.35, 0.15, 0.10.</a:t>
+            </a:r>
+            <a:endParaRPr lang="en-US" sz="1400" dirty="0"/>
+          </a:p>
+          <a:p>
+            <a:pPr marL="190500" indent="-190500">
+              <a:lnSpc>
+                <a:spcPct val="105000"/>
+              </a:lnSpc>
+              <a:spcAft>
+                <a:spcPts val="1400"/>
+              </a:spcAft>
+              <a:buSzPct val="100000"/>
+              <a:buChar char="•"/>
+            </a:pPr>
+            <a:r>
+              <a:rPr lang="en-US" sz="1800" dirty="0">
+                <a:solidFill>
+                  <a:srgbClr val="26303F"/>
+                </a:solidFill>
+                <a:latin typeface="Calibri" pitchFamily="34" charset="0"/>
+                <a:ea typeface="Calibri" pitchFamily="34" charset="-122"/>
+                <a:cs typeface="Calibri" pitchFamily="34" charset="-120"/>
+              </a:rPr>
+              <a:t>P1 from 75, P2 from 50, P3 from 25, otherwise P4.</a:t>
             </a:r>
             <a:endParaRPr lang="en-US" sz="1400" dirty="0"/>
           </a:p>
@@ -4219,8 +3172,8 @@
         </p:nvSpPr>
         <p:spPr>
           <a:xfrm>
-            <a:off x="6583680" y="4434840"/>
-            <a:ext cx="5056632" cy="1737360"/>
+            <a:off x="6583680" y="4206240"/>
+            <a:ext cx="5056632" cy="1965960"/>
           </a:xfrm>
           <a:prstGeom prst="rect">
             <a:avLst/>
@@ -4244,8 +3197,8 @@
         </p:nvSpPr>
         <p:spPr>
           <a:xfrm>
-            <a:off x="6766560" y="4544568"/>
-            <a:ext cx="4690872" cy="1517904"/>
+            <a:off x="6766560" y="4316000"/>
+            <a:ext cx="4690872" cy="1746000"/>
           </a:xfrm>
           <a:prstGeom prst="rect">
             <a:avLst/>
@@ -4284,7 +3237,7 @@
               <a:buNone/>
             </a:pPr>
             <a:r>
-              <a:rPr lang="en-US" sz="1350" dirty="0">
+              <a:rPr lang="en-US" sz="1600" dirty="0">
                 <a:solidFill>
                   <a:srgbClr val="26303F"/>
                 </a:solidFill>
@@ -4292,7 +3245,7 @@
                 <a:ea typeface="Calibri" pitchFamily="34" charset="-122"/>
                 <a:cs typeface="Calibri" pitchFamily="34" charset="-120"/>
               </a:rPr>
-              <a:t>Asha and Chen each have 3 of 10 tickets (0.30); Bikram has 2 of 5 (0.40).</a:t>
+              <a:t>Asha and Chen have 3 of 10 (0.30), Bikram 2 of 5 (0.40).</a:t>
             </a:r>
             <a:endParaRPr lang="en-US" sz="1350" dirty="0"/>
           </a:p>
@@ -4304,7 +3257,7 @@
               <a:buNone/>
             </a:pPr>
             <a:r>
-              <a:rPr lang="en-US" sz="1350" dirty="0">
+              <a:rPr lang="en-US" sz="1600" dirty="0">
                 <a:solidFill>
                   <a:srgbClr val="26303F"/>
                 </a:solidFill>
@@ -4312,7 +3265,7 @@
                 <a:ea typeface="Calibri" pitchFamily="34" charset="-122"/>
                 <a:cs typeface="Calibri" pitchFamily="34" charset="-120"/>
               </a:rPr>
-              <a:t>Asha and Chen tie on load, and Chen was assigned earlier, so Chen receives the ticket.</a:t>
+              <a:t>Asha and Chen tie; Chen was assigned earlier, so Chen gets it.</a:t>
             </a:r>
             <a:endParaRPr lang="en-US" sz="1350" dirty="0"/>
           </a:p>
@@ -4383,7 +3336,7 @@
                 <a:ea typeface="Georgia" pitchFamily="34" charset="-122"/>
                 <a:cs typeface="Georgia" pitchFamily="34" charset="-120"/>
               </a:rPr>
-              <a:t>Duplicates, SLA Timers and History</a:t>
+              <a:t>Algorithms (2/2)</a:t>
             </a:r>
             <a:endParaRPr lang="en-US" sz="2800" dirty="0"/>
           </a:p>
@@ -4523,8 +3476,8 @@
         </p:nvSpPr>
         <p:spPr>
           <a:xfrm>
-            <a:off x="548640" y="1280160"/>
-            <a:ext cx="3547872" cy="384048"/>
+            <a:off x="548640" y="1325880"/>
+            <a:ext cx="5394960" cy="365760"/>
           </a:xfrm>
           <a:prstGeom prst="rect">
             <a:avLst/>
@@ -4533,14 +3486,14 @@
           <a:ln/>
         </p:spPr>
         <p:txBody>
-          <a:bodyPr wrap="square" lIns="0" tIns="0" rIns="0" bIns="0" rtlCol="0" anchor="b"/>
+          <a:bodyPr wrap="square" lIns="0" tIns="0" rIns="0" bIns="0" rtlCol="0" anchor="ctr"/>
           <a:lstStyle/>
           <a:p>
             <a:pPr indent="0" marL="0">
               <a:buNone/>
             </a:pPr>
             <a:r>
-              <a:rPr lang="en-US" sz="1700" dirty="0">
+              <a:rPr lang="en-US" sz="1800" dirty="0">
                 <a:solidFill>
                   <a:srgbClr val="14213D"/>
                 </a:solidFill>
@@ -4550,20 +3503,107 @@
               </a:rPr>
               <a:t>Duplicate detection</a:t>
             </a:r>
-            <a:endParaRPr lang="en-US" sz="1700" dirty="0"/>
+            <a:endParaRPr lang="en-US" sz="1800" dirty="0"/>
           </a:p>
         </p:txBody>
       </p:sp>
       <p:sp>
         <p:nvSpPr>
-          <p:cNvPr id="9" name="Shape 6"/>
+          <p:cNvPr id="11" name="Shape 7"/>
           <p:cNvSpPr/>
           <p:nvPr/>
         </p:nvSpPr>
         <p:spPr>
           <a:xfrm>
-            <a:off x="548640" y="1737360"/>
-            <a:ext cx="3547872" cy="0"/>
+            <a:off x="548640" y="4206240"/>
+            <a:ext cx="5394960" cy="1965960"/>
+          </a:xfrm>
+          <a:prstGeom prst="rect">
+            <a:avLst/>
+          </a:prstGeom>
+          <a:solidFill>
+            <a:srgbClr val="F4F6F9"/>
+          </a:solidFill>
+          <a:ln w="12700">
+            <a:solidFill>
+              <a:srgbClr val="F4F6F9"/>
+            </a:solidFill>
+            <a:prstDash val="solid"/>
+          </a:ln>
+        </p:spPr>
+      </p:sp>
+      <p:sp>
+        <p:nvSpPr>
+          <p:cNvPr id="12" name="Text 8"/>
+          <p:cNvSpPr/>
+          <p:nvPr/>
+        </p:nvSpPr>
+        <p:spPr>
+          <a:xfrm>
+            <a:off x="731520" y="4316000"/>
+            <a:ext cx="5029200" cy="1746000"/>
+          </a:xfrm>
+          <a:prstGeom prst="rect">
+            <a:avLst/>
+          </a:prstGeom>
+          <a:noFill/>
+          <a:ln/>
+        </p:spPr>
+        <p:txBody>
+          <a:bodyPr wrap="square" lIns="0" tIns="0" rIns="0" bIns="0" rtlCol="0" anchor="t"/>
+          <a:lstStyle/>
+          <a:p>
+            <a:pPr indent="0" marL="0">
+              <a:spcAft>
+                <a:spcPts val="500"/>
+              </a:spcAft>
+              <a:buNone/>
+            </a:pPr>
+            <a:r>
+              <a:rPr lang="en-US" sz="1450" dirty="0">
+                <a:solidFill>
+                  <a:srgbClr val="14213D"/>
+                </a:solidFill>
+                <a:latin typeface="Georgia" pitchFamily="34" charset="0"/>
+                <a:ea typeface="Georgia" pitchFamily="34" charset="-122"/>
+                <a:cs typeface="Georgia" pitchFamily="34" charset="-120"/>
+              </a:rPr>
+              <a:t>Example</a:t>
+            </a:r>
+            <a:endParaRPr lang="en-US" sz="1350" dirty="0"/>
+          </a:p>
+          <a:p>
+            <a:pPr indent="0" marL="0">
+              <a:spcAft>
+                <a:spcPts val="300"/>
+              </a:spcAft>
+              <a:buNone/>
+            </a:pPr>
+            <a:r>
+              <a:rPr lang="en-US" sz="1600" dirty="0">
+                <a:solidFill>
+                  <a:srgbClr val="26303F"/>
+                </a:solidFill>
+                <a:latin typeface="Calibri" pitchFamily="34" charset="0"/>
+                <a:ea typeface="Calibri" pitchFamily="34" charset="-122"/>
+                <a:cs typeface="Calibri" pitchFamily="34" charset="-120"/>
+              </a:rPr>
+              <a:t>"Cannot login after password reset" and "Login fails after resetting password" score 0.50.</a:t>
+            </a:r>
+            <a:endParaRPr lang="en-US" sz="1350" dirty="0"/>
+          </a:p>
+        </p:txBody>
+      </p:sp>
+      <p:sp>
+        <p:nvSpPr>
+          <p:cNvPr id="13" name="Shape 9"/>
+          <p:cNvSpPr/>
+          <p:nvPr/>
+        </p:nvSpPr>
+        <p:spPr>
+          <a:xfrm>
+            <a:off x="6263640" y="1371600"/>
+            <a:ext cx="0" cy="4800600"/>
           </a:xfrm>
           <a:prstGeom prst="line">
             <a:avLst/>
@@ -4579,14 +3619,53 @@
       </p:sp>
       <p:sp>
         <p:nvSpPr>
-          <p:cNvPr id="10" name="Text 7"/>
+          <p:cNvPr id="14" name="Text 10"/>
           <p:cNvSpPr/>
           <p:nvPr/>
         </p:nvSpPr>
         <p:spPr>
           <a:xfrm>
-            <a:off x="548640" y="1847088"/>
-            <a:ext cx="3547872" cy="4370832"/>
+            <a:off x="6583680" y="1325880"/>
+            <a:ext cx="5029200" cy="365760"/>
+          </a:xfrm>
+          <a:prstGeom prst="rect">
+            <a:avLst/>
+          </a:prstGeom>
+          <a:noFill/>
+          <a:ln/>
+        </p:spPr>
+        <p:txBody>
+          <a:bodyPr wrap="square" lIns="0" tIns="0" rIns="0" bIns="0" rtlCol="0" anchor="ctr"/>
+          <a:lstStyle/>
+          <a:p>
+            <a:pPr indent="0" marL="0">
+              <a:buNone/>
+            </a:pPr>
+            <a:r>
+              <a:rPr lang="en-US" sz="1800" dirty="0">
+                <a:solidFill>
+                  <a:srgbClr val="14213D"/>
+                </a:solidFill>
+                <a:latin typeface="Georgia" pitchFamily="34" charset="0"/>
+                <a:ea typeface="Georgia" pitchFamily="34" charset="-122"/>
+                <a:cs typeface="Georgia" pitchFamily="34" charset="-120"/>
+              </a:rPr>
+              <a:t>SLA timer</a:t>
+            </a:r>
+            <a:endParaRPr lang="en-US" sz="1800" dirty="0"/>
+          </a:p>
+        </p:txBody>
+      </p:sp>
+      <p:sp>
+        <p:nvSpPr>
+          <p:cNvPr id="15" name="Text 11"/>
+          <p:cNvSpPr/>
+          <p:nvPr/>
+        </p:nvSpPr>
+        <p:spPr>
+          <a:xfrm>
+            <a:off x="6583680" y="1783080"/>
+            <a:ext cx="5056632" cy="2560320"/>
           </a:xfrm>
           <a:prstGeom prst="rect">
             <a:avLst/>
@@ -4609,7 +3688,7 @@
               <a:buChar char="•"/>
             </a:pPr>
             <a:r>
-              <a:rPr lang="en-US" sz="1600" dirty="0">
+              <a:rPr lang="en-US" sz="1800" dirty="0">
                 <a:solidFill>
                   <a:srgbClr val="26303F"/>
                 </a:solidFill>
@@ -4617,9 +3696,9 @@
                 <a:ea typeface="Calibri" pitchFamily="34" charset="-122"/>
                 <a:cs typeface="Calibri" pitchFamily="34" charset="-120"/>
               </a:rPr>
-              <a:t>Each ticket becomes a set of words, without 117 common stop words and very short words.</a:t>
-            </a:r>
-            <a:endParaRPr lang="en-US" sz="1600" dirty="0"/>
+              <a:t>First-response and resolution timers, in all hours or working hours.</a:t>
+            </a:r>
+            <a:endParaRPr lang="en-US" sz="1400" dirty="0"/>
           </a:p>
           <a:p>
             <a:pPr marL="190500" indent="-190500">
@@ -4633,7 +3712,7 @@
               <a:buChar char="•"/>
             </a:pPr>
             <a:r>
-              <a:rPr lang="en-US" sz="1600" dirty="0">
+              <a:rPr lang="en-US" sz="1800" dirty="0">
                 <a:solidFill>
                   <a:srgbClr val="26303F"/>
                 </a:solidFill>
@@ -4641,9 +3720,9 @@
                 <a:ea typeface="Calibri" pitchFamily="34" charset="-122"/>
                 <a:cs typeface="Calibri" pitchFamily="34" charset="-120"/>
               </a:rPr>
-              <a:t>Two tickets are compared by Jaccard similarity: shared words ÷ all distinct words.</a:t>
-            </a:r>
-            <a:endParaRPr lang="en-US" sz="1600" dirty="0"/>
+              <a:t>Warning at 75 % of the target; breach recorded at the deadline.</a:t>
+            </a:r>
+            <a:endParaRPr lang="en-US" sz="1400" dirty="0"/>
           </a:p>
           <a:p>
             <a:pPr marL="190500" indent="-190500">
@@ -4657,7 +3736,7 @@
               <a:buChar char="•"/>
             </a:pPr>
             <a:r>
-              <a:rPr lang="en-US" sz="1600" dirty="0">
+              <a:rPr lang="en-US" sz="1800" dirty="0">
                 <a:solidFill>
                   <a:srgbClr val="26303F"/>
                 </a:solidFill>
@@ -4665,10 +3744,32 @@
                 <a:ea typeface="Calibri" pitchFamily="34" charset="-122"/>
                 <a:cs typeface="Calibri" pitchFamily="34" charset="-120"/>
               </a:rPr>
-              <a:t>Open tickets of the same workspace from the last 30 days scoring 0.35 or more are suggested, top five first.</a:t>
-            </a:r>
-            <a:endParaRPr lang="en-US" sz="1600" dirty="0"/>
-          </a:p>
+              <a:t>Paused while waiting for the customer; the deadline moves by the pause.</a:t>
+            </a:r>
+            <a:endParaRPr lang="en-US" sz="1400" dirty="0"/>
+          </a:p>
+        </p:txBody>
+      </p:sp>
+      <p:sp>
+        <p:nvSpPr>
+          <p:cNvPr id="1000" name="Text 14"/>
+          <p:cNvSpPr/>
+          <p:nvPr/>
+        </p:nvSpPr>
+        <p:spPr>
+          <a:xfrm>
+            <a:off x="548640" y="1783080"/>
+            <a:ext cx="5394960" cy="2560320"/>
+          </a:xfrm>
+          <a:prstGeom prst="rect">
+            <a:avLst/>
+          </a:prstGeom>
+          <a:noFill/>
+          <a:ln/>
+        </p:spPr>
+        <p:txBody>
+          <a:bodyPr wrap="square" lIns="25400" tIns="25400" rIns="25400" bIns="25400" rtlCol="0" anchor="t"/>
+          <a:lstStyle/>
           <a:p>
             <a:pPr marL="190500" indent="-190500">
               <a:lnSpc>
@@ -4681,7 +3782,7 @@
               <a:buChar char="•"/>
             </a:pPr>
             <a:r>
-              <a:rPr lang="en-US" sz="1600" dirty="0">
+              <a:rPr lang="en-US" sz="1800" dirty="0">
                 <a:solidFill>
                   <a:srgbClr val="26303F"/>
                 </a:solidFill>
@@ -4689,94 +3790,10 @@
                 <a:ea typeface="Calibri" pitchFamily="34" charset="-122"/>
                 <a:cs typeface="Calibri" pitchFamily="34" charset="-120"/>
               </a:rPr>
-              <a:t>"Cannot login after password reset" and "Login fails after resetting password" share half their words (0.50) and are suggested.</a:t>
-            </a:r>
-            <a:endParaRPr lang="en-US" sz="1600" dirty="0"/>
-          </a:p>
-        </p:txBody>
-      </p:sp>
-      <p:sp>
-        <p:nvSpPr>
-          <p:cNvPr id="11" name="Text 8"/>
-          <p:cNvSpPr/>
-          <p:nvPr/>
-        </p:nvSpPr>
-        <p:spPr>
-          <a:xfrm>
-            <a:off x="4325112" y="1280160"/>
-            <a:ext cx="3547872" cy="384048"/>
-          </a:xfrm>
-          <a:prstGeom prst="rect">
-            <a:avLst/>
-          </a:prstGeom>
-          <a:noFill/>
-          <a:ln/>
-        </p:spPr>
-        <p:txBody>
-          <a:bodyPr wrap="square" lIns="0" tIns="0" rIns="0" bIns="0" rtlCol="0" anchor="b"/>
-          <a:lstStyle/>
-          <a:p>
-            <a:pPr indent="0" marL="0">
-              <a:buNone/>
-            </a:pPr>
-            <a:r>
-              <a:rPr lang="en-US" sz="1700" dirty="0">
-                <a:solidFill>
-                  <a:srgbClr val="14213D"/>
-                </a:solidFill>
-                <a:latin typeface="Georgia" pitchFamily="34" charset="0"/>
-                <a:ea typeface="Georgia" pitchFamily="34" charset="-122"/>
-                <a:cs typeface="Georgia" pitchFamily="34" charset="-120"/>
-              </a:rPr>
-              <a:t>SLA timer</a:t>
-            </a:r>
-            <a:endParaRPr lang="en-US" sz="1700" dirty="0"/>
-          </a:p>
-        </p:txBody>
-      </p:sp>
-      <p:sp>
-        <p:nvSpPr>
-          <p:cNvPr id="12" name="Shape 9"/>
-          <p:cNvSpPr/>
-          <p:nvPr/>
-        </p:nvSpPr>
-        <p:spPr>
-          <a:xfrm>
-            <a:off x="4325112" y="1737360"/>
-            <a:ext cx="3547872" cy="0"/>
-          </a:xfrm>
-          <a:prstGeom prst="line">
-            <a:avLst/>
-          </a:prstGeom>
-          <a:noFill/>
-          <a:ln w="9525">
-            <a:solidFill>
-              <a:srgbClr val="D5DAE1"/>
-            </a:solidFill>
-            <a:prstDash val="solid"/>
-          </a:ln>
-        </p:spPr>
-      </p:sp>
-      <p:sp>
-        <p:nvSpPr>
-          <p:cNvPr id="13" name="Text 10"/>
-          <p:cNvSpPr/>
-          <p:nvPr/>
-        </p:nvSpPr>
-        <p:spPr>
-          <a:xfrm>
-            <a:off x="4325112" y="1847088"/>
-            <a:ext cx="3547872" cy="4370832"/>
-          </a:xfrm>
-          <a:prstGeom prst="rect">
-            <a:avLst/>
-          </a:prstGeom>
-          <a:noFill/>
-          <a:ln/>
-        </p:spPr>
-        <p:txBody>
-          <a:bodyPr wrap="square" lIns="25400" tIns="25400" rIns="25400" bIns="25400" rtlCol="0" anchor="t"/>
-          <a:lstStyle/>
+              <a:t>Each ticket becomes a set of words, without stop words.</a:t>
+            </a:r>
+            <a:endParaRPr lang="en-US" sz="1400" dirty="0"/>
+          </a:p>
           <a:p>
             <a:pPr marL="190500" indent="-190500">
               <a:lnSpc>
@@ -4789,7 +3806,7 @@
               <a:buChar char="•"/>
             </a:pPr>
             <a:r>
-              <a:rPr lang="en-US" sz="1600" dirty="0">
+              <a:rPr lang="en-US" sz="1800" dirty="0">
                 <a:solidFill>
                   <a:srgbClr val="26303F"/>
                 </a:solidFill>
@@ -4797,9 +3814,9 @@
                 <a:ea typeface="Calibri" pitchFamily="34" charset="-122"/>
                 <a:cs typeface="Calibri" pitchFamily="34" charset="-120"/>
               </a:rPr>
-              <a:t>Each ticket has a first-response and a resolution timer, counted in all hours or only working hours.</a:t>
-            </a:r>
-            <a:endParaRPr lang="en-US" sz="1600" dirty="0"/>
+              <a:t>Jaccard similarity: shared words ÷ all distinct words.</a:t>
+            </a:r>
+            <a:endParaRPr lang="en-US" sz="1400" dirty="0"/>
           </a:p>
           <a:p>
             <a:pPr marL="190500" indent="-190500">
@@ -4813,7 +3830,7 @@
               <a:buChar char="•"/>
             </a:pPr>
             <a:r>
-              <a:rPr lang="en-US" sz="1600" dirty="0">
+              <a:rPr lang="en-US" sz="1800" dirty="0">
                 <a:solidFill>
                   <a:srgbClr val="26303F"/>
                 </a:solidFill>
@@ -4821,44 +3838,83 @@
                 <a:ea typeface="Calibri" pitchFamily="34" charset="-122"/>
                 <a:cs typeface="Calibri" pitchFamily="34" charset="-120"/>
               </a:rPr>
-              <a:t>A warning is sent at 75 % of the target and a breach is recorded at the deadline, each only once.</a:t>
-            </a:r>
-            <a:endParaRPr lang="en-US" sz="1600" dirty="0"/>
-          </a:p>
-          <a:p>
-            <a:pPr marL="190500" indent="-190500">
-              <a:lnSpc>
-                <a:spcPct val="105000"/>
-              </a:lnSpc>
+              <a:t>Open tickets from the last 30 days scoring 0.35 or more are suggested.</a:t>
+            </a:r>
+            <a:endParaRPr lang="en-US" sz="1400" dirty="0"/>
+          </a:p>
+        </p:txBody>
+      </p:sp>
+      <p:sp>
+        <p:nvSpPr>
+          <p:cNvPr id="16" name="Shape 12"/>
+          <p:cNvSpPr/>
+          <p:nvPr/>
+        </p:nvSpPr>
+        <p:spPr>
+          <a:xfrm>
+            <a:off x="6583680" y="4206240"/>
+            <a:ext cx="5056632" cy="1965960"/>
+          </a:xfrm>
+          <a:prstGeom prst="rect">
+            <a:avLst/>
+          </a:prstGeom>
+          <a:solidFill>
+            <a:srgbClr val="F4F6F9"/>
+          </a:solidFill>
+          <a:ln w="12700">
+            <a:solidFill>
+              <a:srgbClr val="F4F6F9"/>
+            </a:solidFill>
+            <a:prstDash val="solid"/>
+          </a:ln>
+        </p:spPr>
+      </p:sp>
+      <p:sp>
+        <p:nvSpPr>
+          <p:cNvPr id="17" name="Text 13"/>
+          <p:cNvSpPr/>
+          <p:nvPr/>
+        </p:nvSpPr>
+        <p:spPr>
+          <a:xfrm>
+            <a:off x="6766560" y="4316000"/>
+            <a:ext cx="4690872" cy="1746000"/>
+          </a:xfrm>
+          <a:prstGeom prst="rect">
+            <a:avLst/>
+          </a:prstGeom>
+          <a:noFill/>
+          <a:ln/>
+        </p:spPr>
+        <p:txBody>
+          <a:bodyPr wrap="square" lIns="0" tIns="0" rIns="0" bIns="0" rtlCol="0" anchor="t"/>
+          <a:lstStyle/>
+          <a:p>
+            <a:pPr indent="0" marL="0">
               <a:spcAft>
-                <a:spcPts val="1400"/>
+                <a:spcPts val="500"/>
               </a:spcAft>
-              <a:buSzPct val="100000"/>
-              <a:buChar char="•"/>
+              <a:buNone/>
             </a:pPr>
             <a:r>
-              <a:rPr lang="en-US" sz="1600" dirty="0">
+              <a:rPr lang="en-US" sz="1450" dirty="0">
                 <a:solidFill>
-                  <a:srgbClr val="26303F"/>
+                  <a:srgbClr val="14213D"/>
                 </a:solidFill>
-                <a:latin typeface="Calibri" pitchFamily="34" charset="0"/>
-                <a:ea typeface="Calibri" pitchFamily="34" charset="-122"/>
-                <a:cs typeface="Calibri" pitchFamily="34" charset="-120"/>
+                <a:latin typeface="Georgia" pitchFamily="34" charset="0"/>
+                <a:ea typeface="Georgia" pitchFamily="34" charset="-122"/>
+                <a:cs typeface="Georgia" pitchFamily="34" charset="-120"/>
               </a:rPr>
-              <a:t>While a ticket waits for the customer the timer pauses, and the deadline moves by the time paused.</a:t>
-            </a:r>
-            <a:endParaRPr lang="en-US" sz="1600" dirty="0"/>
-          </a:p>
-          <a:p>
-            <a:pPr marL="190500" indent="-190500">
-              <a:lnSpc>
-                <a:spcPct val="105000"/>
-              </a:lnSpc>
+              <a:t>Example</a:t>
+            </a:r>
+            <a:endParaRPr lang="en-US" sz="1350" dirty="0"/>
+          </a:p>
+          <a:p>
+            <a:pPr indent="0" marL="0">
               <a:spcAft>
-                <a:spcPts val="1400"/>
+                <a:spcPts val="300"/>
               </a:spcAft>
-              <a:buSzPct val="100000"/>
-              <a:buChar char="•"/>
+              <a:buNone/>
             </a:pPr>
             <a:r>
               <a:rPr lang="en-US" sz="1600" dirty="0">
@@ -4871,187 +3927,7 @@
               </a:rPr>
               <a:t>An 8-hour target from 09:00, paused 10:00–12:00, ends at 19:00 instead of 17:00.</a:t>
             </a:r>
-            <a:endParaRPr lang="en-US" sz="1600" dirty="0"/>
-          </a:p>
-        </p:txBody>
-      </p:sp>
-      <p:sp>
-        <p:nvSpPr>
-          <p:cNvPr id="14" name="Text 11"/>
-          <p:cNvSpPr/>
-          <p:nvPr/>
-        </p:nvSpPr>
-        <p:spPr>
-          <a:xfrm>
-            <a:off x="8101584" y="1280160"/>
-            <a:ext cx="3547872" cy="384048"/>
-          </a:xfrm>
-          <a:prstGeom prst="rect">
-            <a:avLst/>
-          </a:prstGeom>
-          <a:noFill/>
-          <a:ln/>
-        </p:spPr>
-        <p:txBody>
-          <a:bodyPr wrap="square" lIns="0" tIns="0" rIns="0" bIns="0" rtlCol="0" anchor="b"/>
-          <a:lstStyle/>
-          <a:p>
-            <a:pPr indent="0" marL="0">
-              <a:buNone/>
-            </a:pPr>
-            <a:r>
-              <a:rPr lang="en-US" sz="1700" dirty="0">
-                <a:solidFill>
-                  <a:srgbClr val="14213D"/>
-                </a:solidFill>
-                <a:latin typeface="Georgia" pitchFamily="34" charset="0"/>
-                <a:ea typeface="Georgia" pitchFamily="34" charset="-122"/>
-                <a:cs typeface="Georgia" pitchFamily="34" charset="-120"/>
-              </a:rPr>
-              <a:t>History and time analysis</a:t>
-            </a:r>
-            <a:endParaRPr lang="en-US" sz="1700" dirty="0"/>
-          </a:p>
-        </p:txBody>
-      </p:sp>
-      <p:sp>
-        <p:nvSpPr>
-          <p:cNvPr id="15" name="Shape 12"/>
-          <p:cNvSpPr/>
-          <p:nvPr/>
-        </p:nvSpPr>
-        <p:spPr>
-          <a:xfrm>
-            <a:off x="8101584" y="1737360"/>
-            <a:ext cx="3547872" cy="0"/>
-          </a:xfrm>
-          <a:prstGeom prst="line">
-            <a:avLst/>
-          </a:prstGeom>
-          <a:noFill/>
-          <a:ln w="9525">
-            <a:solidFill>
-              <a:srgbClr val="D5DAE1"/>
-            </a:solidFill>
-            <a:prstDash val="solid"/>
-          </a:ln>
-        </p:spPr>
-      </p:sp>
-      <p:sp>
-        <p:nvSpPr>
-          <p:cNvPr id="16" name="Text 13"/>
-          <p:cNvSpPr/>
-          <p:nvPr/>
-        </p:nvSpPr>
-        <p:spPr>
-          <a:xfrm>
-            <a:off x="8101584" y="1847088"/>
-            <a:ext cx="3547872" cy="4370832"/>
-          </a:xfrm>
-          <a:prstGeom prst="rect">
-            <a:avLst/>
-          </a:prstGeom>
-          <a:noFill/>
-          <a:ln/>
-        </p:spPr>
-        <p:txBody>
-          <a:bodyPr wrap="square" lIns="25400" tIns="25400" rIns="25400" bIns="25400" rtlCol="0" anchor="t"/>
-          <a:lstStyle/>
-          <a:p>
-            <a:pPr marL="190500" indent="-190500">
-              <a:lnSpc>
-                <a:spcPct val="105000"/>
-              </a:lnSpc>
-              <a:spcAft>
-                <a:spcPts val="1400"/>
-              </a:spcAft>
-              <a:buSzPct val="100000"/>
-              <a:buChar char="•"/>
-            </a:pPr>
-            <a:r>
-              <a:rPr lang="en-US" sz="1600" dirty="0">
-                <a:solidFill>
-                  <a:srgbClr val="26303F"/>
-                </a:solidFill>
-                <a:latin typeface="Calibri" pitchFamily="34" charset="0"/>
-                <a:ea typeface="Calibri" pitchFamily="34" charset="-122"/>
-                <a:cs typeface="Calibri" pitchFamily="34" charset="-120"/>
-              </a:rPr>
-              <a:t>A database trigger records every change to the main tables with the old and new values.</a:t>
-            </a:r>
-            <a:endParaRPr lang="en-US" sz="1600" dirty="0"/>
-          </a:p>
-          <a:p>
-            <a:pPr marL="190500" indent="-190500">
-              <a:lnSpc>
-                <a:spcPct val="105000"/>
-              </a:lnSpc>
-              <a:spcAft>
-                <a:spcPts val="1400"/>
-              </a:spcAft>
-              <a:buSzPct val="100000"/>
-              <a:buChar char="•"/>
-            </a:pPr>
-            <a:r>
-              <a:rPr lang="en-US" sz="1600" dirty="0">
-                <a:solidFill>
-                  <a:srgbClr val="26303F"/>
-                </a:solidFill>
-                <a:latin typeface="Calibri" pitchFamily="34" charset="0"/>
-                <a:ea typeface="Calibri" pitchFamily="34" charset="-122"/>
-                <a:cs typeface="Calibri" pitchFamily="34" charset="-120"/>
-              </a:rPr>
-              <a:t>A record at any past moment is rebuilt by undoing, newest first, the changes made after it.</a:t>
-            </a:r>
-            <a:endParaRPr lang="en-US" sz="1600" dirty="0"/>
-          </a:p>
-          <a:p>
-            <a:pPr marL="190500" indent="-190500">
-              <a:lnSpc>
-                <a:spcPct val="105000"/>
-              </a:lnSpc>
-              <a:spcAft>
-                <a:spcPts val="1400"/>
-              </a:spcAft>
-              <a:buSzPct val="100000"/>
-              <a:buChar char="•"/>
-            </a:pPr>
-            <a:r>
-              <a:rPr lang="en-US" sz="1600" dirty="0">
-                <a:solidFill>
-                  <a:srgbClr val="26303F"/>
-                </a:solidFill>
-                <a:latin typeface="Calibri" pitchFamily="34" charset="0"/>
-                <a:ea typeface="Calibri" pitchFamily="34" charset="-122"/>
-                <a:cs typeface="Calibri" pitchFamily="34" charset="-120"/>
-              </a:rPr>
-              <a:t>Each ticket's changes form periods of constant status, agent and priority.</a:t>
-            </a:r>
-            <a:endParaRPr lang="en-US" sz="1600" dirty="0"/>
-          </a:p>
-          <a:p>
-            <a:pPr marL="190500" indent="-190500">
-              <a:lnSpc>
-                <a:spcPct val="105000"/>
-              </a:lnSpc>
-              <a:spcAft>
-                <a:spcPts val="1400"/>
-              </a:spcAft>
-              <a:buSzPct val="100000"/>
-              <a:buChar char="•"/>
-            </a:pPr>
-            <a:r>
-              <a:rPr lang="en-US" sz="1600" dirty="0">
-                <a:solidFill>
-                  <a:srgbClr val="26303F"/>
-                </a:solidFill>
-                <a:latin typeface="Calibri" pitchFamily="34" charset="0"/>
-                <a:ea typeface="Calibri" pitchFamily="34" charset="-122"/>
-                <a:cs typeface="Calibri" pitchFamily="34" charset="-120"/>
-              </a:rPr>
-              <a:t>From these periods come time in status, the backlog on any date and each agent's workload.</a:t>
-            </a:r>
-            <a:endParaRPr lang="en-US" sz="1600" dirty="0"/>
+            <a:endParaRPr lang="en-US" sz="1350" dirty="0"/>
           </a:p>
         </p:txBody>
       </p:sp>
@@ -6929,7 +5805,7 @@
       </p:sp>
       <p:sp>
         <p:nvSpPr>
-          <p:cNvPr id="13" name="Shape 8"/>
+          <p:cNvPr id="1000" name="Shape 8"/>
           <p:cNvSpPr/>
           <p:nvPr/>
         </p:nvSpPr>
@@ -12956,7 +11832,7 @@
       </p:sp>
       <p:sp>
         <p:nvSpPr>
-          <p:cNvPr id="14" name="Text 8"/>
+          <p:cNvPr id="1000" name="Text 8"/>
           <p:cNvSpPr/>
           <p:nvPr/>
         </p:nvSpPr>
@@ -14103,55 +12979,13 @@
       </p:sp>
       <p:sp>
         <p:nvSpPr>
-          <p:cNvPr id="8" name="Text 5"/>
-          <p:cNvSpPr/>
-          <p:nvPr/>
-        </p:nvSpPr>
-        <p:spPr>
-          <a:xfrm>
-            <a:off x="548640" y="1371600"/>
-            <a:ext cx="5760720" cy="1143000"/>
-          </a:xfrm>
-          <a:prstGeom prst="rect">
-            <a:avLst/>
-          </a:prstGeom>
-          <a:noFill/>
-          <a:ln/>
-        </p:spPr>
-        <p:txBody>
-          <a:bodyPr wrap="square" lIns="0" tIns="0" rIns="0" bIns="0" rtlCol="0" anchor="t"/>
-          <a:lstStyle/>
-          <a:p>
-            <a:pPr indent="0" marL="0">
-              <a:lnSpc>
-                <a:spcPct val="105000"/>
-              </a:lnSpc>
-              <a:buNone/>
-            </a:pPr>
-            <a:r>
-              <a:rPr lang="en-US" sz="1600" i="1" dirty="0">
-                <a:solidFill>
-                  <a:srgbClr val="66707F"/>
-                </a:solidFill>
-                <a:latin typeface="Calibri" pitchFamily="34" charset="0"/>
-                <a:ea typeface="Calibri" pitchFamily="34" charset="-122"/>
-                <a:cs typeface="Calibri" pitchFamily="34" charset="-120"/>
-              </a:rPr>
-              <a:t>Every organisation receives requests: a login that fails, an invoice that is wrong, a server that is down. A helpdesk turns them into tickets that can be prioritised, assigned, tracked against a promised response time and closed.</a:t>
-            </a:r>
-            <a:endParaRPr lang="en-US" sz="1600" dirty="0"/>
-          </a:p>
-        </p:txBody>
-      </p:sp>
-      <p:sp>
-        <p:nvSpPr>
           <p:cNvPr id="9" name="Text 6"/>
           <p:cNvSpPr/>
           <p:nvPr/>
         </p:nvSpPr>
         <p:spPr>
           <a:xfrm>
-            <a:off x="548640" y="2606040"/>
+            <a:off x="548640" y="2069402"/>
             <a:ext cx="5760720" cy="3657600"/>
           </a:xfrm>
           <a:prstGeom prst="rect">
@@ -15497,7 +14331,7 @@
               <a:buNone/>
             </a:pPr>
             <a:r>
-              <a:rPr lang="en-US" sz="1450" dirty="0">
+              <a:rPr lang="en-US" sz="1600" dirty="0">
                 <a:solidFill>
                   <a:srgbClr val="26303F"/>
                 </a:solidFill>
@@ -15505,7 +14339,7 @@
                 <a:ea typeface="Calibri" pitchFamily="34" charset="-122"/>
                 <a:cs typeface="Calibri" pitchFamily="34" charset="-120"/>
               </a:rPr>
-              <a:t>Design and implement a multi-tenant helpdesk in which each organisation's data is strictly isolated, and which runs on any virtual machine or on an organisation's own server.</a:t>
+              <a:t>Build a multi-tenant helpdesk with strictly isolated data per organisation.</a:t>
             </a:r>
             <a:endParaRPr lang="en-US" sz="1450" dirty="0"/>
           </a:p>
@@ -15578,7 +14412,7 @@
               <a:buNone/>
             </a:pPr>
             <a:r>
-              <a:rPr lang="en-US" sz="1450" dirty="0">
+              <a:rPr lang="en-US" sz="1600" dirty="0">
                 <a:solidFill>
                   <a:srgbClr val="26303F"/>
                 </a:solidFill>
@@ -15586,7 +14420,7 @@
                 <a:ea typeface="Calibri" pitchFamily="34" charset="-122"/>
                 <a:cs typeface="Calibri" pitchFamily="34" charset="-120"/>
               </a:rPr>
-              <a:t>Implement simple, explainable algorithms for priority scoring, agent assignment, duplicate ticket detection and SLA monitoring with working-hours calendars.</a:t>
+              <a:t>Implement explainable algorithms for priority, assignment, duplicates and SLA monitoring.</a:t>
             </a:r>
             <a:endParaRPr lang="en-US" sz="1450" dirty="0"/>
           </a:p>
@@ -15659,7 +14493,7 @@
               <a:buNone/>
             </a:pPr>
             <a:r>
-              <a:rPr lang="en-US" sz="1450" dirty="0">
+              <a:rPr lang="en-US" sz="1600" dirty="0">
                 <a:solidFill>
                   <a:srgbClr val="26303F"/>
                 </a:solidFill>
@@ -15667,7 +14501,7 @@
                 <a:ea typeface="Calibri" pitchFamily="34" charset="-122"/>
                 <a:cs typeface="Calibri" pitchFamily="34" charset="-120"/>
               </a:rPr>
-              <a:t>Provide the features needed for real use: the ticket lifecycle with replies and internal notes, a media library, email notifications and email-to-ticket, a dashboard, an audit trail, a REST API and signed webhooks.</a:t>
+              <a:t>Provide ticket lifecycle, email, media library, dashboard, REST API and webhooks.</a:t>
             </a:r>
             <a:endParaRPr lang="en-US" sz="1450" dirty="0"/>
           </a:p>
@@ -15740,7 +14574,7 @@
               <a:buNone/>
             </a:pPr>
             <a:r>
-              <a:rPr lang="en-US" sz="1450" dirty="0">
+              <a:rPr lang="en-US" sz="1600" dirty="0">
                 <a:solidFill>
                   <a:srgbClr val="26303F"/>
                 </a:solidFill>
@@ -15748,7 +14582,7 @@
                 <a:ea typeface="Calibri" pitchFamily="34" charset="-122"/>
                 <a:cs typeface="Calibri" pitchFamily="34" charset="-120"/>
               </a:rPr>
-              <a:t>Build a reporting module that records every change to the main records and shows any record as it was at a past moment.</a:t>
+              <a:t>Record every change and show any record as at a past moment.</a:t>
             </a:r>
             <a:endParaRPr lang="en-US" sz="1450" dirty="0"/>
           </a:p>
@@ -15842,13 +14676,13 @@
                 <a:spcPct val="105000"/>
               </a:lnSpc>
               <a:spcAft>
-                <a:spcPts val="300"/>
+                <a:spcPts val="1200"/>
               </a:spcAft>
               <a:buSzPct val="100000"/>
               <a:buChar char="•"/>
             </a:pPr>
             <a:r>
-              <a:rPr lang="en-US" sz="1400" dirty="0">
+              <a:rPr lang="en-US" sz="1600" dirty="0">
                 <a:solidFill>
                   <a:srgbClr val="26303F"/>
                 </a:solidFill>
@@ -15866,85 +14700,13 @@
                 <a:spcPct val="105000"/>
               </a:lnSpc>
               <a:spcAft>
-                <a:spcPts val="300"/>
+                <a:spcPts val="1200"/>
               </a:spcAft>
               <a:buSzPct val="100000"/>
               <a:buChar char="•"/>
             </a:pPr>
             <a:r>
-              <a:rPr lang="en-US" sz="1400" dirty="0">
-                <a:solidFill>
-                  <a:srgbClr val="26303F"/>
-                </a:solidFill>
-                <a:latin typeface="Calibri" pitchFamily="34" charset="0"/>
-                <a:ea typeface="Calibri" pitchFamily="34" charset="-122"/>
-                <a:cs typeface="Calibri" pitchFamily="34" charset="-120"/>
-              </a:rPr>
-              <a:t>Sign-in, invitations, roles and permissions in each workspace</a:t>
-            </a:r>
-            <a:endParaRPr lang="en-US" sz="1400" dirty="0"/>
-          </a:p>
-          <a:p>
-            <a:pPr marL="190500" indent="-190500">
-              <a:lnSpc>
-                <a:spcPct val="105000"/>
-              </a:lnSpc>
-              <a:spcAft>
-                <a:spcPts val="300"/>
-              </a:spcAft>
-              <a:buSzPct val="100000"/>
-              <a:buChar char="•"/>
-            </a:pPr>
-            <a:r>
-              <a:rPr lang="en-US" sz="1400" dirty="0">
-                <a:solidFill>
-                  <a:srgbClr val="26303F"/>
-                </a:solidFill>
-                <a:latin typeface="Calibri" pitchFamily="34" charset="0"/>
-                <a:ea typeface="Calibri" pitchFamily="34" charset="-122"/>
-                <a:cs typeface="Calibri" pitchFamily="34" charset="-120"/>
-              </a:rPr>
-              <a:t>Contacts and organisations with customer tiers</a:t>
-            </a:r>
-            <a:endParaRPr lang="en-US" sz="1400" dirty="0"/>
-          </a:p>
-          <a:p>
-            <a:pPr marL="190500" indent="-190500">
-              <a:lnSpc>
-                <a:spcPct val="105000"/>
-              </a:lnSpc>
-              <a:spcAft>
-                <a:spcPts val="300"/>
-              </a:spcAft>
-              <a:buSzPct val="100000"/>
-              <a:buChar char="•"/>
-            </a:pPr>
-            <a:r>
-              <a:rPr lang="en-US" sz="1400" dirty="0">
-                <a:solidFill>
-                  <a:srgbClr val="26303F"/>
-                </a:solidFill>
-                <a:latin typeface="Calibri" pitchFamily="34" charset="0"/>
-                <a:ea typeface="Calibri" pitchFamily="34" charset="-122"/>
-                <a:cs typeface="Calibri" pitchFamily="34" charset="-120"/>
-              </a:rPr>
-              <a:t>Teams, skills, categories, agent capacity and shifts</a:t>
-            </a:r>
-            <a:endParaRPr lang="en-US" sz="1400" dirty="0"/>
-          </a:p>
-          <a:p>
-            <a:pPr marL="190500" indent="-190500">
-              <a:lnSpc>
-                <a:spcPct val="105000"/>
-              </a:lnSpc>
-              <a:spcAft>
-                <a:spcPts val="300"/>
-              </a:spcAft>
-              <a:buSzPct val="100000"/>
-              <a:buChar char="•"/>
-            </a:pPr>
-            <a:r>
-              <a:rPr lang="en-US" sz="1400" dirty="0">
+              <a:rPr lang="en-US" sz="1600" dirty="0">
                 <a:solidFill>
                   <a:srgbClr val="26303F"/>
                 </a:solidFill>
@@ -15962,13 +14724,13 @@
                 <a:spcPct val="105000"/>
               </a:lnSpc>
               <a:spcAft>
-                <a:spcPts val="300"/>
+                <a:spcPts val="1200"/>
               </a:spcAft>
               <a:buSzPct val="100000"/>
               <a:buChar char="•"/>
             </a:pPr>
             <a:r>
-              <a:rPr lang="en-US" sz="1400" dirty="0">
+              <a:rPr lang="en-US" sz="1600" dirty="0">
                 <a:solidFill>
                   <a:srgbClr val="26303F"/>
                 </a:solidFill>
@@ -15986,13 +14748,13 @@
                 <a:spcPct val="105000"/>
               </a:lnSpc>
               <a:spcAft>
-                <a:spcPts val="300"/>
+                <a:spcPts val="1200"/>
               </a:spcAft>
               <a:buSzPct val="100000"/>
               <a:buChar char="•"/>
             </a:pPr>
             <a:r>
-              <a:rPr lang="en-US" sz="1400" dirty="0">
+              <a:rPr lang="en-US" sz="1600" dirty="0">
                 <a:solidFill>
                   <a:srgbClr val="26303F"/>
                 </a:solidFill>
@@ -16010,37 +14772,13 @@
                 <a:spcPct val="105000"/>
               </a:lnSpc>
               <a:spcAft>
-                <a:spcPts val="300"/>
+                <a:spcPts val="1200"/>
               </a:spcAft>
               <a:buSzPct val="100000"/>
               <a:buChar char="•"/>
             </a:pPr>
             <a:r>
-              <a:rPr lang="en-US" sz="1400" dirty="0">
-                <a:solidFill>
-                  <a:srgbClr val="26303F"/>
-                </a:solidFill>
-                <a:latin typeface="Calibri" pitchFamily="34" charset="0"/>
-                <a:ea typeface="Calibri" pitchFamily="34" charset="-122"/>
-                <a:cs typeface="Calibri" pitchFamily="34" charset="-120"/>
-              </a:rPr>
-              <a:t>Notifications, email-to-ticket and a media library</a:t>
-            </a:r>
-            <a:endParaRPr lang="en-US" sz="1400" dirty="0"/>
-          </a:p>
-          <a:p>
-            <a:pPr marL="190500" indent="-190500">
-              <a:lnSpc>
-                <a:spcPct val="105000"/>
-              </a:lnSpc>
-              <a:spcAft>
-                <a:spcPts val="300"/>
-              </a:spcAft>
-              <a:buSzPct val="100000"/>
-              <a:buChar char="•"/>
-            </a:pPr>
-            <a:r>
-              <a:rPr lang="en-US" sz="1400" dirty="0">
+              <a:rPr lang="en-US" sz="1600" dirty="0">
                 <a:solidFill>
                   <a:srgbClr val="26303F"/>
                 </a:solidFill>
@@ -16049,54 +14787,6 @@
                 <a:cs typeface="Calibri" pitchFamily="34" charset="-120"/>
               </a:rPr>
               <a:t>Dashboard and reports with drill-down and past views</a:t>
-            </a:r>
-            <a:endParaRPr lang="en-US" sz="1400" dirty="0"/>
-          </a:p>
-          <a:p>
-            <a:pPr marL="190500" indent="-190500">
-              <a:lnSpc>
-                <a:spcPct val="105000"/>
-              </a:lnSpc>
-              <a:spcAft>
-                <a:spcPts val="300"/>
-              </a:spcAft>
-              <a:buSzPct val="100000"/>
-              <a:buChar char="•"/>
-            </a:pPr>
-            <a:r>
-              <a:rPr lang="en-US" sz="1400" dirty="0">
-                <a:solidFill>
-                  <a:srgbClr val="26303F"/>
-                </a:solidFill>
-                <a:latin typeface="Calibri" pitchFamily="34" charset="0"/>
-                <a:ea typeface="Calibri" pitchFamily="34" charset="-122"/>
-                <a:cs typeface="Calibri" pitchFamily="34" charset="-120"/>
-              </a:rPr>
-              <a:t>REST API with client credentials and signed webhooks</a:t>
-            </a:r>
-            <a:endParaRPr lang="en-US" sz="1400" dirty="0"/>
-          </a:p>
-          <a:p>
-            <a:pPr marL="190500" indent="-190500">
-              <a:lnSpc>
-                <a:spcPct val="105000"/>
-              </a:lnSpc>
-              <a:spcAft>
-                <a:spcPts val="300"/>
-              </a:spcAft>
-              <a:buSzPct val="100000"/>
-              <a:buChar char="•"/>
-            </a:pPr>
-            <a:r>
-              <a:rPr lang="en-US" sz="1400" dirty="0">
-                <a:solidFill>
-                  <a:srgbClr val="26303F"/>
-                </a:solidFill>
-                <a:latin typeface="Calibri" pitchFamily="34" charset="0"/>
-                <a:ea typeface="Calibri" pitchFamily="34" charset="-122"/>
-                <a:cs typeface="Calibri" pitchFamily="34" charset="-120"/>
-              </a:rPr>
-              <a:t>Light and dark themes; deployment with Docker on AWS</a:t>
             </a:r>
             <a:endParaRPr lang="en-US" sz="1400" dirty="0"/>
           </a:p>
@@ -16396,7 +15086,7 @@
         <p:spPr>
           <a:xfrm>
             <a:off x="6035040" y="1371600"/>
-            <a:ext cx="5605272" cy="960120"/>
+            <a:ext cx="5605272" cy="457200"/>
           </a:xfrm>
           <a:prstGeom prst="rect">
             <a:avLst/>
@@ -16423,7 +15113,7 @@
                 <a:ea typeface="Calibri" pitchFamily="34" charset="-122"/>
                 <a:cs typeface="Calibri" pitchFamily="34" charset="-120"/>
               </a:rPr>
-              <a:t>We followed the waterfall model. The requirements were known at the start and the project had a fixed period of three months, so each phase was finished and reviewed before the next one began.</a:t>
+              <a:t>We followed the waterfall model, one phase after another.</a:t>
             </a:r>
             <a:endParaRPr lang="en-US" sz="1500" dirty="0"/>
           </a:p>
@@ -16431,7 +15121,7 @@
       </p:sp>
       <p:graphicFrame>
         <p:nvGraphicFramePr>
-          <p:cNvPr id="6" name="Table 0"/>
+          <p:cNvPr id="1000" name="Table 0"/>
           <p:cNvGraphicFramePr>
             <a:graphicFrameLocks noGrp="1"/>
           </p:cNvGraphicFramePr>
@@ -16444,7 +15134,7 @@
           </p:nvPr>
         </p:nvGraphicFramePr>
         <p:xfrm>
-          <a:off x="6035040" y="2468880"/>
+          <a:off x="6035040" y="1965960"/>
           <a:ext cx="5605272" cy="914400"/>
         </p:xfrm>
         <a:graphic>
@@ -17704,7 +16394,7 @@
         </p:nvSpPr>
         <p:spPr>
           <a:xfrm>
-            <a:off x="6035040" y="5257800"/>
+            <a:off x="6035040" y="4754880"/>
             <a:ext cx="5605272" cy="822960"/>
           </a:xfrm>
           <a:prstGeom prst="rect">
@@ -17941,7 +16631,7 @@
         <p:spPr>
           <a:xfrm>
             <a:off x="548640" y="1371600"/>
-            <a:ext cx="4389120" cy="365760"/>
+            <a:ext cx="11091672" cy="365760"/>
           </a:xfrm>
           <a:prstGeom prst="rect">
             <a:avLst/>
@@ -17980,7 +16670,7 @@
         <p:spPr>
           <a:xfrm>
             <a:off x="548640" y="1828800"/>
-            <a:ext cx="4389120" cy="4389120"/>
+            <a:ext cx="11091672" cy="4389120"/>
           </a:xfrm>
           <a:prstGeom prst="rect">
             <a:avLst/>
@@ -17997,13 +16687,13 @@
                 <a:spcPct val="105000"/>
               </a:lnSpc>
               <a:spcAft>
-                <a:spcPts val="800"/>
+                <a:spcPts val="2200"/>
               </a:spcAft>
               <a:buSzPct val="100000"/>
               <a:buChar char="•"/>
             </a:pPr>
             <a:r>
-              <a:rPr lang="en-US" sz="1400" b="1" dirty="0">
+              <a:rPr lang="en-US" sz="2000" b="1" dirty="0">
                 <a:solidFill>
                   <a:srgbClr val="14213D"/>
                 </a:solidFill>
@@ -18014,7 +16704,7 @@
               <a:t>Priority</a:t>
             </a:r>
             <a:r>
-              <a:rPr lang="en-US" sz="1400" dirty="0">
+              <a:rPr lang="en-US" sz="2000" dirty="0">
                 <a:solidFill>
                   <a:srgbClr val="26303F"/>
                 </a:solidFill>
@@ -18032,13 +16722,13 @@
                 <a:spcPct val="105000"/>
               </a:lnSpc>
               <a:spcAft>
-                <a:spcPts val="800"/>
+                <a:spcPts val="2200"/>
               </a:spcAft>
               <a:buSzPct val="100000"/>
               <a:buChar char="•"/>
             </a:pPr>
             <a:r>
-              <a:rPr lang="en-US" sz="1400" b="1" dirty="0">
+              <a:rPr lang="en-US" sz="2000" b="1" dirty="0">
                 <a:solidFill>
                   <a:srgbClr val="14213D"/>
                 </a:solidFill>
@@ -18049,7 +16739,7 @@
               <a:t>Simple additive weighting</a:t>
             </a:r>
             <a:r>
-              <a:rPr lang="en-US" sz="1400" dirty="0">
+              <a:rPr lang="en-US" sz="2000" dirty="0">
                 <a:solidFill>
                   <a:srgbClr val="26303F"/>
                 </a:solidFill>
@@ -18067,13 +16757,13 @@
                 <a:spcPct val="105000"/>
               </a:lnSpc>
               <a:spcAft>
-                <a:spcPts val="800"/>
+                <a:spcPts val="2200"/>
               </a:spcAft>
               <a:buSzPct val="100000"/>
               <a:buChar char="•"/>
             </a:pPr>
             <a:r>
-              <a:rPr lang="en-US" sz="1400" b="1" dirty="0">
+              <a:rPr lang="en-US" sz="2000" b="1" dirty="0">
                 <a:solidFill>
                   <a:srgbClr val="14213D"/>
                 </a:solidFill>
@@ -18084,7 +16774,7 @@
               <a:t>Least-loaded routing</a:t>
             </a:r>
             <a:r>
-              <a:rPr lang="en-US" sz="1400" dirty="0">
+              <a:rPr lang="en-US" sz="2000" dirty="0">
                 <a:solidFill>
                   <a:srgbClr val="26303F"/>
                 </a:solidFill>
@@ -18102,13 +16792,13 @@
                 <a:spcPct val="105000"/>
               </a:lnSpc>
               <a:spcAft>
-                <a:spcPts val="800"/>
+                <a:spcPts val="2200"/>
               </a:spcAft>
               <a:buSzPct val="100000"/>
               <a:buChar char="•"/>
             </a:pPr>
             <a:r>
-              <a:rPr lang="en-US" sz="1400" b="1" dirty="0">
+              <a:rPr lang="en-US" sz="2000" b="1" dirty="0">
                 <a:solidFill>
                   <a:srgbClr val="14213D"/>
                 </a:solidFill>
@@ -18119,7 +16809,7 @@
               <a:t>Jaccard similarity</a:t>
             </a:r>
             <a:r>
-              <a:rPr lang="en-US" sz="1400" dirty="0">
+              <a:rPr lang="en-US" sz="2000" dirty="0">
                 <a:solidFill>
                   <a:srgbClr val="26303F"/>
                 </a:solidFill>
@@ -18137,13 +16827,13 @@
                 <a:spcPct val="105000"/>
               </a:lnSpc>
               <a:spcAft>
-                <a:spcPts val="800"/>
+                <a:spcPts val="2200"/>
               </a:spcAft>
               <a:buSzPct val="100000"/>
               <a:buChar char="•"/>
             </a:pPr>
             <a:r>
-              <a:rPr lang="en-US" sz="1400" b="1" dirty="0">
+              <a:rPr lang="en-US" sz="2000" b="1" dirty="0">
                 <a:solidFill>
                   <a:srgbClr val="14213D"/>
                 </a:solidFill>
@@ -18154,7 +16844,7 @@
               <a:t>Row-level security</a:t>
             </a:r>
             <a:r>
-              <a:rPr lang="en-US" sz="1400" dirty="0">
+              <a:rPr lang="en-US" sz="2000" dirty="0">
                 <a:solidFill>
                   <a:srgbClr val="26303F"/>
                 </a:solidFill>
@@ -18165,1864 +16855,6 @@
               <a:t> in PostgreSQL lets the database itself keep tenants apart.</a:t>
             </a:r>
             <a:endParaRPr lang="en-US" sz="1400" dirty="0"/>
-          </a:p>
-        </p:txBody>
-      </p:sp>
-      <p:sp>
-        <p:nvSpPr>
-          <p:cNvPr id="10" name="Shape 7"/>
-          <p:cNvSpPr/>
-          <p:nvPr/>
-        </p:nvSpPr>
-        <p:spPr>
-          <a:xfrm>
-            <a:off x="5212080" y="1417320"/>
-            <a:ext cx="0" cy="4754880"/>
-          </a:xfrm>
-          <a:prstGeom prst="line">
-            <a:avLst/>
-          </a:prstGeom>
-          <a:noFill/>
-          <a:ln w="9525">
-            <a:solidFill>
-              <a:srgbClr val="D5DAE1"/>
-            </a:solidFill>
-            <a:prstDash val="solid"/>
-          </a:ln>
-        </p:spPr>
-      </p:sp>
-      <p:sp>
-        <p:nvSpPr>
-          <p:cNvPr id="11" name="Text 8"/>
-          <p:cNvSpPr/>
-          <p:nvPr/>
-        </p:nvSpPr>
-        <p:spPr>
-          <a:xfrm>
-            <a:off x="5486400" y="1371600"/>
-            <a:ext cx="6126480" cy="365760"/>
-          </a:xfrm>
-          <a:prstGeom prst="rect">
-            <a:avLst/>
-          </a:prstGeom>
-          <a:noFill/>
-          <a:ln/>
-        </p:spPr>
-        <p:txBody>
-          <a:bodyPr wrap="square" lIns="0" tIns="0" rIns="0" bIns="0" rtlCol="0" anchor="ctr"/>
-          <a:lstStyle/>
-          <a:p>
-            <a:pPr indent="0" marL="0">
-              <a:buNone/>
-            </a:pPr>
-            <a:r>
-              <a:rPr lang="en-US" sz="1700" dirty="0">
-                <a:solidFill>
-                  <a:srgbClr val="14213D"/>
-                </a:solidFill>
-                <a:latin typeface="Georgia" pitchFamily="34" charset="0"/>
-                <a:ea typeface="Georgia" pitchFamily="34" charset="-122"/>
-                <a:cs typeface="Georgia" pitchFamily="34" charset="-120"/>
-              </a:rPr>
-              <a:t>Existing open-source helpdesks</a:t>
-            </a:r>
-            <a:endParaRPr lang="en-US" sz="1700" dirty="0"/>
-          </a:p>
-        </p:txBody>
-      </p:sp>
-      <p:graphicFrame>
-        <p:nvGraphicFramePr>
-          <p:cNvPr id="7" name="Table 0"/>
-          <p:cNvGraphicFramePr>
-            <a:graphicFrameLocks noGrp="1"/>
-          </p:cNvGraphicFramePr>
-          <p:nvPr>
-            <p:extLst>
-              <p:ext uri="{D42A27DB-BD31-4B8C-83A1-F6EECF244321}">
-                <p14:modId xmlns:p14="http://schemas.microsoft.com/office/powerpoint/2010/main" val="1579011935"/>
-              </p:ext>
-            </p:extLst>
-          </p:nvPr>
-        </p:nvGraphicFramePr>
-        <p:xfrm>
-          <a:off x="5486400" y="1828800"/>
-          <a:ext cx="6153912" cy="914400"/>
-        </p:xfrm>
-        <a:graphic>
-          <a:graphicData uri="http://schemas.openxmlformats.org/drawingml/2006/table">
-            <a:tbl>
-              <a:tblPr/>
-              <a:tblGrid>
-                <a:gridCol w="1005840"/>
-                <a:gridCol w="1371600"/>
-                <a:gridCol w="1508760"/>
-                <a:gridCol w="987552"/>
-                <a:gridCol w="1280160"/>
-              </a:tblGrid>
-              <a:tr h="475488">
-                <a:tc>
-                  <a:txBody>
-                    <a:bodyPr/>
-                    <a:lstStyle/>
-                    <a:p>
-                      <a:pPr indent="0" marL="0">
-                        <a:buNone/>
-                      </a:pPr>
-                      <a:r>
-                        <a:rPr lang="en-US" sz="1200" b="1" dirty="0">
-                          <a:solidFill>
-                            <a:srgbClr val="FFFFFF"/>
-                          </a:solidFill>
-                          <a:latin typeface="Calibri" pitchFamily="34" charset="0"/>
-                          <a:ea typeface="Calibri" pitchFamily="34" charset="-122"/>
-                          <a:cs typeface="Calibri" pitchFamily="34" charset="-120"/>
-                        </a:rPr>
-                        <a:t>System</a:t>
-                      </a:r>
-                      <a:endParaRPr lang="en-US" sz="1200" dirty="0">
-                        <a:latin typeface="Calibri" charset="0"/>
-                        <a:ea typeface="Calibri" charset="0"/>
-                        <a:cs typeface="Calibri" charset="0"/>
-                      </a:endParaRPr>
-                    </a:p>
-                  </a:txBody>
-                  <a:tcPr marL="76200" marR="76200" marT="25400" marB="25400" anchor="ctr">
-                    <a:lnL w="9525" cap="flat" cmpd="sng" algn="ctr">
-                      <a:solidFill>
-                        <a:srgbClr val="D5DAE1"/>
-                      </a:solidFill>
-                      <a:prstDash val="solid"/>
-                      <a:round/>
-                      <a:headEnd type="none" w="med" len="med"/>
-                      <a:tailEnd type="none" w="med" len="med"/>
-                    </a:lnL>
-                    <a:lnR w="9525" cap="flat" cmpd="sng" algn="ctr">
-                      <a:solidFill>
-                        <a:srgbClr val="D5DAE1"/>
-                      </a:solidFill>
-                      <a:prstDash val="solid"/>
-                      <a:round/>
-                      <a:headEnd type="none" w="med" len="med"/>
-                      <a:tailEnd type="none" w="med" len="med"/>
-                    </a:lnR>
-                    <a:lnT w="9525" cap="flat" cmpd="sng" algn="ctr">
-                      <a:solidFill>
-                        <a:srgbClr val="D5DAE1"/>
-                      </a:solidFill>
-                      <a:prstDash val="solid"/>
-                      <a:round/>
-                      <a:headEnd type="none" w="med" len="med"/>
-                      <a:tailEnd type="none" w="med" len="med"/>
-                    </a:lnT>
-                    <a:lnB w="9525" cap="flat" cmpd="sng" algn="ctr">
-                      <a:solidFill>
-                        <a:srgbClr val="D5DAE1"/>
-                      </a:solidFill>
-                      <a:prstDash val="solid"/>
-                      <a:round/>
-                      <a:headEnd type="none" w="med" len="med"/>
-                      <a:tailEnd type="none" w="med" len="med"/>
-                    </a:lnB>
-                    <a:solidFill>
-                      <a:srgbClr val="14213D"/>
-                    </a:solidFill>
-                  </a:tcPr>
-                </a:tc>
-                <a:tc>
-                  <a:txBody>
-                    <a:bodyPr/>
-                    <a:lstStyle/>
-                    <a:p>
-                      <a:pPr indent="0" marL="0">
-                        <a:buNone/>
-                      </a:pPr>
-                      <a:r>
-                        <a:rPr lang="en-US" sz="1200" b="1" dirty="0">
-                          <a:solidFill>
-                            <a:srgbClr val="FFFFFF"/>
-                          </a:solidFill>
-                          <a:latin typeface="Calibri" pitchFamily="34" charset="0"/>
-                          <a:ea typeface="Calibri" pitchFamily="34" charset="-122"/>
-                          <a:cs typeface="Calibri" pitchFamily="34" charset="-120"/>
-                        </a:rPr>
-                        <a:t>Priority</a:t>
-                      </a:r>
-                      <a:endParaRPr lang="en-US" sz="1200" dirty="0">
-                        <a:latin typeface="Calibri" charset="0"/>
-                        <a:ea typeface="Calibri" charset="0"/>
-                        <a:cs typeface="Calibri" charset="0"/>
-                      </a:endParaRPr>
-                    </a:p>
-                  </a:txBody>
-                  <a:tcPr marL="76200" marR="76200" marT="25400" marB="25400" anchor="ctr">
-                    <a:lnL w="9525" cap="flat" cmpd="sng" algn="ctr">
-                      <a:solidFill>
-                        <a:srgbClr val="D5DAE1"/>
-                      </a:solidFill>
-                      <a:prstDash val="solid"/>
-                      <a:round/>
-                      <a:headEnd type="none" w="med" len="med"/>
-                      <a:tailEnd type="none" w="med" len="med"/>
-                    </a:lnL>
-                    <a:lnR w="9525" cap="flat" cmpd="sng" algn="ctr">
-                      <a:solidFill>
-                        <a:srgbClr val="D5DAE1"/>
-                      </a:solidFill>
-                      <a:prstDash val="solid"/>
-                      <a:round/>
-                      <a:headEnd type="none" w="med" len="med"/>
-                      <a:tailEnd type="none" w="med" len="med"/>
-                    </a:lnR>
-                    <a:lnT w="9525" cap="flat" cmpd="sng" algn="ctr">
-                      <a:solidFill>
-                        <a:srgbClr val="D5DAE1"/>
-                      </a:solidFill>
-                      <a:prstDash val="solid"/>
-                      <a:round/>
-                      <a:headEnd type="none" w="med" len="med"/>
-                      <a:tailEnd type="none" w="med" len="med"/>
-                    </a:lnT>
-                    <a:lnB w="9525" cap="flat" cmpd="sng" algn="ctr">
-                      <a:solidFill>
-                        <a:srgbClr val="D5DAE1"/>
-                      </a:solidFill>
-                      <a:prstDash val="solid"/>
-                      <a:round/>
-                      <a:headEnd type="none" w="med" len="med"/>
-                      <a:tailEnd type="none" w="med" len="med"/>
-                    </a:lnB>
-                    <a:solidFill>
-                      <a:srgbClr val="14213D"/>
-                    </a:solidFill>
-                  </a:tcPr>
-                </a:tc>
-                <a:tc>
-                  <a:txBody>
-                    <a:bodyPr/>
-                    <a:lstStyle/>
-                    <a:p>
-                      <a:pPr indent="0" marL="0">
-                        <a:buNone/>
-                      </a:pPr>
-                      <a:r>
-                        <a:rPr lang="en-US" sz="1200" b="1" dirty="0">
-                          <a:solidFill>
-                            <a:srgbClr val="FFFFFF"/>
-                          </a:solidFill>
-                          <a:latin typeface="Calibri" pitchFamily="34" charset="0"/>
-                          <a:ea typeface="Calibri" pitchFamily="34" charset="-122"/>
-                          <a:cs typeface="Calibri" pitchFamily="34" charset="-120"/>
-                        </a:rPr>
-                        <a:t>Assignment</a:t>
-                      </a:r>
-                      <a:endParaRPr lang="en-US" sz="1200" dirty="0">
-                        <a:latin typeface="Calibri" charset="0"/>
-                        <a:ea typeface="Calibri" charset="0"/>
-                        <a:cs typeface="Calibri" charset="0"/>
-                      </a:endParaRPr>
-                    </a:p>
-                  </a:txBody>
-                  <a:tcPr marL="76200" marR="76200" marT="25400" marB="25400" anchor="ctr">
-                    <a:lnL w="9525" cap="flat" cmpd="sng" algn="ctr">
-                      <a:solidFill>
-                        <a:srgbClr val="D5DAE1"/>
-                      </a:solidFill>
-                      <a:prstDash val="solid"/>
-                      <a:round/>
-                      <a:headEnd type="none" w="med" len="med"/>
-                      <a:tailEnd type="none" w="med" len="med"/>
-                    </a:lnL>
-                    <a:lnR w="9525" cap="flat" cmpd="sng" algn="ctr">
-                      <a:solidFill>
-                        <a:srgbClr val="D5DAE1"/>
-                      </a:solidFill>
-                      <a:prstDash val="solid"/>
-                      <a:round/>
-                      <a:headEnd type="none" w="med" len="med"/>
-                      <a:tailEnd type="none" w="med" len="med"/>
-                    </a:lnR>
-                    <a:lnT w="9525" cap="flat" cmpd="sng" algn="ctr">
-                      <a:solidFill>
-                        <a:srgbClr val="D5DAE1"/>
-                      </a:solidFill>
-                      <a:prstDash val="solid"/>
-                      <a:round/>
-                      <a:headEnd type="none" w="med" len="med"/>
-                      <a:tailEnd type="none" w="med" len="med"/>
-                    </a:lnT>
-                    <a:lnB w="9525" cap="flat" cmpd="sng" algn="ctr">
-                      <a:solidFill>
-                        <a:srgbClr val="D5DAE1"/>
-                      </a:solidFill>
-                      <a:prstDash val="solid"/>
-                      <a:round/>
-                      <a:headEnd type="none" w="med" len="med"/>
-                      <a:tailEnd type="none" w="med" len="med"/>
-                    </a:lnB>
-                    <a:solidFill>
-                      <a:srgbClr val="14213D"/>
-                    </a:solidFill>
-                  </a:tcPr>
-                </a:tc>
-                <a:tc>
-                  <a:txBody>
-                    <a:bodyPr/>
-                    <a:lstStyle/>
-                    <a:p>
-                      <a:pPr indent="0" marL="0">
-                        <a:buNone/>
-                      </a:pPr>
-                      <a:r>
-                        <a:rPr lang="en-US" sz="1200" b="1" dirty="0">
-                          <a:solidFill>
-                            <a:srgbClr val="FFFFFF"/>
-                          </a:solidFill>
-                          <a:latin typeface="Calibri" pitchFamily="34" charset="0"/>
-                          <a:ea typeface="Calibri" pitchFamily="34" charset="-122"/>
-                          <a:cs typeface="Calibri" pitchFamily="34" charset="-120"/>
-                        </a:rPr>
-                        <a:t>Duplicates</a:t>
-                      </a:r>
-                      <a:endParaRPr lang="en-US" sz="1200" dirty="0">
-                        <a:latin typeface="Calibri" charset="0"/>
-                        <a:ea typeface="Calibri" charset="0"/>
-                        <a:cs typeface="Calibri" charset="0"/>
-                      </a:endParaRPr>
-                    </a:p>
-                  </a:txBody>
-                  <a:tcPr marL="76200" marR="76200" marT="25400" marB="25400" anchor="ctr">
-                    <a:lnL w="9525" cap="flat" cmpd="sng" algn="ctr">
-                      <a:solidFill>
-                        <a:srgbClr val="D5DAE1"/>
-                      </a:solidFill>
-                      <a:prstDash val="solid"/>
-                      <a:round/>
-                      <a:headEnd type="none" w="med" len="med"/>
-                      <a:tailEnd type="none" w="med" len="med"/>
-                    </a:lnL>
-                    <a:lnR w="9525" cap="flat" cmpd="sng" algn="ctr">
-                      <a:solidFill>
-                        <a:srgbClr val="D5DAE1"/>
-                      </a:solidFill>
-                      <a:prstDash val="solid"/>
-                      <a:round/>
-                      <a:headEnd type="none" w="med" len="med"/>
-                      <a:tailEnd type="none" w="med" len="med"/>
-                    </a:lnR>
-                    <a:lnT w="9525" cap="flat" cmpd="sng" algn="ctr">
-                      <a:solidFill>
-                        <a:srgbClr val="D5DAE1"/>
-                      </a:solidFill>
-                      <a:prstDash val="solid"/>
-                      <a:round/>
-                      <a:headEnd type="none" w="med" len="med"/>
-                      <a:tailEnd type="none" w="med" len="med"/>
-                    </a:lnT>
-                    <a:lnB w="9525" cap="flat" cmpd="sng" algn="ctr">
-                      <a:solidFill>
-                        <a:srgbClr val="D5DAE1"/>
-                      </a:solidFill>
-                      <a:prstDash val="solid"/>
-                      <a:round/>
-                      <a:headEnd type="none" w="med" len="med"/>
-                      <a:tailEnd type="none" w="med" len="med"/>
-                    </a:lnB>
-                    <a:solidFill>
-                      <a:srgbClr val="14213D"/>
-                    </a:solidFill>
-                  </a:tcPr>
-                </a:tc>
-                <a:tc>
-                  <a:txBody>
-                    <a:bodyPr/>
-                    <a:lstStyle/>
-                    <a:p>
-                      <a:pPr indent="0" marL="0">
-                        <a:buNone/>
-                      </a:pPr>
-                      <a:r>
-                        <a:rPr lang="en-US" sz="1200" b="1" dirty="0">
-                          <a:solidFill>
-                            <a:srgbClr val="FFFFFF"/>
-                          </a:solidFill>
-                          <a:latin typeface="Calibri" pitchFamily="34" charset="0"/>
-                          <a:ea typeface="Calibri" pitchFamily="34" charset="-122"/>
-                          <a:cs typeface="Calibri" pitchFamily="34" charset="-120"/>
-                        </a:rPr>
-                        <a:t>SLA</a:t>
-                      </a:r>
-                      <a:endParaRPr lang="en-US" sz="1200" dirty="0">
-                        <a:latin typeface="Calibri" charset="0"/>
-                        <a:ea typeface="Calibri" charset="0"/>
-                        <a:cs typeface="Calibri" charset="0"/>
-                      </a:endParaRPr>
-                    </a:p>
-                  </a:txBody>
-                  <a:tcPr marL="76200" marR="76200" marT="25400" marB="25400" anchor="ctr">
-                    <a:lnL w="9525" cap="flat" cmpd="sng" algn="ctr">
-                      <a:solidFill>
-                        <a:srgbClr val="D5DAE1"/>
-                      </a:solidFill>
-                      <a:prstDash val="solid"/>
-                      <a:round/>
-                      <a:headEnd type="none" w="med" len="med"/>
-                      <a:tailEnd type="none" w="med" len="med"/>
-                    </a:lnL>
-                    <a:lnR w="9525" cap="flat" cmpd="sng" algn="ctr">
-                      <a:solidFill>
-                        <a:srgbClr val="D5DAE1"/>
-                      </a:solidFill>
-                      <a:prstDash val="solid"/>
-                      <a:round/>
-                      <a:headEnd type="none" w="med" len="med"/>
-                      <a:tailEnd type="none" w="med" len="med"/>
-                    </a:lnR>
-                    <a:lnT w="9525" cap="flat" cmpd="sng" algn="ctr">
-                      <a:solidFill>
-                        <a:srgbClr val="D5DAE1"/>
-                      </a:solidFill>
-                      <a:prstDash val="solid"/>
-                      <a:round/>
-                      <a:headEnd type="none" w="med" len="med"/>
-                      <a:tailEnd type="none" w="med" len="med"/>
-                    </a:lnT>
-                    <a:lnB w="9525" cap="flat" cmpd="sng" algn="ctr">
-                      <a:solidFill>
-                        <a:srgbClr val="D5DAE1"/>
-                      </a:solidFill>
-                      <a:prstDash val="solid"/>
-                      <a:round/>
-                      <a:headEnd type="none" w="med" len="med"/>
-                      <a:tailEnd type="none" w="med" len="med"/>
-                    </a:lnB>
-                    <a:solidFill>
-                      <a:srgbClr val="14213D"/>
-                    </a:solidFill>
-                  </a:tcPr>
-                </a:tc>
-              </a:tr>
-              <a:tr h="475488">
-                <a:tc>
-                  <a:txBody>
-                    <a:bodyPr/>
-                    <a:lstStyle/>
-                    <a:p>
-                      <a:pPr indent="0" marL="0">
-                        <a:buNone/>
-                      </a:pPr>
-                      <a:r>
-                        <a:rPr lang="en-US" sz="1200" dirty="0">
-                          <a:solidFill>
-                            <a:srgbClr val="26303F"/>
-                          </a:solidFill>
-                          <a:latin typeface="Calibri" pitchFamily="34" charset="0"/>
-                          <a:ea typeface="Calibri" pitchFamily="34" charset="-122"/>
-                          <a:cs typeface="Calibri" pitchFamily="34" charset="-120"/>
-                        </a:rPr>
-                        <a:t>osTicket</a:t>
-                      </a:r>
-                      <a:endParaRPr lang="en-US" sz="1200" dirty="0">
-                        <a:latin typeface="Calibri" charset="0"/>
-                        <a:ea typeface="Calibri" charset="0"/>
-                        <a:cs typeface="Calibri" charset="0"/>
-                      </a:endParaRPr>
-                    </a:p>
-                  </a:txBody>
-                  <a:tcPr marL="76200" marR="76200" marT="25400" marB="25400" anchor="ctr">
-                    <a:lnL w="9525" cap="flat" cmpd="sng" algn="ctr">
-                      <a:solidFill>
-                        <a:srgbClr val="D5DAE1"/>
-                      </a:solidFill>
-                      <a:prstDash val="solid"/>
-                      <a:round/>
-                      <a:headEnd type="none" w="med" len="med"/>
-                      <a:tailEnd type="none" w="med" len="med"/>
-                    </a:lnL>
-                    <a:lnR w="9525" cap="flat" cmpd="sng" algn="ctr">
-                      <a:solidFill>
-                        <a:srgbClr val="D5DAE1"/>
-                      </a:solidFill>
-                      <a:prstDash val="solid"/>
-                      <a:round/>
-                      <a:headEnd type="none" w="med" len="med"/>
-                      <a:tailEnd type="none" w="med" len="med"/>
-                    </a:lnR>
-                    <a:lnT w="9525" cap="flat" cmpd="sng" algn="ctr">
-                      <a:solidFill>
-                        <a:srgbClr val="D5DAE1"/>
-                      </a:solidFill>
-                      <a:prstDash val="solid"/>
-                      <a:round/>
-                      <a:headEnd type="none" w="med" len="med"/>
-                      <a:tailEnd type="none" w="med" len="med"/>
-                    </a:lnT>
-                    <a:lnB w="9525" cap="flat" cmpd="sng" algn="ctr">
-                      <a:solidFill>
-                        <a:srgbClr val="D5DAE1"/>
-                      </a:solidFill>
-                      <a:prstDash val="solid"/>
-                      <a:round/>
-                      <a:headEnd type="none" w="med" len="med"/>
-                      <a:tailEnd type="none" w="med" len="med"/>
-                    </a:lnB>
-                    <a:solidFill>
-                      <a:srgbClr val="FFFFFF"/>
-                    </a:solidFill>
-                  </a:tcPr>
-                </a:tc>
-                <a:tc>
-                  <a:txBody>
-                    <a:bodyPr/>
-                    <a:lstStyle/>
-                    <a:p>
-                      <a:pPr indent="0" marL="0">
-                        <a:buNone/>
-                      </a:pPr>
-                      <a:r>
-                        <a:rPr lang="en-US" sz="1200" dirty="0">
-                          <a:solidFill>
-                            <a:srgbClr val="26303F"/>
-                          </a:solidFill>
-                          <a:latin typeface="Calibri" pitchFamily="34" charset="0"/>
-                          <a:ea typeface="Calibri" pitchFamily="34" charset="-122"/>
-                          <a:cs typeface="Calibri" pitchFamily="34" charset="-120"/>
-                        </a:rPr>
-                        <a:t>manual per help topic</a:t>
-                      </a:r>
-                      <a:endParaRPr lang="en-US" sz="1200" dirty="0">
-                        <a:latin typeface="Calibri" charset="0"/>
-                        <a:ea typeface="Calibri" charset="0"/>
-                        <a:cs typeface="Calibri" charset="0"/>
-                      </a:endParaRPr>
-                    </a:p>
-                  </a:txBody>
-                  <a:tcPr marL="76200" marR="76200" marT="25400" marB="25400" anchor="ctr">
-                    <a:lnL w="9525" cap="flat" cmpd="sng" algn="ctr">
-                      <a:solidFill>
-                        <a:srgbClr val="D5DAE1"/>
-                      </a:solidFill>
-                      <a:prstDash val="solid"/>
-                      <a:round/>
-                      <a:headEnd type="none" w="med" len="med"/>
-                      <a:tailEnd type="none" w="med" len="med"/>
-                    </a:lnL>
-                    <a:lnR w="9525" cap="flat" cmpd="sng" algn="ctr">
-                      <a:solidFill>
-                        <a:srgbClr val="D5DAE1"/>
-                      </a:solidFill>
-                      <a:prstDash val="solid"/>
-                      <a:round/>
-                      <a:headEnd type="none" w="med" len="med"/>
-                      <a:tailEnd type="none" w="med" len="med"/>
-                    </a:lnR>
-                    <a:lnT w="9525" cap="flat" cmpd="sng" algn="ctr">
-                      <a:solidFill>
-                        <a:srgbClr val="D5DAE1"/>
-                      </a:solidFill>
-                      <a:prstDash val="solid"/>
-                      <a:round/>
-                      <a:headEnd type="none" w="med" len="med"/>
-                      <a:tailEnd type="none" w="med" len="med"/>
-                    </a:lnT>
-                    <a:lnB w="9525" cap="flat" cmpd="sng" algn="ctr">
-                      <a:solidFill>
-                        <a:srgbClr val="D5DAE1"/>
-                      </a:solidFill>
-                      <a:prstDash val="solid"/>
-                      <a:round/>
-                      <a:headEnd type="none" w="med" len="med"/>
-                      <a:tailEnd type="none" w="med" len="med"/>
-                    </a:lnB>
-                    <a:solidFill>
-                      <a:srgbClr val="FFFFFF"/>
-                    </a:solidFill>
-                  </a:tcPr>
-                </a:tc>
-                <a:tc>
-                  <a:txBody>
-                    <a:bodyPr/>
-                    <a:lstStyle/>
-                    <a:p>
-                      <a:pPr indent="0" marL="0">
-                        <a:buNone/>
-                      </a:pPr>
-                      <a:r>
-                        <a:rPr lang="en-US" sz="1200" dirty="0">
-                          <a:solidFill>
-                            <a:srgbClr val="26303F"/>
-                          </a:solidFill>
-                          <a:latin typeface="Calibri" pitchFamily="34" charset="0"/>
-                          <a:ea typeface="Calibri" pitchFamily="34" charset="-122"/>
-                          <a:cs typeface="Calibri" pitchFamily="34" charset="-120"/>
-                        </a:rPr>
-                        <a:t>by department, manual claim</a:t>
-                      </a:r>
-                      <a:endParaRPr lang="en-US" sz="1200" dirty="0">
-                        <a:latin typeface="Calibri" charset="0"/>
-                        <a:ea typeface="Calibri" charset="0"/>
-                        <a:cs typeface="Calibri" charset="0"/>
-                      </a:endParaRPr>
-                    </a:p>
-                  </a:txBody>
-                  <a:tcPr marL="76200" marR="76200" marT="25400" marB="25400" anchor="ctr">
-                    <a:lnL w="9525" cap="flat" cmpd="sng" algn="ctr">
-                      <a:solidFill>
-                        <a:srgbClr val="D5DAE1"/>
-                      </a:solidFill>
-                      <a:prstDash val="solid"/>
-                      <a:round/>
-                      <a:headEnd type="none" w="med" len="med"/>
-                      <a:tailEnd type="none" w="med" len="med"/>
-                    </a:lnL>
-                    <a:lnR w="9525" cap="flat" cmpd="sng" algn="ctr">
-                      <a:solidFill>
-                        <a:srgbClr val="D5DAE1"/>
-                      </a:solidFill>
-                      <a:prstDash val="solid"/>
-                      <a:round/>
-                      <a:headEnd type="none" w="med" len="med"/>
-                      <a:tailEnd type="none" w="med" len="med"/>
-                    </a:lnR>
-                    <a:lnT w="9525" cap="flat" cmpd="sng" algn="ctr">
-                      <a:solidFill>
-                        <a:srgbClr val="D5DAE1"/>
-                      </a:solidFill>
-                      <a:prstDash val="solid"/>
-                      <a:round/>
-                      <a:headEnd type="none" w="med" len="med"/>
-                      <a:tailEnd type="none" w="med" len="med"/>
-                    </a:lnT>
-                    <a:lnB w="9525" cap="flat" cmpd="sng" algn="ctr">
-                      <a:solidFill>
-                        <a:srgbClr val="D5DAE1"/>
-                      </a:solidFill>
-                      <a:prstDash val="solid"/>
-                      <a:round/>
-                      <a:headEnd type="none" w="med" len="med"/>
-                      <a:tailEnd type="none" w="med" len="med"/>
-                    </a:lnB>
-                    <a:solidFill>
-                      <a:srgbClr val="FFFFFF"/>
-                    </a:solidFill>
-                  </a:tcPr>
-                </a:tc>
-                <a:tc>
-                  <a:txBody>
-                    <a:bodyPr/>
-                    <a:lstStyle/>
-                    <a:p>
-                      <a:pPr indent="0" marL="0">
-                        <a:buNone/>
-                      </a:pPr>
-                      <a:r>
-                        <a:rPr lang="en-US" sz="1200" dirty="0">
-                          <a:solidFill>
-                            <a:srgbClr val="26303F"/>
-                          </a:solidFill>
-                          <a:latin typeface="Calibri" pitchFamily="34" charset="0"/>
-                          <a:ea typeface="Calibri" pitchFamily="34" charset="-122"/>
-                          <a:cs typeface="Calibri" pitchFamily="34" charset="-120"/>
-                        </a:rPr>
-                        <a:t>none</a:t>
-                      </a:r>
-                      <a:endParaRPr lang="en-US" sz="1200" dirty="0">
-                        <a:latin typeface="Calibri" charset="0"/>
-                        <a:ea typeface="Calibri" charset="0"/>
-                        <a:cs typeface="Calibri" charset="0"/>
-                      </a:endParaRPr>
-                    </a:p>
-                  </a:txBody>
-                  <a:tcPr marL="76200" marR="76200" marT="25400" marB="25400" anchor="ctr">
-                    <a:lnL w="9525" cap="flat" cmpd="sng" algn="ctr">
-                      <a:solidFill>
-                        <a:srgbClr val="D5DAE1"/>
-                      </a:solidFill>
-                      <a:prstDash val="solid"/>
-                      <a:round/>
-                      <a:headEnd type="none" w="med" len="med"/>
-                      <a:tailEnd type="none" w="med" len="med"/>
-                    </a:lnL>
-                    <a:lnR w="9525" cap="flat" cmpd="sng" algn="ctr">
-                      <a:solidFill>
-                        <a:srgbClr val="D5DAE1"/>
-                      </a:solidFill>
-                      <a:prstDash val="solid"/>
-                      <a:round/>
-                      <a:headEnd type="none" w="med" len="med"/>
-                      <a:tailEnd type="none" w="med" len="med"/>
-                    </a:lnR>
-                    <a:lnT w="9525" cap="flat" cmpd="sng" algn="ctr">
-                      <a:solidFill>
-                        <a:srgbClr val="D5DAE1"/>
-                      </a:solidFill>
-                      <a:prstDash val="solid"/>
-                      <a:round/>
-                      <a:headEnd type="none" w="med" len="med"/>
-                      <a:tailEnd type="none" w="med" len="med"/>
-                    </a:lnT>
-                    <a:lnB w="9525" cap="flat" cmpd="sng" algn="ctr">
-                      <a:solidFill>
-                        <a:srgbClr val="D5DAE1"/>
-                      </a:solidFill>
-                      <a:prstDash val="solid"/>
-                      <a:round/>
-                      <a:headEnd type="none" w="med" len="med"/>
-                      <a:tailEnd type="none" w="med" len="med"/>
-                    </a:lnB>
-                    <a:solidFill>
-                      <a:srgbClr val="FFFFFF"/>
-                    </a:solidFill>
-                  </a:tcPr>
-                </a:tc>
-                <a:tc>
-                  <a:txBody>
-                    <a:bodyPr/>
-                    <a:lstStyle/>
-                    <a:p>
-                      <a:pPr indent="0" marL="0">
-                        <a:buNone/>
-                      </a:pPr>
-                      <a:r>
-                        <a:rPr lang="en-US" sz="1200" dirty="0">
-                          <a:solidFill>
-                            <a:srgbClr val="26303F"/>
-                          </a:solidFill>
-                          <a:latin typeface="Calibri" pitchFamily="34" charset="0"/>
-                          <a:ea typeface="Calibri" pitchFamily="34" charset="-122"/>
-                          <a:cs typeface="Calibri" pitchFamily="34" charset="-120"/>
-                        </a:rPr>
-                        <a:t>overdue after a grace period</a:t>
-                      </a:r>
-                      <a:endParaRPr lang="en-US" sz="1200" dirty="0">
-                        <a:latin typeface="Calibri" charset="0"/>
-                        <a:ea typeface="Calibri" charset="0"/>
-                        <a:cs typeface="Calibri" charset="0"/>
-                      </a:endParaRPr>
-                    </a:p>
-                  </a:txBody>
-                  <a:tcPr marL="76200" marR="76200" marT="25400" marB="25400" anchor="ctr">
-                    <a:lnL w="9525" cap="flat" cmpd="sng" algn="ctr">
-                      <a:solidFill>
-                        <a:srgbClr val="D5DAE1"/>
-                      </a:solidFill>
-                      <a:prstDash val="solid"/>
-                      <a:round/>
-                      <a:headEnd type="none" w="med" len="med"/>
-                      <a:tailEnd type="none" w="med" len="med"/>
-                    </a:lnL>
-                    <a:lnR w="9525" cap="flat" cmpd="sng" algn="ctr">
-                      <a:solidFill>
-                        <a:srgbClr val="D5DAE1"/>
-                      </a:solidFill>
-                      <a:prstDash val="solid"/>
-                      <a:round/>
-                      <a:headEnd type="none" w="med" len="med"/>
-                      <a:tailEnd type="none" w="med" len="med"/>
-                    </a:lnR>
-                    <a:lnT w="9525" cap="flat" cmpd="sng" algn="ctr">
-                      <a:solidFill>
-                        <a:srgbClr val="D5DAE1"/>
-                      </a:solidFill>
-                      <a:prstDash val="solid"/>
-                      <a:round/>
-                      <a:headEnd type="none" w="med" len="med"/>
-                      <a:tailEnd type="none" w="med" len="med"/>
-                    </a:lnT>
-                    <a:lnB w="9525" cap="flat" cmpd="sng" algn="ctr">
-                      <a:solidFill>
-                        <a:srgbClr val="D5DAE1"/>
-                      </a:solidFill>
-                      <a:prstDash val="solid"/>
-                      <a:round/>
-                      <a:headEnd type="none" w="med" len="med"/>
-                      <a:tailEnd type="none" w="med" len="med"/>
-                    </a:lnB>
-                    <a:solidFill>
-                      <a:srgbClr val="FFFFFF"/>
-                    </a:solidFill>
-                  </a:tcPr>
-                </a:tc>
-              </a:tr>
-              <a:tr h="475488">
-                <a:tc>
-                  <a:txBody>
-                    <a:bodyPr/>
-                    <a:lstStyle/>
-                    <a:p>
-                      <a:pPr indent="0" marL="0">
-                        <a:buNone/>
-                      </a:pPr>
-                      <a:r>
-                        <a:rPr lang="en-US" sz="1200" dirty="0">
-                          <a:solidFill>
-                            <a:srgbClr val="26303F"/>
-                          </a:solidFill>
-                          <a:latin typeface="Calibri" pitchFamily="34" charset="0"/>
-                          <a:ea typeface="Calibri" pitchFamily="34" charset="-122"/>
-                          <a:cs typeface="Calibri" pitchFamily="34" charset="-120"/>
-                        </a:rPr>
-                        <a:t>Zammad</a:t>
-                      </a:r>
-                      <a:endParaRPr lang="en-US" sz="1200" dirty="0">
-                        <a:latin typeface="Calibri" charset="0"/>
-                        <a:ea typeface="Calibri" charset="0"/>
-                        <a:cs typeface="Calibri" charset="0"/>
-                      </a:endParaRPr>
-                    </a:p>
-                  </a:txBody>
-                  <a:tcPr marL="76200" marR="76200" marT="25400" marB="25400" anchor="ctr">
-                    <a:lnL w="9525" cap="flat" cmpd="sng" algn="ctr">
-                      <a:solidFill>
-                        <a:srgbClr val="D5DAE1"/>
-                      </a:solidFill>
-                      <a:prstDash val="solid"/>
-                      <a:round/>
-                      <a:headEnd type="none" w="med" len="med"/>
-                      <a:tailEnd type="none" w="med" len="med"/>
-                    </a:lnL>
-                    <a:lnR w="9525" cap="flat" cmpd="sng" algn="ctr">
-                      <a:solidFill>
-                        <a:srgbClr val="D5DAE1"/>
-                      </a:solidFill>
-                      <a:prstDash val="solid"/>
-                      <a:round/>
-                      <a:headEnd type="none" w="med" len="med"/>
-                      <a:tailEnd type="none" w="med" len="med"/>
-                    </a:lnR>
-                    <a:lnT w="9525" cap="flat" cmpd="sng" algn="ctr">
-                      <a:solidFill>
-                        <a:srgbClr val="D5DAE1"/>
-                      </a:solidFill>
-                      <a:prstDash val="solid"/>
-                      <a:round/>
-                      <a:headEnd type="none" w="med" len="med"/>
-                      <a:tailEnd type="none" w="med" len="med"/>
-                    </a:lnT>
-                    <a:lnB w="9525" cap="flat" cmpd="sng" algn="ctr">
-                      <a:solidFill>
-                        <a:srgbClr val="D5DAE1"/>
-                      </a:solidFill>
-                      <a:prstDash val="solid"/>
-                      <a:round/>
-                      <a:headEnd type="none" w="med" len="med"/>
-                      <a:tailEnd type="none" w="med" len="med"/>
-                    </a:lnB>
-                    <a:solidFill>
-                      <a:srgbClr val="F7F8FA"/>
-                    </a:solidFill>
-                  </a:tcPr>
-                </a:tc>
-                <a:tc>
-                  <a:txBody>
-                    <a:bodyPr/>
-                    <a:lstStyle/>
-                    <a:p>
-                      <a:pPr indent="0" marL="0">
-                        <a:buNone/>
-                      </a:pPr>
-                      <a:r>
-                        <a:rPr lang="en-US" sz="1200" dirty="0">
-                          <a:solidFill>
-                            <a:srgbClr val="26303F"/>
-                          </a:solidFill>
-                          <a:latin typeface="Calibri" pitchFamily="34" charset="0"/>
-                          <a:ea typeface="Calibri" pitchFamily="34" charset="-122"/>
-                          <a:cs typeface="Calibri" pitchFamily="34" charset="-120"/>
-                        </a:rPr>
-                        <a:t>three fixed levels</a:t>
-                      </a:r>
-                      <a:endParaRPr lang="en-US" sz="1200" dirty="0">
-                        <a:latin typeface="Calibri" charset="0"/>
-                        <a:ea typeface="Calibri" charset="0"/>
-                        <a:cs typeface="Calibri" charset="0"/>
-                      </a:endParaRPr>
-                    </a:p>
-                  </a:txBody>
-                  <a:tcPr marL="76200" marR="76200" marT="25400" marB="25400" anchor="ctr">
-                    <a:lnL w="9525" cap="flat" cmpd="sng" algn="ctr">
-                      <a:solidFill>
-                        <a:srgbClr val="D5DAE1"/>
-                      </a:solidFill>
-                      <a:prstDash val="solid"/>
-                      <a:round/>
-                      <a:headEnd type="none" w="med" len="med"/>
-                      <a:tailEnd type="none" w="med" len="med"/>
-                    </a:lnL>
-                    <a:lnR w="9525" cap="flat" cmpd="sng" algn="ctr">
-                      <a:solidFill>
-                        <a:srgbClr val="D5DAE1"/>
-                      </a:solidFill>
-                      <a:prstDash val="solid"/>
-                      <a:round/>
-                      <a:headEnd type="none" w="med" len="med"/>
-                      <a:tailEnd type="none" w="med" len="med"/>
-                    </a:lnR>
-                    <a:lnT w="9525" cap="flat" cmpd="sng" algn="ctr">
-                      <a:solidFill>
-                        <a:srgbClr val="D5DAE1"/>
-                      </a:solidFill>
-                      <a:prstDash val="solid"/>
-                      <a:round/>
-                      <a:headEnd type="none" w="med" len="med"/>
-                      <a:tailEnd type="none" w="med" len="med"/>
-                    </a:lnT>
-                    <a:lnB w="9525" cap="flat" cmpd="sng" algn="ctr">
-                      <a:solidFill>
-                        <a:srgbClr val="D5DAE1"/>
-                      </a:solidFill>
-                      <a:prstDash val="solid"/>
-                      <a:round/>
-                      <a:headEnd type="none" w="med" len="med"/>
-                      <a:tailEnd type="none" w="med" len="med"/>
-                    </a:lnB>
-                    <a:solidFill>
-                      <a:srgbClr val="F7F8FA"/>
-                    </a:solidFill>
-                  </a:tcPr>
-                </a:tc>
-                <a:tc>
-                  <a:txBody>
-                    <a:bodyPr/>
-                    <a:lstStyle/>
-                    <a:p>
-                      <a:pPr indent="0" marL="0">
-                        <a:buNone/>
-                      </a:pPr>
-                      <a:r>
-                        <a:rPr lang="en-US" sz="1200" dirty="0">
-                          <a:solidFill>
-                            <a:srgbClr val="26303F"/>
-                          </a:solidFill>
-                          <a:latin typeface="Calibri" pitchFamily="34" charset="0"/>
-                          <a:ea typeface="Calibri" pitchFamily="34" charset="-122"/>
-                          <a:cs typeface="Calibri" pitchFamily="34" charset="-120"/>
-                        </a:rPr>
-                        <a:t>group rules, no workload</a:t>
-                      </a:r>
-                      <a:endParaRPr lang="en-US" sz="1200" dirty="0">
-                        <a:latin typeface="Calibri" charset="0"/>
-                        <a:ea typeface="Calibri" charset="0"/>
-                        <a:cs typeface="Calibri" charset="0"/>
-                      </a:endParaRPr>
-                    </a:p>
-                  </a:txBody>
-                  <a:tcPr marL="76200" marR="76200" marT="25400" marB="25400" anchor="ctr">
-                    <a:lnL w="9525" cap="flat" cmpd="sng" algn="ctr">
-                      <a:solidFill>
-                        <a:srgbClr val="D5DAE1"/>
-                      </a:solidFill>
-                      <a:prstDash val="solid"/>
-                      <a:round/>
-                      <a:headEnd type="none" w="med" len="med"/>
-                      <a:tailEnd type="none" w="med" len="med"/>
-                    </a:lnL>
-                    <a:lnR w="9525" cap="flat" cmpd="sng" algn="ctr">
-                      <a:solidFill>
-                        <a:srgbClr val="D5DAE1"/>
-                      </a:solidFill>
-                      <a:prstDash val="solid"/>
-                      <a:round/>
-                      <a:headEnd type="none" w="med" len="med"/>
-                      <a:tailEnd type="none" w="med" len="med"/>
-                    </a:lnR>
-                    <a:lnT w="9525" cap="flat" cmpd="sng" algn="ctr">
-                      <a:solidFill>
-                        <a:srgbClr val="D5DAE1"/>
-                      </a:solidFill>
-                      <a:prstDash val="solid"/>
-                      <a:round/>
-                      <a:headEnd type="none" w="med" len="med"/>
-                      <a:tailEnd type="none" w="med" len="med"/>
-                    </a:lnT>
-                    <a:lnB w="9525" cap="flat" cmpd="sng" algn="ctr">
-                      <a:solidFill>
-                        <a:srgbClr val="D5DAE1"/>
-                      </a:solidFill>
-                      <a:prstDash val="solid"/>
-                      <a:round/>
-                      <a:headEnd type="none" w="med" len="med"/>
-                      <a:tailEnd type="none" w="med" len="med"/>
-                    </a:lnB>
-                    <a:solidFill>
-                      <a:srgbClr val="F7F8FA"/>
-                    </a:solidFill>
-                  </a:tcPr>
-                </a:tc>
-                <a:tc>
-                  <a:txBody>
-                    <a:bodyPr/>
-                    <a:lstStyle/>
-                    <a:p>
-                      <a:pPr indent="0" marL="0">
-                        <a:buNone/>
-                      </a:pPr>
-                      <a:r>
-                        <a:rPr lang="en-US" sz="1200" dirty="0">
-                          <a:solidFill>
-                            <a:srgbClr val="26303F"/>
-                          </a:solidFill>
-                          <a:latin typeface="Calibri" pitchFamily="34" charset="0"/>
-                          <a:ea typeface="Calibri" pitchFamily="34" charset="-122"/>
-                          <a:cs typeface="Calibri" pitchFamily="34" charset="-120"/>
-                        </a:rPr>
-                        <a:t>manual merge</a:t>
-                      </a:r>
-                      <a:endParaRPr lang="en-US" sz="1200" dirty="0">
-                        <a:latin typeface="Calibri" charset="0"/>
-                        <a:ea typeface="Calibri" charset="0"/>
-                        <a:cs typeface="Calibri" charset="0"/>
-                      </a:endParaRPr>
-                    </a:p>
-                  </a:txBody>
-                  <a:tcPr marL="76200" marR="76200" marT="25400" marB="25400" anchor="ctr">
-                    <a:lnL w="9525" cap="flat" cmpd="sng" algn="ctr">
-                      <a:solidFill>
-                        <a:srgbClr val="D5DAE1"/>
-                      </a:solidFill>
-                      <a:prstDash val="solid"/>
-                      <a:round/>
-                      <a:headEnd type="none" w="med" len="med"/>
-                      <a:tailEnd type="none" w="med" len="med"/>
-                    </a:lnL>
-                    <a:lnR w="9525" cap="flat" cmpd="sng" algn="ctr">
-                      <a:solidFill>
-                        <a:srgbClr val="D5DAE1"/>
-                      </a:solidFill>
-                      <a:prstDash val="solid"/>
-                      <a:round/>
-                      <a:headEnd type="none" w="med" len="med"/>
-                      <a:tailEnd type="none" w="med" len="med"/>
-                    </a:lnR>
-                    <a:lnT w="9525" cap="flat" cmpd="sng" algn="ctr">
-                      <a:solidFill>
-                        <a:srgbClr val="D5DAE1"/>
-                      </a:solidFill>
-                      <a:prstDash val="solid"/>
-                      <a:round/>
-                      <a:headEnd type="none" w="med" len="med"/>
-                      <a:tailEnd type="none" w="med" len="med"/>
-                    </a:lnT>
-                    <a:lnB w="9525" cap="flat" cmpd="sng" algn="ctr">
-                      <a:solidFill>
-                        <a:srgbClr val="D5DAE1"/>
-                      </a:solidFill>
-                      <a:prstDash val="solid"/>
-                      <a:round/>
-                      <a:headEnd type="none" w="med" len="med"/>
-                      <a:tailEnd type="none" w="med" len="med"/>
-                    </a:lnB>
-                    <a:solidFill>
-                      <a:srgbClr val="F7F8FA"/>
-                    </a:solidFill>
-                  </a:tcPr>
-                </a:tc>
-                <a:tc>
-                  <a:txBody>
-                    <a:bodyPr/>
-                    <a:lstStyle/>
-                    <a:p>
-                      <a:pPr indent="0" marL="0">
-                        <a:buNone/>
-                      </a:pPr>
-                      <a:r>
-                        <a:rPr lang="en-US" sz="1200" dirty="0">
-                          <a:solidFill>
-                            <a:srgbClr val="26303F"/>
-                          </a:solidFill>
-                          <a:latin typeface="Calibri" pitchFamily="34" charset="0"/>
-                          <a:ea typeface="Calibri" pitchFamily="34" charset="-122"/>
-                          <a:cs typeface="Calibri" pitchFamily="34" charset="-120"/>
-                        </a:rPr>
-                        <a:t>timers with calendars</a:t>
-                      </a:r>
-                      <a:endParaRPr lang="en-US" sz="1200" dirty="0">
-                        <a:latin typeface="Calibri" charset="0"/>
-                        <a:ea typeface="Calibri" charset="0"/>
-                        <a:cs typeface="Calibri" charset="0"/>
-                      </a:endParaRPr>
-                    </a:p>
-                  </a:txBody>
-                  <a:tcPr marL="76200" marR="76200" marT="25400" marB="25400" anchor="ctr">
-                    <a:lnL w="9525" cap="flat" cmpd="sng" algn="ctr">
-                      <a:solidFill>
-                        <a:srgbClr val="D5DAE1"/>
-                      </a:solidFill>
-                      <a:prstDash val="solid"/>
-                      <a:round/>
-                      <a:headEnd type="none" w="med" len="med"/>
-                      <a:tailEnd type="none" w="med" len="med"/>
-                    </a:lnL>
-                    <a:lnR w="9525" cap="flat" cmpd="sng" algn="ctr">
-                      <a:solidFill>
-                        <a:srgbClr val="D5DAE1"/>
-                      </a:solidFill>
-                      <a:prstDash val="solid"/>
-                      <a:round/>
-                      <a:headEnd type="none" w="med" len="med"/>
-                      <a:tailEnd type="none" w="med" len="med"/>
-                    </a:lnR>
-                    <a:lnT w="9525" cap="flat" cmpd="sng" algn="ctr">
-                      <a:solidFill>
-                        <a:srgbClr val="D5DAE1"/>
-                      </a:solidFill>
-                      <a:prstDash val="solid"/>
-                      <a:round/>
-                      <a:headEnd type="none" w="med" len="med"/>
-                      <a:tailEnd type="none" w="med" len="med"/>
-                    </a:lnT>
-                    <a:lnB w="9525" cap="flat" cmpd="sng" algn="ctr">
-                      <a:solidFill>
-                        <a:srgbClr val="D5DAE1"/>
-                      </a:solidFill>
-                      <a:prstDash val="solid"/>
-                      <a:round/>
-                      <a:headEnd type="none" w="med" len="med"/>
-                      <a:tailEnd type="none" w="med" len="med"/>
-                    </a:lnB>
-                    <a:solidFill>
-                      <a:srgbClr val="F7F8FA"/>
-                    </a:solidFill>
-                  </a:tcPr>
-                </a:tc>
-              </a:tr>
-              <a:tr h="475488">
-                <a:tc>
-                  <a:txBody>
-                    <a:bodyPr/>
-                    <a:lstStyle/>
-                    <a:p>
-                      <a:pPr indent="0" marL="0">
-                        <a:buNone/>
-                      </a:pPr>
-                      <a:r>
-                        <a:rPr lang="en-US" sz="1200" dirty="0">
-                          <a:solidFill>
-                            <a:srgbClr val="26303F"/>
-                          </a:solidFill>
-                          <a:latin typeface="Calibri" pitchFamily="34" charset="0"/>
-                          <a:ea typeface="Calibri" pitchFamily="34" charset="-122"/>
-                          <a:cs typeface="Calibri" pitchFamily="34" charset="-120"/>
-                        </a:rPr>
-                        <a:t>GLPI</a:t>
-                      </a:r>
-                      <a:endParaRPr lang="en-US" sz="1200" dirty="0">
-                        <a:latin typeface="Calibri" charset="0"/>
-                        <a:ea typeface="Calibri" charset="0"/>
-                        <a:cs typeface="Calibri" charset="0"/>
-                      </a:endParaRPr>
-                    </a:p>
-                  </a:txBody>
-                  <a:tcPr marL="76200" marR="76200" marT="25400" marB="25400" anchor="ctr">
-                    <a:lnL w="9525" cap="flat" cmpd="sng" algn="ctr">
-                      <a:solidFill>
-                        <a:srgbClr val="D5DAE1"/>
-                      </a:solidFill>
-                      <a:prstDash val="solid"/>
-                      <a:round/>
-                      <a:headEnd type="none" w="med" len="med"/>
-                      <a:tailEnd type="none" w="med" len="med"/>
-                    </a:lnL>
-                    <a:lnR w="9525" cap="flat" cmpd="sng" algn="ctr">
-                      <a:solidFill>
-                        <a:srgbClr val="D5DAE1"/>
-                      </a:solidFill>
-                      <a:prstDash val="solid"/>
-                      <a:round/>
-                      <a:headEnd type="none" w="med" len="med"/>
-                      <a:tailEnd type="none" w="med" len="med"/>
-                    </a:lnR>
-                    <a:lnT w="9525" cap="flat" cmpd="sng" algn="ctr">
-                      <a:solidFill>
-                        <a:srgbClr val="D5DAE1"/>
-                      </a:solidFill>
-                      <a:prstDash val="solid"/>
-                      <a:round/>
-                      <a:headEnd type="none" w="med" len="med"/>
-                      <a:tailEnd type="none" w="med" len="med"/>
-                    </a:lnT>
-                    <a:lnB w="9525" cap="flat" cmpd="sng" algn="ctr">
-                      <a:solidFill>
-                        <a:srgbClr val="D5DAE1"/>
-                      </a:solidFill>
-                      <a:prstDash val="solid"/>
-                      <a:round/>
-                      <a:headEnd type="none" w="med" len="med"/>
-                      <a:tailEnd type="none" w="med" len="med"/>
-                    </a:lnB>
-                    <a:solidFill>
-                      <a:srgbClr val="FFFFFF"/>
-                    </a:solidFill>
-                  </a:tcPr>
-                </a:tc>
-                <a:tc>
-                  <a:txBody>
-                    <a:bodyPr/>
-                    <a:lstStyle/>
-                    <a:p>
-                      <a:pPr indent="0" marL="0">
-                        <a:buNone/>
-                      </a:pPr>
-                      <a:r>
-                        <a:rPr lang="en-US" sz="1200" dirty="0">
-                          <a:solidFill>
-                            <a:srgbClr val="26303F"/>
-                          </a:solidFill>
-                          <a:latin typeface="Calibri" pitchFamily="34" charset="0"/>
-                          <a:ea typeface="Calibri" pitchFamily="34" charset="-122"/>
-                          <a:cs typeface="Calibri" pitchFamily="34" charset="-120"/>
-                        </a:rPr>
-                        <a:t>urgency × impact matrix</a:t>
-                      </a:r>
-                      <a:endParaRPr lang="en-US" sz="1200" dirty="0">
-                        <a:latin typeface="Calibri" charset="0"/>
-                        <a:ea typeface="Calibri" charset="0"/>
-                        <a:cs typeface="Calibri" charset="0"/>
-                      </a:endParaRPr>
-                    </a:p>
-                  </a:txBody>
-                  <a:tcPr marL="76200" marR="76200" marT="25400" marB="25400" anchor="ctr">
-                    <a:lnL w="9525" cap="flat" cmpd="sng" algn="ctr">
-                      <a:solidFill>
-                        <a:srgbClr val="D5DAE1"/>
-                      </a:solidFill>
-                      <a:prstDash val="solid"/>
-                      <a:round/>
-                      <a:headEnd type="none" w="med" len="med"/>
-                      <a:tailEnd type="none" w="med" len="med"/>
-                    </a:lnL>
-                    <a:lnR w="9525" cap="flat" cmpd="sng" algn="ctr">
-                      <a:solidFill>
-                        <a:srgbClr val="D5DAE1"/>
-                      </a:solidFill>
-                      <a:prstDash val="solid"/>
-                      <a:round/>
-                      <a:headEnd type="none" w="med" len="med"/>
-                      <a:tailEnd type="none" w="med" len="med"/>
-                    </a:lnR>
-                    <a:lnT w="9525" cap="flat" cmpd="sng" algn="ctr">
-                      <a:solidFill>
-                        <a:srgbClr val="D5DAE1"/>
-                      </a:solidFill>
-                      <a:prstDash val="solid"/>
-                      <a:round/>
-                      <a:headEnd type="none" w="med" len="med"/>
-                      <a:tailEnd type="none" w="med" len="med"/>
-                    </a:lnT>
-                    <a:lnB w="9525" cap="flat" cmpd="sng" algn="ctr">
-                      <a:solidFill>
-                        <a:srgbClr val="D5DAE1"/>
-                      </a:solidFill>
-                      <a:prstDash val="solid"/>
-                      <a:round/>
-                      <a:headEnd type="none" w="med" len="med"/>
-                      <a:tailEnd type="none" w="med" len="med"/>
-                    </a:lnB>
-                    <a:solidFill>
-                      <a:srgbClr val="FFFFFF"/>
-                    </a:solidFill>
-                  </a:tcPr>
-                </a:tc>
-                <a:tc>
-                  <a:txBody>
-                    <a:bodyPr/>
-                    <a:lstStyle/>
-                    <a:p>
-                      <a:pPr indent="0" marL="0">
-                        <a:buNone/>
-                      </a:pPr>
-                      <a:r>
-                        <a:rPr lang="en-US" sz="1200" dirty="0">
-                          <a:solidFill>
-                            <a:srgbClr val="26303F"/>
-                          </a:solidFill>
-                          <a:latin typeface="Calibri" pitchFamily="34" charset="0"/>
-                          <a:ea typeface="Calibri" pitchFamily="34" charset="-122"/>
-                          <a:cs typeface="Calibri" pitchFamily="34" charset="-120"/>
-                        </a:rPr>
-                        <a:t>rules pick a technician</a:t>
-                      </a:r>
-                      <a:endParaRPr lang="en-US" sz="1200" dirty="0">
-                        <a:latin typeface="Calibri" charset="0"/>
-                        <a:ea typeface="Calibri" charset="0"/>
-                        <a:cs typeface="Calibri" charset="0"/>
-                      </a:endParaRPr>
-                    </a:p>
-                  </a:txBody>
-                  <a:tcPr marL="76200" marR="76200" marT="25400" marB="25400" anchor="ctr">
-                    <a:lnL w="9525" cap="flat" cmpd="sng" algn="ctr">
-                      <a:solidFill>
-                        <a:srgbClr val="D5DAE1"/>
-                      </a:solidFill>
-                      <a:prstDash val="solid"/>
-                      <a:round/>
-                      <a:headEnd type="none" w="med" len="med"/>
-                      <a:tailEnd type="none" w="med" len="med"/>
-                    </a:lnL>
-                    <a:lnR w="9525" cap="flat" cmpd="sng" algn="ctr">
-                      <a:solidFill>
-                        <a:srgbClr val="D5DAE1"/>
-                      </a:solidFill>
-                      <a:prstDash val="solid"/>
-                      <a:round/>
-                      <a:headEnd type="none" w="med" len="med"/>
-                      <a:tailEnd type="none" w="med" len="med"/>
-                    </a:lnR>
-                    <a:lnT w="9525" cap="flat" cmpd="sng" algn="ctr">
-                      <a:solidFill>
-                        <a:srgbClr val="D5DAE1"/>
-                      </a:solidFill>
-                      <a:prstDash val="solid"/>
-                      <a:round/>
-                      <a:headEnd type="none" w="med" len="med"/>
-                      <a:tailEnd type="none" w="med" len="med"/>
-                    </a:lnT>
-                    <a:lnB w="9525" cap="flat" cmpd="sng" algn="ctr">
-                      <a:solidFill>
-                        <a:srgbClr val="D5DAE1"/>
-                      </a:solidFill>
-                      <a:prstDash val="solid"/>
-                      <a:round/>
-                      <a:headEnd type="none" w="med" len="med"/>
-                      <a:tailEnd type="none" w="med" len="med"/>
-                    </a:lnB>
-                    <a:solidFill>
-                      <a:srgbClr val="FFFFFF"/>
-                    </a:solidFill>
-                  </a:tcPr>
-                </a:tc>
-                <a:tc>
-                  <a:txBody>
-                    <a:bodyPr/>
-                    <a:lstStyle/>
-                    <a:p>
-                      <a:pPr indent="0" marL="0">
-                        <a:buNone/>
-                      </a:pPr>
-                      <a:r>
-                        <a:rPr lang="en-US" sz="1200" dirty="0">
-                          <a:solidFill>
-                            <a:srgbClr val="26303F"/>
-                          </a:solidFill>
-                          <a:latin typeface="Calibri" pitchFamily="34" charset="0"/>
-                          <a:ea typeface="Calibri" pitchFamily="34" charset="-122"/>
-                          <a:cs typeface="Calibri" pitchFamily="34" charset="-120"/>
-                        </a:rPr>
-                        <a:t>none</a:t>
-                      </a:r>
-                      <a:endParaRPr lang="en-US" sz="1200" dirty="0">
-                        <a:latin typeface="Calibri" charset="0"/>
-                        <a:ea typeface="Calibri" charset="0"/>
-                        <a:cs typeface="Calibri" charset="0"/>
-                      </a:endParaRPr>
-                    </a:p>
-                  </a:txBody>
-                  <a:tcPr marL="76200" marR="76200" marT="25400" marB="25400" anchor="ctr">
-                    <a:lnL w="9525" cap="flat" cmpd="sng" algn="ctr">
-                      <a:solidFill>
-                        <a:srgbClr val="D5DAE1"/>
-                      </a:solidFill>
-                      <a:prstDash val="solid"/>
-                      <a:round/>
-                      <a:headEnd type="none" w="med" len="med"/>
-                      <a:tailEnd type="none" w="med" len="med"/>
-                    </a:lnL>
-                    <a:lnR w="9525" cap="flat" cmpd="sng" algn="ctr">
-                      <a:solidFill>
-                        <a:srgbClr val="D5DAE1"/>
-                      </a:solidFill>
-                      <a:prstDash val="solid"/>
-                      <a:round/>
-                      <a:headEnd type="none" w="med" len="med"/>
-                      <a:tailEnd type="none" w="med" len="med"/>
-                    </a:lnR>
-                    <a:lnT w="9525" cap="flat" cmpd="sng" algn="ctr">
-                      <a:solidFill>
-                        <a:srgbClr val="D5DAE1"/>
-                      </a:solidFill>
-                      <a:prstDash val="solid"/>
-                      <a:round/>
-                      <a:headEnd type="none" w="med" len="med"/>
-                      <a:tailEnd type="none" w="med" len="med"/>
-                    </a:lnT>
-                    <a:lnB w="9525" cap="flat" cmpd="sng" algn="ctr">
-                      <a:solidFill>
-                        <a:srgbClr val="D5DAE1"/>
-                      </a:solidFill>
-                      <a:prstDash val="solid"/>
-                      <a:round/>
-                      <a:headEnd type="none" w="med" len="med"/>
-                      <a:tailEnd type="none" w="med" len="med"/>
-                    </a:lnB>
-                    <a:solidFill>
-                      <a:srgbClr val="FFFFFF"/>
-                    </a:solidFill>
-                  </a:tcPr>
-                </a:tc>
-                <a:tc>
-                  <a:txBody>
-                    <a:bodyPr/>
-                    <a:lstStyle/>
-                    <a:p>
-                      <a:pPr indent="0" marL="0">
-                        <a:buNone/>
-                      </a:pPr>
-                      <a:r>
-                        <a:rPr lang="en-US" sz="1200" dirty="0">
-                          <a:solidFill>
-                            <a:srgbClr val="26303F"/>
-                          </a:solidFill>
-                          <a:latin typeface="Calibri" pitchFamily="34" charset="0"/>
-                          <a:ea typeface="Calibri" pitchFamily="34" charset="-122"/>
-                          <a:cs typeface="Calibri" pitchFamily="34" charset="-120"/>
-                        </a:rPr>
-                        <a:t>attached by rules</a:t>
-                      </a:r>
-                      <a:endParaRPr lang="en-US" sz="1200" dirty="0">
-                        <a:latin typeface="Calibri" charset="0"/>
-                        <a:ea typeface="Calibri" charset="0"/>
-                        <a:cs typeface="Calibri" charset="0"/>
-                      </a:endParaRPr>
-                    </a:p>
-                  </a:txBody>
-                  <a:tcPr marL="76200" marR="76200" marT="25400" marB="25400" anchor="ctr">
-                    <a:lnL w="9525" cap="flat" cmpd="sng" algn="ctr">
-                      <a:solidFill>
-                        <a:srgbClr val="D5DAE1"/>
-                      </a:solidFill>
-                      <a:prstDash val="solid"/>
-                      <a:round/>
-                      <a:headEnd type="none" w="med" len="med"/>
-                      <a:tailEnd type="none" w="med" len="med"/>
-                    </a:lnL>
-                    <a:lnR w="9525" cap="flat" cmpd="sng" algn="ctr">
-                      <a:solidFill>
-                        <a:srgbClr val="D5DAE1"/>
-                      </a:solidFill>
-                      <a:prstDash val="solid"/>
-                      <a:round/>
-                      <a:headEnd type="none" w="med" len="med"/>
-                      <a:tailEnd type="none" w="med" len="med"/>
-                    </a:lnR>
-                    <a:lnT w="9525" cap="flat" cmpd="sng" algn="ctr">
-                      <a:solidFill>
-                        <a:srgbClr val="D5DAE1"/>
-                      </a:solidFill>
-                      <a:prstDash val="solid"/>
-                      <a:round/>
-                      <a:headEnd type="none" w="med" len="med"/>
-                      <a:tailEnd type="none" w="med" len="med"/>
-                    </a:lnT>
-                    <a:lnB w="9525" cap="flat" cmpd="sng" algn="ctr">
-                      <a:solidFill>
-                        <a:srgbClr val="D5DAE1"/>
-                      </a:solidFill>
-                      <a:prstDash val="solid"/>
-                      <a:round/>
-                      <a:headEnd type="none" w="med" len="med"/>
-                      <a:tailEnd type="none" w="med" len="med"/>
-                    </a:lnB>
-                    <a:solidFill>
-                      <a:srgbClr val="FFFFFF"/>
-                    </a:solidFill>
-                  </a:tcPr>
-                </a:tc>
-              </a:tr>
-              <a:tr h="475488">
-                <a:tc>
-                  <a:txBody>
-                    <a:bodyPr/>
-                    <a:lstStyle/>
-                    <a:p>
-                      <a:pPr indent="0" marL="0">
-                        <a:buNone/>
-                      </a:pPr>
-                      <a:r>
-                        <a:rPr lang="en-US" sz="1200" dirty="0">
-                          <a:solidFill>
-                            <a:srgbClr val="26303F"/>
-                          </a:solidFill>
-                          <a:latin typeface="Calibri" pitchFamily="34" charset="0"/>
-                          <a:ea typeface="Calibri" pitchFamily="34" charset="-122"/>
-                          <a:cs typeface="Calibri" pitchFamily="34" charset="-120"/>
-                        </a:rPr>
-                        <a:t>FreeScout</a:t>
-                      </a:r>
-                      <a:endParaRPr lang="en-US" sz="1200" dirty="0">
-                        <a:latin typeface="Calibri" charset="0"/>
-                        <a:ea typeface="Calibri" charset="0"/>
-                        <a:cs typeface="Calibri" charset="0"/>
-                      </a:endParaRPr>
-                    </a:p>
-                  </a:txBody>
-                  <a:tcPr marL="76200" marR="76200" marT="25400" marB="25400" anchor="ctr">
-                    <a:lnL w="9525" cap="flat" cmpd="sng" algn="ctr">
-                      <a:solidFill>
-                        <a:srgbClr val="D5DAE1"/>
-                      </a:solidFill>
-                      <a:prstDash val="solid"/>
-                      <a:round/>
-                      <a:headEnd type="none" w="med" len="med"/>
-                      <a:tailEnd type="none" w="med" len="med"/>
-                    </a:lnL>
-                    <a:lnR w="9525" cap="flat" cmpd="sng" algn="ctr">
-                      <a:solidFill>
-                        <a:srgbClr val="D5DAE1"/>
-                      </a:solidFill>
-                      <a:prstDash val="solid"/>
-                      <a:round/>
-                      <a:headEnd type="none" w="med" len="med"/>
-                      <a:tailEnd type="none" w="med" len="med"/>
-                    </a:lnR>
-                    <a:lnT w="9525" cap="flat" cmpd="sng" algn="ctr">
-                      <a:solidFill>
-                        <a:srgbClr val="D5DAE1"/>
-                      </a:solidFill>
-                      <a:prstDash val="solid"/>
-                      <a:round/>
-                      <a:headEnd type="none" w="med" len="med"/>
-                      <a:tailEnd type="none" w="med" len="med"/>
-                    </a:lnT>
-                    <a:lnB w="9525" cap="flat" cmpd="sng" algn="ctr">
-                      <a:solidFill>
-                        <a:srgbClr val="D5DAE1"/>
-                      </a:solidFill>
-                      <a:prstDash val="solid"/>
-                      <a:round/>
-                      <a:headEnd type="none" w="med" len="med"/>
-                      <a:tailEnd type="none" w="med" len="med"/>
-                    </a:lnB>
-                    <a:solidFill>
-                      <a:srgbClr val="F7F8FA"/>
-                    </a:solidFill>
-                  </a:tcPr>
-                </a:tc>
-                <a:tc>
-                  <a:txBody>
-                    <a:bodyPr/>
-                    <a:lstStyle/>
-                    <a:p>
-                      <a:pPr indent="0" marL="0">
-                        <a:buNone/>
-                      </a:pPr>
-                      <a:r>
-                        <a:rPr lang="en-US" sz="1200" dirty="0">
-                          <a:solidFill>
-                            <a:srgbClr val="26303F"/>
-                          </a:solidFill>
-                          <a:latin typeface="Calibri" pitchFamily="34" charset="0"/>
-                          <a:ea typeface="Calibri" pitchFamily="34" charset="-122"/>
-                          <a:cs typeface="Calibri" pitchFamily="34" charset="-120"/>
-                        </a:rPr>
-                        <a:t>minimal</a:t>
-                      </a:r>
-                      <a:endParaRPr lang="en-US" sz="1200" dirty="0">
-                        <a:latin typeface="Calibri" charset="0"/>
-                        <a:ea typeface="Calibri" charset="0"/>
-                        <a:cs typeface="Calibri" charset="0"/>
-                      </a:endParaRPr>
-                    </a:p>
-                  </a:txBody>
-                  <a:tcPr marL="76200" marR="76200" marT="25400" marB="25400" anchor="ctr">
-                    <a:lnL w="9525" cap="flat" cmpd="sng" algn="ctr">
-                      <a:solidFill>
-                        <a:srgbClr val="D5DAE1"/>
-                      </a:solidFill>
-                      <a:prstDash val="solid"/>
-                      <a:round/>
-                      <a:headEnd type="none" w="med" len="med"/>
-                      <a:tailEnd type="none" w="med" len="med"/>
-                    </a:lnL>
-                    <a:lnR w="9525" cap="flat" cmpd="sng" algn="ctr">
-                      <a:solidFill>
-                        <a:srgbClr val="D5DAE1"/>
-                      </a:solidFill>
-                      <a:prstDash val="solid"/>
-                      <a:round/>
-                      <a:headEnd type="none" w="med" len="med"/>
-                      <a:tailEnd type="none" w="med" len="med"/>
-                    </a:lnR>
-                    <a:lnT w="9525" cap="flat" cmpd="sng" algn="ctr">
-                      <a:solidFill>
-                        <a:srgbClr val="D5DAE1"/>
-                      </a:solidFill>
-                      <a:prstDash val="solid"/>
-                      <a:round/>
-                      <a:headEnd type="none" w="med" len="med"/>
-                      <a:tailEnd type="none" w="med" len="med"/>
-                    </a:lnT>
-                    <a:lnB w="9525" cap="flat" cmpd="sng" algn="ctr">
-                      <a:solidFill>
-                        <a:srgbClr val="D5DAE1"/>
-                      </a:solidFill>
-                      <a:prstDash val="solid"/>
-                      <a:round/>
-                      <a:headEnd type="none" w="med" len="med"/>
-                      <a:tailEnd type="none" w="med" len="med"/>
-                    </a:lnB>
-                    <a:solidFill>
-                      <a:srgbClr val="F7F8FA"/>
-                    </a:solidFill>
-                  </a:tcPr>
-                </a:tc>
-                <a:tc>
-                  <a:txBody>
-                    <a:bodyPr/>
-                    <a:lstStyle/>
-                    <a:p>
-                      <a:pPr indent="0" marL="0">
-                        <a:buNone/>
-                      </a:pPr>
-                      <a:r>
-                        <a:rPr lang="en-US" sz="1200" dirty="0">
-                          <a:solidFill>
-                            <a:srgbClr val="26303F"/>
-                          </a:solidFill>
-                          <a:latin typeface="Calibri" pitchFamily="34" charset="0"/>
-                          <a:ea typeface="Calibri" pitchFamily="34" charset="-122"/>
-                          <a:cs typeface="Calibri" pitchFamily="34" charset="-120"/>
-                        </a:rPr>
-                        <a:t>workflow rules</a:t>
-                      </a:r>
-                      <a:endParaRPr lang="en-US" sz="1200" dirty="0">
-                        <a:latin typeface="Calibri" charset="0"/>
-                        <a:ea typeface="Calibri" charset="0"/>
-                        <a:cs typeface="Calibri" charset="0"/>
-                      </a:endParaRPr>
-                    </a:p>
-                  </a:txBody>
-                  <a:tcPr marL="76200" marR="76200" marT="25400" marB="25400" anchor="ctr">
-                    <a:lnL w="9525" cap="flat" cmpd="sng" algn="ctr">
-                      <a:solidFill>
-                        <a:srgbClr val="D5DAE1"/>
-                      </a:solidFill>
-                      <a:prstDash val="solid"/>
-                      <a:round/>
-                      <a:headEnd type="none" w="med" len="med"/>
-                      <a:tailEnd type="none" w="med" len="med"/>
-                    </a:lnL>
-                    <a:lnR w="9525" cap="flat" cmpd="sng" algn="ctr">
-                      <a:solidFill>
-                        <a:srgbClr val="D5DAE1"/>
-                      </a:solidFill>
-                      <a:prstDash val="solid"/>
-                      <a:round/>
-                      <a:headEnd type="none" w="med" len="med"/>
-                      <a:tailEnd type="none" w="med" len="med"/>
-                    </a:lnR>
-                    <a:lnT w="9525" cap="flat" cmpd="sng" algn="ctr">
-                      <a:solidFill>
-                        <a:srgbClr val="D5DAE1"/>
-                      </a:solidFill>
-                      <a:prstDash val="solid"/>
-                      <a:round/>
-                      <a:headEnd type="none" w="med" len="med"/>
-                      <a:tailEnd type="none" w="med" len="med"/>
-                    </a:lnT>
-                    <a:lnB w="9525" cap="flat" cmpd="sng" algn="ctr">
-                      <a:solidFill>
-                        <a:srgbClr val="D5DAE1"/>
-                      </a:solidFill>
-                      <a:prstDash val="solid"/>
-                      <a:round/>
-                      <a:headEnd type="none" w="med" len="med"/>
-                      <a:tailEnd type="none" w="med" len="med"/>
-                    </a:lnB>
-                    <a:solidFill>
-                      <a:srgbClr val="F7F8FA"/>
-                    </a:solidFill>
-                  </a:tcPr>
-                </a:tc>
-                <a:tc>
-                  <a:txBody>
-                    <a:bodyPr/>
-                    <a:lstStyle/>
-                    <a:p>
-                      <a:pPr indent="0" marL="0">
-                        <a:buNone/>
-                      </a:pPr>
-                      <a:r>
-                        <a:rPr lang="en-US" sz="1200" dirty="0">
-                          <a:solidFill>
-                            <a:srgbClr val="26303F"/>
-                          </a:solidFill>
-                          <a:latin typeface="Calibri" pitchFamily="34" charset="0"/>
-                          <a:ea typeface="Calibri" pitchFamily="34" charset="-122"/>
-                          <a:cs typeface="Calibri" pitchFamily="34" charset="-120"/>
-                        </a:rPr>
-                        <a:t>none</a:t>
-                      </a:r>
-                      <a:endParaRPr lang="en-US" sz="1200" dirty="0">
-                        <a:latin typeface="Calibri" charset="0"/>
-                        <a:ea typeface="Calibri" charset="0"/>
-                        <a:cs typeface="Calibri" charset="0"/>
-                      </a:endParaRPr>
-                    </a:p>
-                  </a:txBody>
-                  <a:tcPr marL="76200" marR="76200" marT="25400" marB="25400" anchor="ctr">
-                    <a:lnL w="9525" cap="flat" cmpd="sng" algn="ctr">
-                      <a:solidFill>
-                        <a:srgbClr val="D5DAE1"/>
-                      </a:solidFill>
-                      <a:prstDash val="solid"/>
-                      <a:round/>
-                      <a:headEnd type="none" w="med" len="med"/>
-                      <a:tailEnd type="none" w="med" len="med"/>
-                    </a:lnL>
-                    <a:lnR w="9525" cap="flat" cmpd="sng" algn="ctr">
-                      <a:solidFill>
-                        <a:srgbClr val="D5DAE1"/>
-                      </a:solidFill>
-                      <a:prstDash val="solid"/>
-                      <a:round/>
-                      <a:headEnd type="none" w="med" len="med"/>
-                      <a:tailEnd type="none" w="med" len="med"/>
-                    </a:lnR>
-                    <a:lnT w="9525" cap="flat" cmpd="sng" algn="ctr">
-                      <a:solidFill>
-                        <a:srgbClr val="D5DAE1"/>
-                      </a:solidFill>
-                      <a:prstDash val="solid"/>
-                      <a:round/>
-                      <a:headEnd type="none" w="med" len="med"/>
-                      <a:tailEnd type="none" w="med" len="med"/>
-                    </a:lnT>
-                    <a:lnB w="9525" cap="flat" cmpd="sng" algn="ctr">
-                      <a:solidFill>
-                        <a:srgbClr val="D5DAE1"/>
-                      </a:solidFill>
-                      <a:prstDash val="solid"/>
-                      <a:round/>
-                      <a:headEnd type="none" w="med" len="med"/>
-                      <a:tailEnd type="none" w="med" len="med"/>
-                    </a:lnB>
-                    <a:solidFill>
-                      <a:srgbClr val="F7F8FA"/>
-                    </a:solidFill>
-                  </a:tcPr>
-                </a:tc>
-                <a:tc>
-                  <a:txBody>
-                    <a:bodyPr/>
-                    <a:lstStyle/>
-                    <a:p>
-                      <a:pPr indent="0" marL="0">
-                        <a:buNone/>
-                      </a:pPr>
-                      <a:r>
-                        <a:rPr lang="en-US" sz="1200" dirty="0">
-                          <a:solidFill>
-                            <a:srgbClr val="26303F"/>
-                          </a:solidFill>
-                          <a:latin typeface="Calibri" pitchFamily="34" charset="0"/>
-                          <a:ea typeface="Calibri" pitchFamily="34" charset="-122"/>
-                          <a:cs typeface="Calibri" pitchFamily="34" charset="-120"/>
-                        </a:rPr>
-                        <a:t>paid module only</a:t>
-                      </a:r>
-                      <a:endParaRPr lang="en-US" sz="1200" dirty="0">
-                        <a:latin typeface="Calibri" charset="0"/>
-                        <a:ea typeface="Calibri" charset="0"/>
-                        <a:cs typeface="Calibri" charset="0"/>
-                      </a:endParaRPr>
-                    </a:p>
-                  </a:txBody>
-                  <a:tcPr marL="76200" marR="76200" marT="25400" marB="25400" anchor="ctr">
-                    <a:lnL w="9525" cap="flat" cmpd="sng" algn="ctr">
-                      <a:solidFill>
-                        <a:srgbClr val="D5DAE1"/>
-                      </a:solidFill>
-                      <a:prstDash val="solid"/>
-                      <a:round/>
-                      <a:headEnd type="none" w="med" len="med"/>
-                      <a:tailEnd type="none" w="med" len="med"/>
-                    </a:lnL>
-                    <a:lnR w="9525" cap="flat" cmpd="sng" algn="ctr">
-                      <a:solidFill>
-                        <a:srgbClr val="D5DAE1"/>
-                      </a:solidFill>
-                      <a:prstDash val="solid"/>
-                      <a:round/>
-                      <a:headEnd type="none" w="med" len="med"/>
-                      <a:tailEnd type="none" w="med" len="med"/>
-                    </a:lnR>
-                    <a:lnT w="9525" cap="flat" cmpd="sng" algn="ctr">
-                      <a:solidFill>
-                        <a:srgbClr val="D5DAE1"/>
-                      </a:solidFill>
-                      <a:prstDash val="solid"/>
-                      <a:round/>
-                      <a:headEnd type="none" w="med" len="med"/>
-                      <a:tailEnd type="none" w="med" len="med"/>
-                    </a:lnT>
-                    <a:lnB w="9525" cap="flat" cmpd="sng" algn="ctr">
-                      <a:solidFill>
-                        <a:srgbClr val="D5DAE1"/>
-                      </a:solidFill>
-                      <a:prstDash val="solid"/>
-                      <a:round/>
-                      <a:headEnd type="none" w="med" len="med"/>
-                      <a:tailEnd type="none" w="med" len="med"/>
-                    </a:lnB>
-                    <a:solidFill>
-                      <a:srgbClr val="F7F8FA"/>
-                    </a:solidFill>
-                  </a:tcPr>
-                </a:tc>
-              </a:tr>
-            </a:tbl>
-          </a:graphicData>
-        </a:graphic>
-      </p:graphicFrame>
-      <p:sp>
-        <p:nvSpPr>
-          <p:cNvPr id="13" name="Text 9"/>
-          <p:cNvSpPr/>
-          <p:nvPr/>
-        </p:nvSpPr>
-        <p:spPr>
-          <a:xfrm>
-            <a:off x="5486400" y="4434840"/>
-            <a:ext cx="6153912" cy="1737360"/>
-          </a:xfrm>
-          <a:prstGeom prst="rect">
-            <a:avLst/>
-          </a:prstGeom>
-          <a:noFill/>
-          <a:ln/>
-        </p:spPr>
-        <p:txBody>
-          <a:bodyPr wrap="square" lIns="0" tIns="0" rIns="0" bIns="0" rtlCol="0" anchor="t"/>
-          <a:lstStyle/>
-          <a:p>
-            <a:pPr indent="0" marL="0">
-              <a:lnSpc>
-                <a:spcPct val="105000"/>
-              </a:lnSpc>
-              <a:buNone/>
-            </a:pPr>
-            <a:r>
-              <a:rPr lang="en-US" sz="1450" dirty="0">
-                <a:solidFill>
-                  <a:srgbClr val="14213D"/>
-                </a:solidFill>
-                <a:latin typeface="Georgia" pitchFamily="34" charset="0"/>
-                <a:ea typeface="Georgia" pitchFamily="34" charset="-122"/>
-                <a:cs typeface="Georgia" pitchFamily="34" charset="-120"/>
-              </a:rPr>
-              <a:t>What is missing. </a:t>
-            </a:r>
-            <a:r>
-              <a:rPr lang="en-US" sz="1450" dirty="0">
-                <a:solidFill>
-                  <a:srgbClr val="26303F"/>
-                </a:solidFill>
-                <a:latin typeface="Calibri" pitchFamily="34" charset="0"/>
-                <a:ea typeface="Calibri" pitchFamily="34" charset="-122"/>
-                <a:cs typeface="Calibri" pitchFamily="34" charset="-120"/>
-              </a:rPr>
-              <a:t>Only GLPI computes priority, and without waiting time. None of them assigns by workload and skills, and none detects duplicates automatically. Machine-learning approaches in the literature need labelled history and are hard to explain, so a transparent baseline is a reasonable place to start.</a:t>
-            </a:r>
-            <a:endParaRPr lang="en-US" sz="1450" dirty="0"/>
           </a:p>
         </p:txBody>
       </p:sp>
@@ -20264,7 +17096,7 @@
       </p:sp>
       <p:graphicFrame>
         <p:nvGraphicFramePr>
-          <p:cNvPr id="8" name="Table 0"/>
+          <p:cNvPr id="1000" name="Table 0"/>
           <p:cNvGraphicFramePr>
             <a:graphicFrameLocks noGrp="1"/>
           </p:cNvGraphicFramePr>
@@ -20278,15 +17110,15 @@
         </p:nvGraphicFramePr>
         <p:xfrm>
           <a:off x="548640" y="1828800"/>
-          <a:ext cx="6172200" cy="914400"/>
+          <a:ext cx="11091672" cy="914400"/>
         </p:xfrm>
         <a:graphic>
           <a:graphicData uri="http://schemas.openxmlformats.org/drawingml/2006/table">
             <a:tbl>
               <a:tblPr/>
               <a:tblGrid>
-                <a:gridCol w="1737360"/>
-                <a:gridCol w="4434840"/>
+                <a:gridCol w="3122100"/>
+                <a:gridCol w="7969572"/>
               </a:tblGrid>
               <a:tr h="338328">
                 <a:tc>
@@ -21672,94 +18504,6 @@
           </a:graphicData>
         </a:graphic>
       </p:graphicFrame>
-      <p:sp>
-        <p:nvSpPr>
-          <p:cNvPr id="10" name="Shape 6"/>
-          <p:cNvSpPr/>
-          <p:nvPr/>
-        </p:nvSpPr>
-        <p:spPr>
-          <a:xfrm>
-            <a:off x="7371452" y="1792224"/>
-            <a:ext cx="3892568" cy="3227832"/>
-          </a:xfrm>
-          <a:prstGeom prst="rect">
-            <a:avLst/>
-          </a:prstGeom>
-          <a:solidFill>
-            <a:srgbClr val="FFFFFF"/>
-          </a:solidFill>
-          <a:ln w="9525">
-            <a:solidFill>
-              <a:srgbClr val="D5DAE1"/>
-            </a:solidFill>
-            <a:prstDash val="solid"/>
-          </a:ln>
-        </p:spPr>
-      </p:sp>
-      <p:pic>
-        <p:nvPicPr>
-          <p:cNvPr id="11" name="Image 0" descr="/home/subham/Projects/college/fyp/smart-helpdesk/report/university/figures/uc-01.png">    </p:cNvPr>
-          <p:cNvPicPr>
-            <a:picLocks noChangeAspect="1"/>
-          </p:cNvPicPr>
-          <p:nvPr/>
-        </p:nvPicPr>
-        <p:blipFill>
-          <a:blip r:embed="rId1"/>
-          <a:stretch>
-            <a:fillRect/>
-          </a:stretch>
-        </p:blipFill>
-        <p:spPr>
-          <a:xfrm>
-            <a:off x="7408028" y="1828800"/>
-            <a:ext cx="3819416" cy="3154680"/>
-          </a:xfrm>
-          <a:prstGeom prst="rect">
-            <a:avLst/>
-          </a:prstGeom>
-        </p:spPr>
-      </p:pic>
-      <p:sp>
-        <p:nvSpPr>
-          <p:cNvPr id="12" name="Text 7"/>
-          <p:cNvSpPr/>
-          <p:nvPr/>
-        </p:nvSpPr>
-        <p:spPr>
-          <a:xfrm>
-            <a:off x="6995160" y="5074920"/>
-            <a:ext cx="4645152" cy="274320"/>
-          </a:xfrm>
-          <a:prstGeom prst="rect">
-            <a:avLst/>
-          </a:prstGeom>
-          <a:noFill/>
-          <a:ln/>
-        </p:spPr>
-        <p:txBody>
-          <a:bodyPr wrap="square" lIns="0" tIns="0" rIns="0" bIns="0" rtlCol="0" anchor="ctr"/>
-          <a:lstStyle/>
-          <a:p>
-            <a:pPr algn="ctr" indent="0" marL="0">
-              <a:buNone/>
-            </a:pPr>
-            <a:r>
-              <a:rPr lang="en-US" sz="1100" i="1" dirty="0">
-                <a:solidFill>
-                  <a:srgbClr val="66707F"/>
-                </a:solidFill>
-                <a:latin typeface="Calibri" pitchFamily="34" charset="0"/>
-                <a:ea typeface="Calibri" pitchFamily="34" charset="-122"/>
-                <a:cs typeface="Calibri" pitchFamily="34" charset="-120"/>
-              </a:rPr>
-              <a:t>Figure 3.1: Use cases of ticket handling and automation</a:t>
-            </a:r>
-            <a:endParaRPr lang="en-US" sz="1100" dirty="0"/>
-          </a:p>
-        </p:txBody>
-      </p:sp>
       <p:sp>
         <p:nvSpPr>
           <p:cNvPr id="13" name="Text 8"/>

</xml_diff>